<commit_message>
Eliminate widow lines in seminar slides
Awkward line breaks where one or two words spilled to the next line were
visible across most of the deck. Two passes of fixes:

- Body bullet font 14pt → 13pt (sed-style replace_all)
- Tighten copy on the worst offenders in slides 3, 5, 8, 9, 10, 11, 13,
  17, 23 (shorter Korean phrasing, English term abbreviations)
- Widen the slide-4 attention diagram box (5.8" → 6.1") and rewrite the
  formula in ASCII (`K^T`, `sqrt(d)`) so it fits on one line
</commit_message>
<xml_diff>
--- a/Bidaw_seminar.pptx
+++ b/Bidaw_seminar.pptx
@@ -3294,7 +3294,7 @@
               </a:spcAft>
             </a:pPr>
             <a:r>
-              <a:rPr sz="1400" b="0" i="0">
+              <a:rPr sz="1300" b="0" i="0">
                 <a:solidFill>
                   <a:srgbClr val="222222"/>
                 </a:solidFill>
@@ -3311,7 +3311,7 @@
               </a:spcAft>
             </a:pPr>
             <a:r>
-              <a:rPr sz="1400" b="0" i="0">
+              <a:rPr sz="1300" b="0" i="0">
                 <a:solidFill>
                   <a:srgbClr val="222222"/>
                 </a:solidFill>
@@ -3599,7 +3599,7 @@
               </a:spcAft>
             </a:pPr>
             <a:r>
-              <a:rPr sz="1400" b="1" i="0">
+              <a:rPr sz="1300" b="1" i="0">
                 <a:solidFill>
                   <a:srgbClr val="1F2937"/>
                 </a:solidFill>
@@ -3643,7 +3643,7 @@
               </a:spcAft>
             </a:pPr>
             <a:r>
-              <a:rPr sz="1400" b="1" i="0">
+              <a:rPr sz="1300" b="1" i="0">
                 <a:solidFill>
                   <a:srgbClr val="1F2937"/>
                 </a:solidFill>
@@ -3778,7 +3778,7 @@
                 <a:latin typeface="Calibri"/>
                 <a:ea typeface="맑은 고딕"/>
               </a:rPr>
-              <a:t>→ 사용자가 다음 질문을 “생각하는 시간” 동안 </a:t>
+              <a:t>→ 사용자가 답을 읽는 사이 </a:t>
             </a:r>
             <a:r>
               <a:rPr sz="1200" b="0" i="1">
@@ -3788,7 +3788,7 @@
                 <a:latin typeface="Calibri"/>
                 <a:ea typeface="맑은 고딕"/>
               </a:rPr>
-              <a:t>다른 사용자 요청이 끼어들기 때문</a:t>
+              <a:t>다른 user KV 가 끼어들기 때문</a:t>
             </a:r>
           </a:p>
         </p:txBody>
@@ -4191,7 +4191,7 @@
               </a:spcAft>
             </a:pPr>
             <a:r>
-              <a:rPr sz="1400" b="1" i="0">
+              <a:rPr sz="1300" b="1" i="0">
                 <a:solidFill>
                   <a:srgbClr val="444444"/>
                 </a:solidFill>
@@ -4201,7 +4201,7 @@
               <a:t>▸ </a:t>
             </a:r>
             <a:r>
-              <a:rPr sz="1400" b="0" i="0">
+              <a:rPr sz="1300" b="0" i="0">
                 <a:solidFill>
                   <a:srgbClr val="222222"/>
                 </a:solidFill>
@@ -4211,7 +4211,7 @@
               <a:t>두 layer 의 </a:t>
             </a:r>
             <a:r>
-              <a:rPr sz="1400" b="1" i="0">
+              <a:rPr sz="1300" b="1" i="0">
                 <a:solidFill>
                   <a:srgbClr val="222222"/>
                 </a:solidFill>
@@ -4228,7 +4228,7 @@
               </a:spcAft>
             </a:pPr>
             <a:r>
-              <a:rPr sz="1400" b="1" i="0">
+              <a:rPr sz="1300" b="1" i="0">
                 <a:solidFill>
                   <a:srgbClr val="444444"/>
                 </a:solidFill>
@@ -4238,7 +4238,7 @@
               <a:t>▸ </a:t>
             </a:r>
             <a:r>
-              <a:rPr sz="1400" b="0" i="0">
+              <a:rPr sz="1300" b="0" i="0">
                 <a:solidFill>
                   <a:srgbClr val="222222"/>
                 </a:solidFill>
@@ -4248,7 +4248,7 @@
               <a:t>요청별 </a:t>
             </a:r>
             <a:r>
-              <a:rPr sz="1400" b="1" i="0">
+              <a:rPr sz="1300" b="1" i="0">
                 <a:solidFill>
                   <a:srgbClr val="222222"/>
                 </a:solidFill>
@@ -4265,7 +4265,7 @@
               </a:spcAft>
             </a:pPr>
             <a:r>
-              <a:rPr sz="1400" b="1" i="0">
+              <a:rPr sz="1300" b="1" i="0">
                 <a:solidFill>
                   <a:srgbClr val="444444"/>
                 </a:solidFill>
@@ -4275,7 +4275,7 @@
               <a:t>▸ </a:t>
             </a:r>
             <a:r>
-              <a:rPr sz="1400" b="0" i="0">
+              <a:rPr sz="1300" b="0" i="0">
                 <a:solidFill>
                   <a:srgbClr val="222222"/>
                 </a:solidFill>
@@ -4285,7 +4285,7 @@
               <a:t>심지어 </a:t>
             </a:r>
             <a:r>
-              <a:rPr sz="1400" b="1" i="0">
+              <a:rPr sz="1300" b="1" i="0">
                 <a:solidFill>
                   <a:srgbClr val="222222"/>
                 </a:solidFill>
@@ -4319,24 +4319,24 @@
               </a:spcAft>
             </a:pPr>
             <a:r>
-              <a:rPr sz="1400" b="0" i="0">
+              <a:rPr sz="1300" b="0" i="0">
                 <a:solidFill>
                   <a:srgbClr val="222222"/>
                 </a:solidFill>
                 <a:latin typeface="Calibri"/>
                 <a:ea typeface="맑은 고딕"/>
               </a:rPr>
-              <a:t>한 요청의 큰 KV가 도착할 때, </a:t>
-            </a:r>
-            <a:r>
-              <a:rPr sz="1400" b="1" i="0">
+              <a:t>큰 KV 한 개가 </a:t>
+            </a:r>
+            <a:r>
+              <a:rPr sz="1300" b="1" i="0">
                 <a:solidFill>
                   <a:srgbClr val="444444"/>
                 </a:solidFill>
                 <a:latin typeface="Calibri"/>
                 <a:ea typeface="맑은 고딕"/>
               </a:rPr>
-              <a:t>뒤따르는 작은 KV 요청까지 모두 GPU idle 상태로 만든다</a:t>
+              <a:t>뒤따르는 작은 KV 까지 GPU idle 로 만든다</a:t>
             </a:r>
           </a:p>
         </p:txBody>
@@ -4657,7 +4657,7 @@
               </a:spcAft>
             </a:pPr>
             <a:r>
-              <a:rPr sz="1400" b="0" i="0">
+              <a:rPr sz="1300" b="0" i="0">
                 <a:solidFill>
                   <a:srgbClr val="222222"/>
                 </a:solidFill>
@@ -4674,7 +4674,7 @@
               </a:spcAft>
             </a:pPr>
             <a:r>
-              <a:rPr sz="1400" b="0" i="0">
+              <a:rPr sz="1300" b="0" i="0">
                 <a:solidFill>
                   <a:srgbClr val="222222"/>
                 </a:solidFill>
@@ -4691,7 +4691,7 @@
               </a:spcAft>
             </a:pPr>
             <a:r>
-              <a:rPr sz="1400" b="0" i="1">
+              <a:rPr sz="1300" b="0" i="1">
                 <a:solidFill>
                   <a:srgbClr val="444444"/>
                 </a:solidFill>
@@ -4794,7 +4794,7 @@
               </a:spcAft>
             </a:pPr>
             <a:r>
-              <a:rPr sz="1400" b="0" i="0">
+              <a:rPr sz="1300" b="0" i="0">
                 <a:solidFill>
                   <a:srgbClr val="222222"/>
                 </a:solidFill>
@@ -4811,7 +4811,7 @@
               </a:spcAft>
             </a:pPr>
             <a:r>
-              <a:rPr sz="1400" b="0" i="0">
+              <a:rPr sz="1300" b="0" i="0">
                 <a:solidFill>
                   <a:srgbClr val="222222"/>
                 </a:solidFill>
@@ -4828,7 +4828,7 @@
               </a:spcAft>
             </a:pPr>
             <a:r>
-              <a:rPr sz="1400" b="0" i="1">
+              <a:rPr sz="1300" b="0" i="1">
                 <a:solidFill>
                   <a:srgbClr val="444444"/>
                 </a:solidFill>
@@ -5279,7 +5279,7 @@
               </a:spcAft>
             </a:pPr>
             <a:r>
-              <a:rPr sz="1400" b="0" i="0">
+              <a:rPr sz="1300" b="0" i="0">
                 <a:solidFill>
                   <a:srgbClr val="222222"/>
                 </a:solidFill>
@@ -5289,7 +5289,7 @@
               <a:t>이전 라운드의 </a:t>
             </a:r>
             <a:r>
-              <a:rPr sz="1400" b="1" i="0">
+              <a:rPr sz="1300" b="1" i="0">
                 <a:solidFill>
                   <a:srgbClr val="444444"/>
                 </a:solidFill>
@@ -5299,14 +5299,14 @@
               <a:t>model answer 길이</a:t>
             </a:r>
             <a:r>
-              <a:rPr sz="1400" b="0" i="0">
+              <a:rPr sz="1300" b="0" i="0">
                 <a:solidFill>
                   <a:srgbClr val="222222"/>
                 </a:solidFill>
                 <a:latin typeface="Calibri"/>
                 <a:ea typeface="맑은 고딕"/>
               </a:rPr>
-              <a:t>를 storage 측에 넘긴다</a:t>
+              <a:t>를 storage 에 넘긴다</a:t>
             </a:r>
           </a:p>
           <a:p>
@@ -5333,7 +5333,7 @@
                 <a:latin typeface="Calibri"/>
                 <a:ea typeface="맑은 고딕"/>
               </a:rPr>
-              <a:t>이 길이는 사용자의 다음 질문이 도착할 시점을 예측하는 신호</a:t>
+              <a:t>이 길이가 다음 질문 도착 시점의 예측 신호</a:t>
             </a:r>
           </a:p>
           <a:p>
@@ -5360,7 +5360,7 @@
                 <a:latin typeface="Calibri"/>
                 <a:ea typeface="맑은 고딕"/>
               </a:rPr>
-              <a:t>Storage는 이 신호로 next-access의 weighted reuse distance를 추정</a:t>
+              <a:t>Storage 는 신호로 next-access reuse distance 추정</a:t>
             </a:r>
           </a:p>
           <a:p>
@@ -5387,7 +5387,7 @@
                 <a:latin typeface="Calibri"/>
                 <a:ea typeface="맑은 고딕"/>
               </a:rPr>
-              <a:t>추정 결과로 hit potential이 가장 낮은 KV를 evict</a:t>
+              <a:t>hit potential 최저 KV 를 evict</a:t>
             </a:r>
           </a:p>
         </p:txBody>
@@ -5483,34 +5483,34 @@
               </a:spcAft>
             </a:pPr>
             <a:r>
-              <a:rPr sz="1400" b="0" i="0">
+              <a:rPr sz="1300" b="0" i="0">
                 <a:solidFill>
                   <a:srgbClr val="222222"/>
                 </a:solidFill>
                 <a:latin typeface="Calibri"/>
                 <a:ea typeface="맑은 고딕"/>
               </a:rPr>
-              <a:t>각 요청 KV의 </a:t>
-            </a:r>
-            <a:r>
-              <a:rPr sz="1400" b="1" i="0">
+              <a:t>각 요청 KV 의 </a:t>
+            </a:r>
+            <a:r>
+              <a:rPr sz="1300" b="1" i="0">
                 <a:solidFill>
                   <a:srgbClr val="444444"/>
                 </a:solidFill>
                 <a:latin typeface="Calibri"/>
                 <a:ea typeface="맑은 고딕"/>
               </a:rPr>
-              <a:t>위치(layer)와 크기</a:t>
-            </a:r>
-            <a:r>
-              <a:rPr sz="1400" b="0" i="0">
+              <a:t>위치 (layer) 와 크기</a:t>
+            </a:r>
+            <a:r>
+              <a:rPr sz="1300" b="0" i="0">
                 <a:solidFill>
                   <a:srgbClr val="222222"/>
                 </a:solidFill>
                 <a:latin typeface="Calibri"/>
                 <a:ea typeface="맑은 고딕"/>
               </a:rPr>
-              <a:t>를 compute 측에 넘긴다</a:t>
+              <a:t>를 compute 에 넘긴다</a:t>
             </a:r>
           </a:p>
           <a:p>
@@ -5537,7 +5537,7 @@
                 <a:latin typeface="Calibri"/>
                 <a:ea typeface="맑은 고딕"/>
               </a:rPr>
-              <a:t>Compute는 KV가 어디에 있고 얼마나 큰지를 알고 dispatch</a:t>
+              <a:t>Compute 는 KV 위치/크기 알고 dispatch</a:t>
             </a:r>
           </a:p>
           <a:p>
@@ -5564,7 +5564,7 @@
                 <a:latin typeface="Calibri"/>
                 <a:ea typeface="맑은 고딕"/>
               </a:rPr>
-              <a:t>두 개 큐(ready / preparing)로 I/O 길이를 결정성과 분리</a:t>
+              <a:t>ready / preparing 두 큐로 I/O 길이를 분리</a:t>
             </a:r>
           </a:p>
           <a:p>
@@ -5591,7 +5591,7 @@
                 <a:latin typeface="Calibri"/>
                 <a:ea typeface="맑은 고딕"/>
               </a:rPr>
-              <a:t>GPU idle 시간을 제거하고 큐잉 지연을 줄임</a:t>
+              <a:t>GPU idle 제거 + 큐잉 지연 감소</a:t>
             </a:r>
           </a:p>
         </p:txBody>
@@ -6991,7 +6991,7 @@
               </a:spcAft>
             </a:pPr>
             <a:r>
-              <a:rPr sz="1400" b="1" i="0">
+              <a:rPr sz="1300" b="1" i="0">
                 <a:solidFill>
                   <a:srgbClr val="1F2937"/>
                 </a:solidFill>
@@ -7533,7 +7533,7 @@
               </a:spcAft>
             </a:pPr>
             <a:r>
-              <a:rPr sz="1400" b="1" i="0">
+              <a:rPr sz="1300" b="1" i="0">
                 <a:solidFill>
                   <a:srgbClr val="222222"/>
                 </a:solidFill>
@@ -7567,7 +7567,7 @@
               </a:spcAft>
             </a:pPr>
             <a:r>
-              <a:rPr sz="1400" b="1" i="0">
+              <a:rPr sz="1300" b="1" i="0">
                 <a:solidFill>
                   <a:srgbClr val="222222"/>
                 </a:solidFill>
@@ -7758,7 +7758,7 @@
                 <a:latin typeface="Calibri"/>
                 <a:ea typeface="맑은 고딕"/>
               </a:rPr>
-              <a:t>작은 KV 요청을 먼저 </a:t>
+              <a:t>작은 KV 먼저 </a:t>
             </a:r>
             <a:r>
               <a:rPr sz="1300" b="1" i="0">
@@ -7768,7 +7768,7 @@
                 <a:latin typeface="Calibri"/>
                 <a:ea typeface="맑은 고딕"/>
               </a:rPr>
-              <a:t>→ ready queue로 빨리 promote</a:t>
+              <a:t>→ ready queue 로 빨리 promote</a:t>
             </a:r>
           </a:p>
           <a:p>
@@ -7795,7 +7795,7 @@
                 <a:latin typeface="Calibri"/>
                 <a:ea typeface="맑은 고딕"/>
               </a:rPr>
-              <a:t>그러나 waiting time이 증가하면 </a:t>
+              <a:t>waiting↑ 시 </a:t>
             </a:r>
             <a:r>
               <a:rPr sz="1300" b="1" i="0">
@@ -7805,7 +7805,7 @@
                 <a:latin typeface="Calibri"/>
                 <a:ea typeface="맑은 고딕"/>
               </a:rPr>
-              <a:t>큰 KV도 결국 promote (기아 방지)</a:t>
+              <a:t>큰 KV 도 promote (기아 방지)</a:t>
             </a:r>
           </a:p>
           <a:p>
@@ -7832,7 +7832,7 @@
                 <a:latin typeface="Calibri"/>
                 <a:ea typeface="맑은 고딕"/>
               </a:rPr>
-              <a:t>classical HRRN을 </a:t>
+              <a:t>classical HRRN 의 </a:t>
             </a:r>
             <a:r>
               <a:rPr sz="1300" b="1" i="0">
@@ -7842,7 +7842,7 @@
                 <a:latin typeface="Calibri"/>
                 <a:ea typeface="맑은 고딕"/>
               </a:rPr>
-              <a:t>I/O 시간 ≈ KV size 가정으로 변형</a:t>
+              <a:t>I/O time ≈ KV size 변형</a:t>
             </a:r>
           </a:p>
         </p:txBody>
@@ -8164,7 +8164,7 @@
               </a:spcAft>
             </a:pPr>
             <a:r>
-              <a:rPr sz="1400" b="1" i="0">
+              <a:rPr sz="1300" b="1" i="0">
                 <a:solidFill>
                   <a:srgbClr val="1F2937"/>
                 </a:solidFill>
@@ -8215,7 +8215,7 @@
               </a:spcAft>
             </a:pPr>
             <a:r>
-              <a:rPr sz="1400" b="1" i="0">
+              <a:rPr sz="1300" b="1" i="0">
                 <a:solidFill>
                   <a:srgbClr val="1F2937"/>
                 </a:solidFill>
@@ -8588,7 +8588,7 @@
               </a:spcAft>
             </a:pPr>
             <a:r>
-              <a:rPr sz="1400" b="1" i="0">
+              <a:rPr sz="1300" b="1" i="0">
                 <a:solidFill>
                   <a:srgbClr val="1F2937"/>
                 </a:solidFill>
@@ -9933,7 +9933,7 @@
               </a:spcAft>
             </a:pPr>
             <a:r>
-              <a:rPr sz="1400" b="1" i="0">
+              <a:rPr sz="1300" b="1" i="0">
                 <a:solidFill>
                   <a:srgbClr val="222222"/>
                 </a:solidFill>
@@ -9967,7 +9967,7 @@
               </a:spcAft>
             </a:pPr>
             <a:r>
-              <a:rPr sz="1400" b="1" i="0">
+              <a:rPr sz="1300" b="1" i="0">
                 <a:solidFill>
                   <a:srgbClr val="444444"/>
                 </a:solidFill>
@@ -10001,7 +10001,7 @@
               </a:spcAft>
             </a:pPr>
             <a:r>
-              <a:rPr sz="1400" b="1" i="0">
+              <a:rPr sz="1300" b="1" i="0">
                 <a:solidFill>
                   <a:srgbClr val="222222"/>
                 </a:solidFill>
@@ -10104,7 +10104,7 @@
               </a:spcAft>
             </a:pPr>
             <a:r>
-              <a:rPr sz="1400" b="0" i="0">
+              <a:rPr sz="1300" b="0" i="0">
                 <a:solidFill>
                   <a:srgbClr val="222222"/>
                 </a:solidFill>
@@ -10115,7 +10115,7 @@
 </a:t>
             </a:r>
             <a:r>
-              <a:rPr sz="1400" b="0" i="0">
+              <a:rPr sz="1300" b="0" i="0">
                 <a:solidFill>
                   <a:srgbClr val="222222"/>
                 </a:solidFill>
@@ -10125,7 +10125,7 @@
               <a:t>Optimal과의 격차를 좁히려면 </a:t>
             </a:r>
             <a:r>
-              <a:rPr sz="1400" b="1" i="0">
+              <a:rPr sz="1300" b="1" i="0">
                 <a:solidFill>
                   <a:srgbClr val="444444"/>
                 </a:solidFill>
@@ -10135,7 +10135,7 @@
               <a:t>구간별 hit 확률을 모델링</a:t>
             </a:r>
             <a:r>
-              <a:rPr sz="1400" b="0" i="0">
+              <a:rPr sz="1300" b="0" i="0">
                 <a:solidFill>
                   <a:srgbClr val="222222"/>
                 </a:solidFill>
@@ -10440,7 +10440,7 @@
               </a:spcAft>
             </a:pPr>
             <a:r>
-              <a:rPr sz="1400" b="0" i="0">
+              <a:rPr sz="1300" b="0" i="0">
                 <a:solidFill>
                   <a:srgbClr val="222222"/>
                 </a:solidFill>
@@ -10520,7 +10520,7 @@
               </a:spcAft>
             </a:pPr>
             <a:r>
-              <a:rPr sz="1400" b="0" i="0">
+              <a:rPr sz="1300" b="0" i="0">
                 <a:solidFill>
                   <a:srgbClr val="222222"/>
                 </a:solidFill>
@@ -10600,7 +10600,7 @@
               </a:spcAft>
             </a:pPr>
             <a:r>
-              <a:rPr sz="1400" b="0" i="0">
+              <a:rPr sz="1300" b="0" i="0">
                 <a:solidFill>
                   <a:srgbClr val="222222"/>
                 </a:solidFill>
@@ -10680,7 +10680,7 @@
               </a:spcAft>
             </a:pPr>
             <a:r>
-              <a:rPr sz="1400" b="0" i="0">
+              <a:rPr sz="1300" b="0" i="0">
                 <a:solidFill>
                   <a:srgbClr val="222222"/>
                 </a:solidFill>
@@ -10760,7 +10760,7 @@
               </a:spcAft>
             </a:pPr>
             <a:r>
-              <a:rPr sz="1400" b="0" i="0">
+              <a:rPr sz="1300" b="0" i="0">
                 <a:solidFill>
                   <a:srgbClr val="222222"/>
                 </a:solidFill>
@@ -11138,7 +11138,7 @@
               <a:t>▸  </a:t>
             </a:r>
             <a:r>
-              <a:rPr sz="1400" b="1" i="0">
+              <a:rPr sz="1300" b="1" i="0">
                 <a:solidFill>
                   <a:srgbClr val="1F2937"/>
                 </a:solidFill>
@@ -11148,7 +11148,7 @@
               <a:t>prob_small</a:t>
             </a:r>
             <a:r>
-              <a:rPr sz="1400" b="0" i="0">
+              <a:rPr sz="1300" b="0" i="0">
                 <a:solidFill>
                   <a:srgbClr val="222222"/>
                 </a:solidFill>
@@ -11208,7 +11208,7 @@
               <a:t>▸  </a:t>
             </a:r>
             <a:r>
-              <a:rPr sz="1400" b="1" i="0">
+              <a:rPr sz="1300" b="1" i="0">
                 <a:solidFill>
                   <a:srgbClr val="1F2937"/>
                 </a:solidFill>
@@ -11218,7 +11218,7 @@
               <a:t>prob_promising(i)</a:t>
             </a:r>
             <a:r>
-              <a:rPr sz="1400" b="0" i="0">
+              <a:rPr sz="1300" b="0" i="0">
                 <a:solidFill>
                   <a:srgbClr val="222222"/>
                 </a:solidFill>
@@ -11278,7 +11278,7 @@
               <a:t>▸  </a:t>
             </a:r>
             <a:r>
-              <a:rPr sz="1400" b="1" i="0">
+              <a:rPr sz="1300" b="1" i="0">
                 <a:solidFill>
                   <a:srgbClr val="1F2937"/>
                 </a:solidFill>
@@ -11288,7 +11288,7 @@
               <a:t>hit_promising(i)</a:t>
             </a:r>
             <a:r>
-              <a:rPr sz="1400" b="0" i="0">
+              <a:rPr sz="1300" b="0" i="0">
                 <a:solidFill>
                   <a:srgbClr val="222222"/>
                 </a:solidFill>
@@ -11348,7 +11348,7 @@
               <a:t>▸  </a:t>
             </a:r>
             <a:r>
-              <a:rPr sz="1400" b="1" i="0">
+              <a:rPr sz="1300" b="1" i="0">
                 <a:solidFill>
                   <a:srgbClr val="1F2937"/>
                 </a:solidFill>
@@ -11358,7 +11358,7 @@
               <a:t>prob_extreme</a:t>
             </a:r>
             <a:r>
-              <a:rPr sz="1400" b="0" i="0">
+              <a:rPr sz="1300" b="0" i="0">
                 <a:solidFill>
                   <a:srgbClr val="222222"/>
                 </a:solidFill>
@@ -11803,7 +11803,7 @@
               </a:spcAft>
             </a:pPr>
             <a:r>
-              <a:rPr sz="1400" b="1" i="0">
+              <a:rPr sz="1300" b="1" i="0">
                 <a:solidFill>
                   <a:srgbClr val="1F2937"/>
                 </a:solidFill>
@@ -11827,7 +11827,7 @@
                 <a:latin typeface="Calibri"/>
                 <a:ea typeface="맑은 고딕"/>
               </a:rPr>
-              <a:t>▸ KV tensor는 attention 입력으로 직접 필요하지만 </a:t>
+              <a:t>▸ KV tensor 는 attention 입력으로 </a:t>
             </a:r>
             <a:r>
               <a:rPr sz="1300" b="1" i="0">
@@ -11837,7 +11837,7 @@
                 <a:latin typeface="Calibri"/>
                 <a:ea typeface="맑은 고딕"/>
               </a:rPr>
-              <a:t>size가 큼</a:t>
+              <a:t>필요하지만 size 가 큼</a:t>
             </a:r>
           </a:p>
           <a:p>
@@ -11847,7 +11847,7 @@
               </a:spcAft>
             </a:pPr>
             <a:r>
-              <a:rPr sz="1400" b="1" i="0">
+              <a:rPr sz="1300" b="1" i="0">
                 <a:solidFill>
                   <a:srgbClr val="1F2937"/>
                 </a:solidFill>
@@ -11881,7 +11881,7 @@
               </a:spcAft>
             </a:pPr>
             <a:r>
-              <a:rPr sz="1400" b="1" i="0">
+              <a:rPr sz="1300" b="1" i="0">
                 <a:solidFill>
                   <a:srgbClr val="444444"/>
                 </a:solidFill>
@@ -14223,7 +14223,7 @@
               </a:spcAft>
             </a:pPr>
             <a:r>
-              <a:rPr sz="1400" b="1" i="0">
+              <a:rPr sz="1300" b="1" i="0">
                 <a:solidFill>
                   <a:srgbClr val="444444"/>
                 </a:solidFill>
@@ -14233,7 +14233,7 @@
               <a:t>▸ </a:t>
             </a:r>
             <a:r>
-              <a:rPr sz="1400" b="1" i="0">
+              <a:rPr sz="1300" b="1" i="0">
                 <a:solidFill>
                   <a:srgbClr val="222222"/>
                 </a:solidFill>
@@ -14243,7 +14243,7 @@
               <a:t>Bidaw — 응답 latency </a:t>
             </a:r>
             <a:r>
-              <a:rPr sz="1400" b="0" i="0">
+              <a:rPr sz="1300" b="0" i="0">
                 <a:solidFill>
                   <a:srgbClr val="222222"/>
                 </a:solidFill>
@@ -14260,7 +14260,7 @@
               </a:spcAft>
             </a:pPr>
             <a:r>
-              <a:rPr sz="1400" b="1" i="0">
+              <a:rPr sz="1300" b="1" i="0">
                 <a:solidFill>
                   <a:srgbClr val="444444"/>
                 </a:solidFill>
@@ -14270,7 +14270,7 @@
               <a:t>▸ </a:t>
             </a:r>
             <a:r>
-              <a:rPr sz="1400" b="1" i="0">
+              <a:rPr sz="1300" b="1" i="0">
                 <a:solidFill>
                   <a:srgbClr val="222222"/>
                 </a:solidFill>
@@ -14280,7 +14280,7 @@
               <a:t>Bidaw — throughput </a:t>
             </a:r>
             <a:r>
-              <a:rPr sz="1400" b="0" i="0">
+              <a:rPr sz="1300" b="0" i="0">
                 <a:solidFill>
                   <a:srgbClr val="222222"/>
                 </a:solidFill>
@@ -14297,7 +14297,7 @@
               </a:spcAft>
             </a:pPr>
             <a:r>
-              <a:rPr sz="1400" b="1" i="0">
+              <a:rPr sz="1300" b="1" i="0">
                 <a:solidFill>
                   <a:srgbClr val="444444"/>
                 </a:solidFill>
@@ -14307,7 +14307,7 @@
               <a:t>▸ </a:t>
             </a:r>
             <a:r>
-              <a:rPr sz="1400" b="1" i="0">
+              <a:rPr sz="1300" b="1" i="0">
                 <a:solidFill>
                   <a:srgbClr val="222222"/>
                 </a:solidFill>
@@ -14317,7 +14317,7 @@
               <a:t>Optimal과의 gap </a:t>
             </a:r>
             <a:r>
-              <a:rPr sz="1400" b="0" i="0">
+              <a:rPr sz="1300" b="0" i="0">
                 <a:solidFill>
                   <a:srgbClr val="222222"/>
                 </a:solidFill>
@@ -14334,7 +14334,7 @@
               </a:spcAft>
             </a:pPr>
             <a:r>
-              <a:rPr sz="1400" b="1" i="0">
+              <a:rPr sz="1300" b="1" i="0">
                 <a:solidFill>
                   <a:srgbClr val="444444"/>
                 </a:solidFill>
@@ -14344,7 +14344,7 @@
               <a:t>▸ </a:t>
             </a:r>
             <a:r>
-              <a:rPr sz="1400" b="1" i="0">
+              <a:rPr sz="1300" b="1" i="0">
                 <a:solidFill>
                   <a:srgbClr val="222222"/>
                 </a:solidFill>
@@ -14354,7 +14354,7 @@
               <a:t>Note </a:t>
             </a:r>
             <a:r>
-              <a:rPr sz="1400" b="0" i="0">
+              <a:rPr sz="1300" b="0" i="0">
                 <a:solidFill>
                   <a:srgbClr val="222222"/>
                 </a:solidFill>
@@ -14747,7 +14747,7 @@
               </a:spcAft>
             </a:pPr>
             <a:r>
-              <a:rPr sz="1400" b="1" i="0">
+              <a:rPr sz="1300" b="1" i="0">
                 <a:solidFill>
                   <a:srgbClr val="1F2937"/>
                 </a:solidFill>
@@ -14818,7 +14818,7 @@
               </a:spcAft>
             </a:pPr>
             <a:r>
-              <a:rPr sz="1400" b="1" i="0">
+              <a:rPr sz="1300" b="1" i="0">
                 <a:solidFill>
                   <a:srgbClr val="1F2937"/>
                 </a:solidFill>
@@ -15349,7 +15349,7 @@
               </a:spcAft>
             </a:pPr>
             <a:r>
-              <a:rPr sz="1400" b="1" i="0">
+              <a:rPr sz="1300" b="1" i="0">
                 <a:solidFill>
                   <a:srgbClr val="444444"/>
                 </a:solidFill>
@@ -15359,7 +15359,7 @@
               <a:t>▸ </a:t>
             </a:r>
             <a:r>
-              <a:rPr sz="1400" b="1" i="0">
+              <a:rPr sz="1300" b="1" i="0">
                 <a:solidFill>
                   <a:srgbClr val="1F2937"/>
                 </a:solidFill>
@@ -15369,7 +15369,7 @@
               <a:t>Tail latency</a:t>
             </a:r>
             <a:r>
-              <a:rPr sz="1400" b="0" i="0">
+              <a:rPr sz="1300" b="0" i="0">
                 <a:solidFill>
                   <a:srgbClr val="222222"/>
                 </a:solidFill>
@@ -15386,7 +15386,7 @@
               </a:spcAft>
             </a:pPr>
             <a:r>
-              <a:rPr sz="1400" b="1" i="0">
+              <a:rPr sz="1300" b="1" i="0">
                 <a:solidFill>
                   <a:srgbClr val="444444"/>
                 </a:solidFill>
@@ -15396,7 +15396,7 @@
               <a:t>▸ </a:t>
             </a:r>
             <a:r>
-              <a:rPr sz="1400" b="1" i="0">
+              <a:rPr sz="1300" b="1" i="0">
                 <a:solidFill>
                   <a:srgbClr val="1F2937"/>
                 </a:solidFill>
@@ -15406,7 +15406,7 @@
               <a:t>Ablation</a:t>
             </a:r>
             <a:r>
-              <a:rPr sz="1400" b="0" i="0">
+              <a:rPr sz="1300" b="0" i="0">
                 <a:solidFill>
                   <a:srgbClr val="222222"/>
                 </a:solidFill>
@@ -15423,7 +15423,7 @@
               </a:spcAft>
             </a:pPr>
             <a:r>
-              <a:rPr sz="1400" b="1" i="0">
+              <a:rPr sz="1300" b="1" i="0">
                 <a:solidFill>
                   <a:srgbClr val="444444"/>
                 </a:solidFill>
@@ -15433,7 +15433,7 @@
               <a:t>▸ </a:t>
             </a:r>
             <a:r>
-              <a:rPr sz="1400" b="1" i="0">
+              <a:rPr sz="1300" b="1" i="0">
                 <a:solidFill>
                   <a:srgbClr val="1F2937"/>
                 </a:solidFill>
@@ -15443,7 +15443,7 @@
               <a:t>Overhead</a:t>
             </a:r>
             <a:r>
-              <a:rPr sz="1400" b="0" i="0">
+              <a:rPr sz="1300" b="0" i="0">
                 <a:solidFill>
                   <a:srgbClr val="222222"/>
                 </a:solidFill>
@@ -15789,7 +15789,7 @@
               </a:spcAft>
             </a:pPr>
             <a:r>
-              <a:rPr sz="1400" b="1" i="0">
+              <a:rPr sz="1300" b="1" i="0">
                 <a:solidFill>
                   <a:srgbClr val="444444"/>
                 </a:solidFill>
@@ -15799,7 +15799,7 @@
               <a:t>•  </a:t>
             </a:r>
             <a:r>
-              <a:rPr sz="1400" b="0" i="0">
+              <a:rPr sz="1300" b="0" i="0">
                 <a:solidFill>
                   <a:srgbClr val="222222"/>
                 </a:solidFill>
@@ -15816,7 +15816,7 @@
               </a:spcAft>
             </a:pPr>
             <a:r>
-              <a:rPr sz="1400" b="1" i="0">
+              <a:rPr sz="1300" b="1" i="0">
                 <a:solidFill>
                   <a:srgbClr val="444444"/>
                 </a:solidFill>
@@ -15826,7 +15826,7 @@
               <a:t>•  </a:t>
             </a:r>
             <a:r>
-              <a:rPr sz="1400" b="0" i="0">
+              <a:rPr sz="1300" b="0" i="0">
                 <a:solidFill>
                   <a:srgbClr val="222222"/>
                 </a:solidFill>
@@ -15843,7 +15843,7 @@
               </a:spcAft>
             </a:pPr>
             <a:r>
-              <a:rPr sz="1400" b="1" i="0">
+              <a:rPr sz="1300" b="1" i="0">
                 <a:solidFill>
                   <a:srgbClr val="444444"/>
                 </a:solidFill>
@@ -15853,7 +15853,7 @@
               <a:t>•  </a:t>
             </a:r>
             <a:r>
-              <a:rPr sz="1400" b="0" i="0">
+              <a:rPr sz="1300" b="0" i="0">
                 <a:solidFill>
                   <a:srgbClr val="222222"/>
                 </a:solidFill>
@@ -15887,7 +15887,7 @@
               </a:spcAft>
             </a:pPr>
             <a:r>
-              <a:rPr sz="1400" b="1" i="0">
+              <a:rPr sz="1300" b="1" i="0">
                 <a:solidFill>
                   <a:srgbClr val="444444"/>
                 </a:solidFill>
@@ -15897,24 +15897,24 @@
               <a:t>•  </a:t>
             </a:r>
             <a:r>
-              <a:rPr sz="1400" b="0" i="0">
+              <a:rPr sz="1300" b="0" i="0">
                 <a:solidFill>
                   <a:srgbClr val="222222"/>
                 </a:solidFill>
                 <a:latin typeface="Calibri"/>
                 <a:ea typeface="맑은 고딕"/>
               </a:rPr>
-              <a:t>라운드 N의 응답은 라운드 0..N-1의 모든 KV tensor를 다시 attention 입력으로 사용</a:t>
-            </a:r>
-          </a:p>
-          <a:p>
-            <a:pPr algn="l">
-              <a:spcAft>
-                <a:spcPts val="400"/>
-              </a:spcAft>
-            </a:pPr>
-            <a:r>
-              <a:rPr sz="1400" b="1" i="0">
+              <a:t>라운드 N 응답은 0..N-1 라운드 KV 를 attention 입력으로 재사용</a:t>
+            </a:r>
+          </a:p>
+          <a:p>
+            <a:pPr algn="l">
+              <a:spcAft>
+                <a:spcPts val="400"/>
+              </a:spcAft>
+            </a:pPr>
+            <a:r>
+              <a:rPr sz="1300" b="1" i="0">
                 <a:solidFill>
                   <a:srgbClr val="444444"/>
                 </a:solidFill>
@@ -15924,14 +15924,14 @@
               <a:t>•  </a:t>
             </a:r>
             <a:r>
-              <a:rPr sz="1400" b="0" i="0">
+              <a:rPr sz="1300" b="0" i="0">
                 <a:solidFill>
                   <a:srgbClr val="222222"/>
                 </a:solidFill>
                 <a:latin typeface="Calibri"/>
                 <a:ea typeface="맑은 고딕"/>
               </a:rPr>
-              <a:t>이 KV를 재계산하면 GPU FLOPs를 매번 다시 태움 → caching이 필수</a:t>
+              <a:t>재계산은 GPU FLOPs를 매번 태움 → KV caching이 필수</a:t>
             </a:r>
           </a:p>
         </p:txBody>
@@ -16949,8 +16949,8 @@
         </p:nvSpPr>
         <p:spPr>
           <a:xfrm>
-            <a:off x="6400800" y="1280160"/>
-            <a:ext cx="5303520" cy="4389120"/>
+            <a:off x="6126480" y="1280160"/>
+            <a:ext cx="5577840" cy="4389120"/>
           </a:xfrm>
           <a:prstGeom prst="rect">
             <a:avLst/>
@@ -16995,8 +16995,8 @@
         </p:nvSpPr>
         <p:spPr>
           <a:xfrm>
-            <a:off x="6583680" y="1463040"/>
-            <a:ext cx="4937760" cy="4023360"/>
+            <a:off x="6309360" y="1463040"/>
+            <a:ext cx="5212080" cy="4023360"/>
           </a:xfrm>
           <a:prstGeom prst="rect">
             <a:avLst/>
@@ -17015,7 +17015,7 @@
               </a:spcAft>
             </a:pPr>
             <a:r>
-              <a:rPr sz="1400" b="1" i="0">
+              <a:rPr sz="1300" b="1" i="0">
                 <a:solidFill>
                   <a:srgbClr val="1F2937"/>
                 </a:solidFill>
@@ -17032,14 +17032,14 @@
               </a:spcAft>
             </a:pPr>
             <a:r>
-              <a:rPr sz="1600" b="0" i="0">
+              <a:rPr sz="1300" b="0" i="0">
                 <a:solidFill>
                   <a:srgbClr val="222222"/>
                 </a:solidFill>
                 <a:latin typeface="Consolas"/>
                 <a:ea typeface="맑은 고딕"/>
               </a:rPr>
-              <a:t>Attention(Q, K, V) = softmax(Q · Kᵀ / √d) · V</a:t>
+              <a:t>Attention(Q,K,V) = softmax(Q·K^T / sqrt(d))·V</a:t>
             </a:r>
           </a:p>
           <a:p>
@@ -17049,7 +17049,7 @@
               </a:spcAft>
             </a:pPr>
             <a:r>
-              <a:rPr sz="1400" b="0" i="0">
+              <a:rPr sz="1300" b="0" i="0">
                 <a:solidFill>
                   <a:srgbClr val="222222"/>
                 </a:solidFill>
@@ -17066,7 +17066,7 @@
               </a:spcAft>
             </a:pPr>
             <a:r>
-              <a:rPr sz="1400" b="0" i="0">
+              <a:rPr sz="1300" b="0" i="0">
                 <a:solidFill>
                   <a:srgbClr val="222222"/>
                 </a:solidFill>
@@ -17076,7 +17076,7 @@
               <a:t>▸ 과거 토큰의 K, V는 변하지 않음 → </a:t>
             </a:r>
             <a:r>
-              <a:rPr sz="1400" b="1" i="0">
+              <a:rPr sz="1300" b="1" i="0">
                 <a:solidFill>
                   <a:srgbClr val="444444"/>
                 </a:solidFill>
@@ -17093,7 +17093,7 @@
               </a:spcAft>
             </a:pPr>
             <a:r>
-              <a:rPr sz="1400" b="0" i="0">
+              <a:rPr sz="1300" b="0" i="0">
                 <a:solidFill>
                   <a:srgbClr val="707680"/>
                 </a:solidFill>
@@ -17110,7 +17110,7 @@
               </a:spcAft>
             </a:pPr>
             <a:r>
-              <a:rPr sz="1400" b="0" i="0">
+              <a:rPr sz="1300" b="0" i="0">
                 <a:solidFill>
                   <a:srgbClr val="222222"/>
                 </a:solidFill>
@@ -17184,7 +17184,7 @@
               </a:spcAft>
             </a:pPr>
             <a:r>
-              <a:rPr sz="1400" b="1" i="0">
+              <a:rPr sz="1300" b="1" i="0">
                 <a:solidFill>
                   <a:srgbClr val="444444"/>
                 </a:solidFill>
@@ -17194,7 +17194,7 @@
               <a:t>•  </a:t>
             </a:r>
             <a:r>
-              <a:rPr sz="1400" b="0" i="0">
+              <a:rPr sz="1300" b="0" i="0">
                 <a:solidFill>
                   <a:srgbClr val="222222"/>
                 </a:solidFill>
@@ -17204,7 +17204,7 @@
               <a:t>재계산을 안 하면 </a:t>
             </a:r>
             <a:r>
-              <a:rPr sz="1400" b="1" i="0">
+              <a:rPr sz="1300" b="1" i="0">
                 <a:solidFill>
                   <a:srgbClr val="222222"/>
                 </a:solidFill>
@@ -17221,7 +17221,7 @@
               </a:spcAft>
             </a:pPr>
             <a:r>
-              <a:rPr sz="1400" b="1" i="0">
+              <a:rPr sz="1300" b="1" i="0">
                 <a:solidFill>
                   <a:srgbClr val="444444"/>
                 </a:solidFill>
@@ -17231,7 +17231,7 @@
               <a:t>•  </a:t>
             </a:r>
             <a:r>
-              <a:rPr sz="1400" b="0" i="0">
+              <a:rPr sz="1300" b="0" i="0">
                 <a:solidFill>
                   <a:srgbClr val="222222"/>
                 </a:solidFill>
@@ -17241,7 +17241,7 @@
               <a:t>저장 비용이 매우 큼 </a:t>
             </a:r>
             <a:r>
-              <a:rPr sz="1400" b="1" i="0">
+              <a:rPr sz="1300" b="1" i="0">
                 <a:solidFill>
                   <a:srgbClr val="222222"/>
                 </a:solidFill>
@@ -17258,7 +17258,7 @@
               </a:spcAft>
             </a:pPr>
             <a:r>
-              <a:rPr sz="1400" b="1" i="0">
+              <a:rPr sz="1300" b="1" i="0">
                 <a:solidFill>
                   <a:srgbClr val="444444"/>
                 </a:solidFill>
@@ -17268,7 +17268,7 @@
               <a:t>•  </a:t>
             </a:r>
             <a:r>
-              <a:rPr sz="1400" b="0" i="0">
+              <a:rPr sz="1300" b="0" i="0">
                 <a:solidFill>
                   <a:srgbClr val="222222"/>
                 </a:solidFill>
@@ -17278,7 +17278,7 @@
               <a:t>vLLM, PagedAttention 류 가속 시스템도 </a:t>
             </a:r>
             <a:r>
-              <a:rPr sz="1400" b="1" i="0">
+              <a:rPr sz="1300" b="1" i="0">
                 <a:solidFill>
                   <a:srgbClr val="222222"/>
                 </a:solidFill>
@@ -17312,7 +17312,7 @@
               </a:spcAft>
             </a:pPr>
             <a:r>
-              <a:rPr sz="1400" b="0" i="0">
+              <a:rPr sz="1300" b="0" i="0">
                 <a:solidFill>
                   <a:srgbClr val="222222"/>
                 </a:solidFill>
@@ -17322,7 +17322,7 @@
               <a:t>▸ 한 사용자의 </a:t>
             </a:r>
             <a:r>
-              <a:rPr sz="1400" b="1" i="0">
+              <a:rPr sz="1300" b="1" i="0">
                 <a:solidFill>
                   <a:srgbClr val="444444"/>
                 </a:solidFill>
@@ -17332,7 +17332,7 @@
               <a:t>여러 라운드 대화 KV</a:t>
             </a:r>
             <a:r>
-              <a:rPr sz="1400" b="0" i="0">
+              <a:rPr sz="1300" b="0" i="0">
                 <a:solidFill>
                   <a:srgbClr val="222222"/>
                 </a:solidFill>
@@ -17661,7 +17661,7 @@
               </a:spcAft>
             </a:pPr>
             <a:r>
-              <a:rPr sz="1400" b="1" i="0">
+              <a:rPr sz="1300" b="1" i="0">
                 <a:solidFill>
                   <a:srgbClr val="444444"/>
                 </a:solidFill>
@@ -17671,24 +17671,24 @@
               <a:t>•  </a:t>
             </a:r>
             <a:r>
-              <a:rPr sz="1400" b="1" i="0">
+              <a:rPr sz="1300" b="1" i="0">
                 <a:solidFill>
                   <a:srgbClr val="222222"/>
                 </a:solidFill>
                 <a:latin typeface="Calibri"/>
                 <a:ea typeface="맑은 고딕"/>
               </a:rPr>
-              <a:t>80GB A800 GPU 1장</a:t>
-            </a:r>
-            <a:r>
-              <a:rPr sz="1400" b="0" i="0">
+              <a:t>80GB A800 GPU 1장 </a:t>
+            </a:r>
+            <a:r>
+              <a:rPr sz="1300" b="0" i="0">
                 <a:solidFill>
                   <a:srgbClr val="222222"/>
                 </a:solidFill>
                 <a:latin typeface="Calibri"/>
                 <a:ea typeface="맑은 고딕"/>
               </a:rPr>
-              <a:t> → Attention KV가 곧바로 GPU 메모리를 잡아먹음</a:t>
+              <a:t>→ KV가 곧바로 GPU 메모리를 점유</a:t>
             </a:r>
           </a:p>
           <a:p>
@@ -17698,7 +17698,7 @@
               </a:spcAft>
             </a:pPr>
             <a:r>
-              <a:rPr sz="1400" b="1" i="0">
+              <a:rPr sz="1300" b="1" i="0">
                 <a:solidFill>
                   <a:srgbClr val="444444"/>
                 </a:solidFill>
@@ -17708,24 +17708,24 @@
               <a:t>•  </a:t>
             </a:r>
             <a:r>
-              <a:rPr sz="1400" b="1" i="0">
+              <a:rPr sz="1300" b="1" i="0">
                 <a:solidFill>
                   <a:srgbClr val="222222"/>
                 </a:solidFill>
                 <a:latin typeface="Calibri"/>
                 <a:ea typeface="맑은 고딕"/>
               </a:rPr>
-              <a:t>사용자 30명/분 도착 시 </a:t>
-            </a:r>
-            <a:r>
-              <a:rPr sz="1400" b="0" i="0">
+              <a:t>30 users/min 도착 시 </a:t>
+            </a:r>
+            <a:r>
+              <a:rPr sz="1300" b="0" i="0">
                 <a:solidFill>
                   <a:srgbClr val="222222"/>
                 </a:solidFill>
                 <a:latin typeface="Calibri"/>
                 <a:ea typeface="맑은 고딕"/>
               </a:rPr>
-              <a:t>OPT-13B에서 동시 캐시 KV가 480GB까지 증가</a:t>
+              <a:t>OPT-13B 동시 캐시 KV ≈ 480 GB</a:t>
             </a:r>
           </a:p>
           <a:p>
@@ -17735,7 +17735,7 @@
               </a:spcAft>
             </a:pPr>
             <a:r>
-              <a:rPr sz="1400" b="1" i="0">
+              <a:rPr sz="1300" b="1" i="0">
                 <a:solidFill>
                   <a:srgbClr val="444444"/>
                 </a:solidFill>
@@ -17745,24 +17745,24 @@
               <a:t>•  </a:t>
             </a:r>
             <a:r>
-              <a:rPr sz="1400" b="1" i="0">
+              <a:rPr sz="1300" b="1" i="0">
                 <a:solidFill>
                   <a:srgbClr val="222222"/>
                 </a:solidFill>
                 <a:latin typeface="Calibri"/>
                 <a:ea typeface="맑은 고딕"/>
               </a:rPr>
-              <a:t>일반적인 LLM 서버의 </a:t>
-            </a:r>
-            <a:r>
-              <a:rPr sz="1400" b="0" i="0">
+              <a:t>LLM 서버 host memory </a:t>
+            </a:r>
+            <a:r>
+              <a:rPr sz="1300" b="0" i="0">
                 <a:solidFill>
                   <a:srgbClr val="222222"/>
                 </a:solidFill>
                 <a:latin typeface="Calibri"/>
                 <a:ea typeface="맑은 고딕"/>
               </a:rPr>
-              <a:t>host memory(perf layer)는 약 1.6×–3.2× of GPU memory</a:t>
+              <a:t>≈ GPU mem 의 1.6–3.2×</a:t>
             </a:r>
           </a:p>
           <a:p>
@@ -17772,7 +17772,7 @@
               </a:spcAft>
             </a:pPr>
             <a:r>
-              <a:rPr sz="1400" b="1" i="0">
+              <a:rPr sz="1300" b="1" i="0">
                 <a:solidFill>
                   <a:srgbClr val="444444"/>
                 </a:solidFill>
@@ -17782,24 +17782,24 @@
               <a:t>•  </a:t>
             </a:r>
             <a:r>
-              <a:rPr sz="1400" b="1" i="0">
+              <a:rPr sz="1300" b="1" i="0">
                 <a:solidFill>
                   <a:srgbClr val="222222"/>
                 </a:solidFill>
                 <a:latin typeface="Calibri"/>
                 <a:ea typeface="맑은 고딕"/>
               </a:rPr>
-              <a:t>따라서 </a:t>
-            </a:r>
-            <a:r>
-              <a:rPr sz="1400" b="0" i="0">
+              <a:t>→ host memory </a:t>
+            </a:r>
+            <a:r>
+              <a:rPr sz="1300" b="0" i="0">
                 <a:solidFill>
                   <a:srgbClr val="222222"/>
                 </a:solidFill>
                 <a:latin typeface="Calibri"/>
                 <a:ea typeface="맑은 고딕"/>
               </a:rPr>
-              <a:t>host memory도 부족 → SSD(capacity layer)까지 사용해야 함</a:t>
+              <a:t>도 부족, capacity SSD 도 사용해야 함</a:t>
             </a:r>
           </a:p>
         </p:txBody>
@@ -17915,7 +17915,7 @@
               </a:spcAft>
             </a:pPr>
             <a:r>
-              <a:rPr sz="1400" b="0" i="1">
+              <a:rPr sz="1300" b="0" i="1">
                 <a:solidFill>
                   <a:srgbClr val="707680"/>
                 </a:solidFill>
@@ -18509,7 +18509,7 @@
               </a:spcAft>
             </a:pPr>
             <a:r>
-              <a:rPr sz="1400" b="0" i="0">
+              <a:rPr sz="1300" b="0" i="0">
                 <a:solidFill>
                   <a:srgbClr val="222222"/>
                 </a:solidFill>
@@ -18519,7 +18519,7 @@
               <a:t>쓰기는 백그라운드, 그러나 읽기(load)는 </a:t>
             </a:r>
             <a:r>
-              <a:rPr sz="1400" b="1" i="0">
+              <a:rPr sz="1300" b="1" i="0">
                 <a:solidFill>
                   <a:srgbClr val="444444"/>
                 </a:solidFill>
@@ -18848,7 +18848,7 @@
               </a:spcAft>
             </a:pPr>
             <a:r>
-              <a:rPr sz="1400" b="1" i="0">
+              <a:rPr sz="1300" b="1" i="0">
                 <a:solidFill>
                   <a:srgbClr val="1F2937"/>
                 </a:solidFill>
@@ -18882,7 +18882,7 @@
               </a:spcAft>
             </a:pPr>
             <a:r>
-              <a:rPr sz="1400" b="1" i="0">
+              <a:rPr sz="1300" b="1" i="0">
                 <a:solidFill>
                   <a:srgbClr val="1F2937"/>
                 </a:solidFill>
@@ -18899,7 +18899,7 @@
               </a:spcAft>
             </a:pPr>
             <a:r>
-              <a:rPr sz="1400" b="0" i="0">
+              <a:rPr sz="1300" b="0" i="0">
                 <a:solidFill>
                   <a:srgbClr val="222222"/>
                 </a:solidFill>
@@ -18909,7 +18909,7 @@
               <a:t>▸ 응답 latency가 </a:t>
             </a:r>
             <a:r>
-              <a:rPr sz="1400" b="1" i="0">
+              <a:rPr sz="1300" b="1" i="0">
                 <a:solidFill>
                   <a:srgbClr val="444444"/>
                 </a:solidFill>
@@ -18926,7 +18926,7 @@
               </a:spcAft>
             </a:pPr>
             <a:r>
-              <a:rPr sz="1400" b="0" i="0">
+              <a:rPr sz="1300" b="0" i="0">
                 <a:solidFill>
                   <a:srgbClr val="222222"/>
                 </a:solidFill>
@@ -18936,7 +18936,7 @@
               <a:t>▸ throughput은 </a:t>
             </a:r>
             <a:r>
-              <a:rPr sz="1400" b="1" i="0">
+              <a:rPr sz="1300" b="1" i="0">
                 <a:solidFill>
                   <a:srgbClr val="444444"/>
                 </a:solidFill>
@@ -18953,7 +18953,7 @@
               </a:spcAft>
             </a:pPr>
             <a:r>
-              <a:rPr sz="1400" b="1" i="0">
+              <a:rPr sz="1300" b="1" i="0">
                 <a:solidFill>
                   <a:srgbClr val="1F2937"/>
                 </a:solidFill>
@@ -19316,7 +19316,7 @@
               </a:spcAft>
             </a:pPr>
             <a:r>
-              <a:rPr sz="1400" b="1" i="0">
+              <a:rPr sz="1300" b="1" i="0">
                 <a:solidFill>
                   <a:srgbClr val="1F2937"/>
                 </a:solidFill>
@@ -19340,17 +19340,17 @@
                 <a:latin typeface="Calibri"/>
                 <a:ea typeface="맑은 고딕"/>
               </a:rPr>
-              <a:t>China Telecom omni-channel — 1M+ 라운드, 사용자 단위 timestamp 보존</a:t>
-            </a:r>
-          </a:p>
-          <a:p>
-            <a:pPr algn="l">
-              <a:spcAft>
-                <a:spcPts val="400"/>
-              </a:spcAft>
-            </a:pPr>
-            <a:r>
-              <a:rPr sz="1400" b="1" i="0">
+              <a:t>China Telecom · 1M+ 라운드 · user timestamp 보존</a:t>
+            </a:r>
+          </a:p>
+          <a:p>
+            <a:pPr algn="l">
+              <a:spcAft>
+                <a:spcPts val="400"/>
+              </a:spcAft>
+            </a:pPr>
+            <a:r>
+              <a:rPr sz="1300" b="1" i="0">
                 <a:solidFill>
                   <a:srgbClr val="1F2937"/>
                 </a:solidFill>
@@ -19384,7 +19384,7 @@
                 <a:latin typeface="Calibri"/>
                 <a:ea typeface="맑은 고딕"/>
               </a:rPr>
-              <a:t>ShareGPT: 평균 5.7 라운드 — 인터랙티브 대화 분석에 부족</a:t>
+              <a:t>ShareGPT: 5.7 라운드 — interactive 분석엔 짧음</a:t>
             </a:r>
           </a:p>
           <a:p>
@@ -19411,7 +19411,7 @@
                 <a:latin typeface="Calibri"/>
                 <a:ea typeface="맑은 고딕"/>
               </a:rPr>
-              <a:t>Mooncake: query 12k+ 토큰 — 길지만 대화 패턴은 부재</a:t>
+              <a:t>Mooncake: 12k+ 토큰 — 길지만 대화 패턴 부재</a:t>
             </a:r>
           </a:p>
           <a:p>
@@ -19438,7 +19438,7 @@
                 <a:latin typeface="Calibri"/>
                 <a:ea typeface="맑은 고딕"/>
               </a:rPr>
-              <a:t>본 trace: 라운드 수 22.4 / 토큰 길이 36 — “interactive” 정의에 부합</a:t>
+              <a:t>본 trace: 22.4 라운드 / 36 토큰 — interactive 부합</a:t>
             </a:r>
           </a:p>
         </p:txBody>
@@ -19517,7 +19517,7 @@
               </a:spcAft>
             </a:pPr>
             <a:r>
-              <a:rPr sz="1400" b="0" i="0">
+              <a:rPr sz="1300" b="0" i="0">
                 <a:solidFill>
                   <a:srgbClr val="222222"/>
                 </a:solidFill>
@@ -19527,7 +19527,7 @@
               <a:t>이어지는 세 슬라이드에서 </a:t>
             </a:r>
             <a:r>
-              <a:rPr sz="1400" b="1" i="0">
+              <a:rPr sz="1300" b="1" i="0">
                 <a:solidFill>
                   <a:srgbClr val="444444"/>
                 </a:solidFill>
@@ -19537,7 +19537,7 @@
               <a:t>Observation 1 / 2 / 3</a:t>
             </a:r>
             <a:r>
-              <a:rPr sz="1400" b="0" i="0">
+              <a:rPr sz="1300" b="0" i="0">
                 <a:solidFill>
                   <a:srgbClr val="222222"/>
                 </a:solidFill>
@@ -19866,7 +19866,7 @@
               </a:spcAft>
             </a:pPr>
             <a:r>
-              <a:rPr sz="1400" b="1" i="0">
+              <a:rPr sz="1300" b="1" i="0">
                 <a:solidFill>
                   <a:srgbClr val="1F2937"/>
                 </a:solidFill>
@@ -19900,7 +19900,7 @@
                 <a:latin typeface="Calibri"/>
                 <a:ea typeface="맑은 고딕"/>
               </a:rPr>
-              <a:t>사용자는 평균 22.4 라운드 동안 KV가 살아있어야 함</a:t>
+              <a:t>사용자 평균 22.4 라운드 동안 KV 가 생존</a:t>
             </a:r>
           </a:p>
           <a:p>
@@ -19927,7 +19927,7 @@
                 <a:latin typeface="Calibri"/>
                 <a:ea typeface="맑은 고딕"/>
               </a:rPr>
-              <a:t>도착률이 늘면 동시 사용자 수가 선형 증가</a:t>
+              <a:t>도착률↑ → 동시 사용자 수 선형 증가</a:t>
             </a:r>
           </a:p>
           <a:p>
@@ -19954,17 +19954,17 @@
                 <a:latin typeface="Calibri"/>
                 <a:ea typeface="맑은 고딕"/>
               </a:rPr>
-              <a:t>OPT-13B에서 30 users/min일 때 480 GB &gt; 200 GB perf layer</a:t>
-            </a:r>
-          </a:p>
-          <a:p>
-            <a:pPr algn="l">
-              <a:spcAft>
-                <a:spcPts val="400"/>
-              </a:spcAft>
-            </a:pPr>
-            <a:r>
-              <a:rPr sz="1400" b="1" i="0">
+              <a:t>OPT-13B · 30 users/min ≈ 480 GB (perf 200 GB)</a:t>
+            </a:r>
+          </a:p>
+          <a:p>
+            <a:pPr algn="l">
+              <a:spcAft>
+                <a:spcPts val="400"/>
+              </a:spcAft>
+            </a:pPr>
+            <a:r>
+              <a:rPr sz="1300" b="1" i="0">
                 <a:solidFill>
                   <a:srgbClr val="1F2937"/>
                 </a:solidFill>
@@ -19998,7 +19998,7 @@
                 <a:latin typeface="Calibri"/>
                 <a:ea typeface="맑은 고딕"/>
               </a:rPr>
-              <a:t>perf layer가 아무리 크더라도 곧 한계</a:t>
+              <a:t>perf layer 가 커도 결국 한계</a:t>
             </a:r>
           </a:p>
           <a:p>
@@ -20025,7 +20025,7 @@
                 <a:latin typeface="Calibri"/>
                 <a:ea typeface="맑은 고딕"/>
               </a:rPr>
-              <a:t>eviction을 잘 하지 못하면 capacity layer로 자주 fallback</a:t>
+              <a:t>eviction 부실 → capacity layer 로 빈번히 fallback</a:t>
             </a:r>
           </a:p>
         </p:txBody>

</xml_diff>

<commit_message>
Self-review pass: fix layout, overlap, and dead space
After eyeballing the rendered deck slide-by-slide, several layout
issues surfaced. Changes:

- Slide 4: shrink left-bullet column 6.4″ → 6.0″ so it stops bleeding
  into the right-side schematic box
- Slide 8: replace 1.6″ tinted callout panel (which held a single
  sentence) with a slim one-line teaser
- Slide 11: rearrange figures 7 + 8 from stacked vertically (which left
  the right half empty) to side-by-side across the top, with the body
  on the bottom row
- Slides 13, 17, 24: shrink the two-column callout panels from 5.6″
  height to ~3.4–4.0″ so they actually match their content
- Slide 21: stretch the 5-step list from 0.85″ row pitch to 1.05″, with
  larger circled numerals — fills the slide instead of bottom-loading
- Slides 9, 10, 23, 24: tighten Korean copy on widow-prone bullets
</commit_message>
<xml_diff>
--- a/Bidaw_seminar.pptx
+++ b/Bidaw_seminar.pptx
@@ -3641,24 +3641,24 @@
               <a:t>▸ </a:t>
             </a:r>
             <a:r>
-              <a:rPr sz="1400" b="0" i="0">
-                <a:solidFill>
-                  <a:srgbClr val="1F2937"/>
-                </a:solidFill>
-                <a:latin typeface="Calibri"/>
-                <a:ea typeface="맑은 고딕"/>
-              </a:rPr>
-              <a:t>80%의 KV access 가 </a:t>
-            </a:r>
-            <a:r>
-              <a:rPr sz="1400" b="1" i="0">
-                <a:solidFill>
-                  <a:srgbClr val="1F2937"/>
-                </a:solidFill>
-                <a:latin typeface="Calibri"/>
-                <a:ea typeface="맑은 고딕"/>
-              </a:rPr>
-              <a:t>perf layer (200GB)를 초과</a:t>
+              <a:rPr sz="1700" b="0" i="0">
+                <a:solidFill>
+                  <a:srgbClr val="1F2937"/>
+                </a:solidFill>
+                <a:latin typeface="Calibri"/>
+                <a:ea typeface="맑은 고딕"/>
+              </a:rPr>
+              <a:t>80% access </a:t>
+            </a:r>
+            <a:r>
+              <a:rPr sz="1700" b="1" i="0">
+                <a:solidFill>
+                  <a:srgbClr val="1F2937"/>
+                </a:solidFill>
+                <a:latin typeface="Calibri"/>
+                <a:ea typeface="맑은 고딕"/>
+              </a:rPr>
+              <a:t>&gt;  perf 200 GB</a:t>
             </a:r>
           </a:p>
           <a:p>
@@ -3678,24 +3678,24 @@
               <a:t>▸ </a:t>
             </a:r>
             <a:r>
-              <a:rPr sz="1400" b="0" i="0">
-                <a:solidFill>
-                  <a:srgbClr val="1F2937"/>
-                </a:solidFill>
-                <a:latin typeface="Calibri"/>
-                <a:ea typeface="맑은 고딕"/>
-              </a:rPr>
-              <a:t>FIFO/LRU/queue-enhanced 모두 </a:t>
-            </a:r>
-            <a:r>
-              <a:rPr sz="1400" b="1" i="0">
-                <a:solidFill>
-                  <a:srgbClr val="1F2937"/>
-                </a:solidFill>
-                <a:latin typeface="Calibri"/>
-                <a:ea typeface="맑은 고딕"/>
-              </a:rPr>
-              <a:t>hit rate ≈ 20% 수준</a:t>
+              <a:rPr sz="1700" b="0" i="0">
+                <a:solidFill>
+                  <a:srgbClr val="1F2937"/>
+                </a:solidFill>
+                <a:latin typeface="Calibri"/>
+                <a:ea typeface="맑은 고딕"/>
+              </a:rPr>
+              <a:t>정책 무관 </a:t>
+            </a:r>
+            <a:r>
+              <a:rPr sz="1700" b="1" i="0">
+                <a:solidFill>
+                  <a:srgbClr val="1F2937"/>
+                </a:solidFill>
+                <a:latin typeface="Calibri"/>
+                <a:ea typeface="맑은 고딕"/>
+              </a:rPr>
+              <a:t>hit ≈ 20 %</a:t>
             </a:r>
           </a:p>
           <a:p>
@@ -3715,51 +3715,51 @@
               <a:t>▸ </a:t>
             </a:r>
             <a:r>
-              <a:rPr sz="1400" b="0" i="0">
-                <a:solidFill>
-                  <a:srgbClr val="1F2937"/>
-                </a:solidFill>
-                <a:latin typeface="Calibri"/>
-                <a:ea typeface="맑은 고딕"/>
-              </a:rPr>
-              <a:t>perf layer가 </a:t>
-            </a:r>
-            <a:r>
-              <a:rPr sz="1400" b="1" i="0">
-                <a:solidFill>
-                  <a:srgbClr val="1F2937"/>
-                </a:solidFill>
-                <a:latin typeface="Calibri"/>
-                <a:ea typeface="맑은 고딕"/>
-              </a:rPr>
-              <a:t>전체 KV의 40.1%를 담을 수 있음에도 hit는 절반 수준</a:t>
-            </a:r>
-          </a:p>
-          <a:p>
-            <a:pPr algn="l">
-              <a:spcAft>
-                <a:spcPts val="400"/>
-              </a:spcAft>
-            </a:pPr>
-            <a:r>
-              <a:rPr sz="1400" b="0" i="0">
-                <a:solidFill>
-                  <a:srgbClr val="1F2937"/>
-                </a:solidFill>
-                <a:latin typeface="Calibri"/>
-                <a:ea typeface="맑은 고딕"/>
-              </a:rPr>
-              <a:t>→ 사용자가 답을 읽는 사이 </a:t>
-            </a:r>
-            <a:r>
-              <a:rPr sz="1400" b="0" i="1">
+              <a:rPr sz="1700" b="0" i="0">
+                <a:solidFill>
+                  <a:srgbClr val="1F2937"/>
+                </a:solidFill>
+                <a:latin typeface="Calibri"/>
+                <a:ea typeface="맑은 고딕"/>
+              </a:rPr>
+              <a:t>perf 가 40 % 담아도 </a:t>
+            </a:r>
+            <a:r>
+              <a:rPr sz="1700" b="1" i="0">
+                <a:solidFill>
+                  <a:srgbClr val="1F2937"/>
+                </a:solidFill>
+                <a:latin typeface="Calibri"/>
+                <a:ea typeface="맑은 고딕"/>
+              </a:rPr>
+              <a:t>hit 절반 수준</a:t>
+            </a:r>
+          </a:p>
+          <a:p>
+            <a:pPr algn="l">
+              <a:spcAft>
+                <a:spcPts val="400"/>
+              </a:spcAft>
+            </a:pPr>
+            <a:r>
+              <a:rPr sz="1600" b="0" i="0">
+                <a:solidFill>
+                  <a:srgbClr val="1F2937"/>
+                </a:solidFill>
+                <a:latin typeface="Calibri"/>
+                <a:ea typeface="맑은 고딕"/>
+              </a:rPr>
+              <a:t>→ user 가 답 읽는 사이 </a:t>
+            </a:r>
+            <a:r>
+              <a:rPr sz="1600" b="0" i="1">
                 <a:solidFill>
                   <a:srgbClr val="6B7280"/>
                 </a:solidFill>
                 <a:latin typeface="Calibri"/>
                 <a:ea typeface="맑은 고딕"/>
               </a:rPr>
-              <a:t>다른 user KV 가 끼어들기 때문</a:t>
+              <a:t>다른 KV 끼어듦</a:t>
             </a:r>
           </a:p>
         </p:txBody>
@@ -3895,8 +3895,8 @@
         </p:blipFill>
         <p:spPr>
           <a:xfrm>
-            <a:off x="507102" y="1280160"/>
-            <a:ext cx="5660916" cy="2377440"/>
+            <a:off x="457200" y="1280160"/>
+            <a:ext cx="5669280" cy="2380952"/>
           </a:xfrm>
           <a:prstGeom prst="rect">
             <a:avLst/>
@@ -3911,8 +3911,8 @@
         </p:nvSpPr>
         <p:spPr>
           <a:xfrm>
-            <a:off x="457200" y="3703320"/>
-            <a:ext cx="5760720" cy="320040"/>
+            <a:off x="457200" y="3706832"/>
+            <a:ext cx="5669280" cy="320040"/>
           </a:xfrm>
           <a:prstGeom prst="rect">
             <a:avLst/>
@@ -3938,7 +3938,7 @@
                 <a:latin typeface="Calibri"/>
                 <a:ea typeface="맑은 고딕"/>
               </a:rPr>
-              <a:t>Figure 7. 시간 구간별 KV loading time의 변동계수 CV</a:t>
+              <a:t>Figure 7. 시간 구간별 KV loading time 의 변동계수 CV</a:t>
             </a:r>
           </a:p>
         </p:txBody>
@@ -3959,8 +3959,8 @@
         </p:blipFill>
         <p:spPr>
           <a:xfrm>
-            <a:off x="603837" y="3931920"/>
-            <a:ext cx="5467446" cy="2377440"/>
+            <a:off x="6309360" y="1280160"/>
+            <a:ext cx="5486400" cy="2385681"/>
           </a:xfrm>
           <a:prstGeom prst="rect">
             <a:avLst/>
@@ -3975,8 +3975,8 @@
         </p:nvSpPr>
         <p:spPr>
           <a:xfrm>
-            <a:off x="457200" y="6355080"/>
-            <a:ext cx="5760720" cy="320040"/>
+            <a:off x="6309360" y="3711561"/>
+            <a:ext cx="5486400" cy="320040"/>
           </a:xfrm>
           <a:prstGeom prst="rect">
             <a:avLst/>
@@ -4015,8 +4015,8 @@
         </p:nvSpPr>
         <p:spPr>
           <a:xfrm>
-            <a:off x="6492240" y="1280160"/>
-            <a:ext cx="5486400" cy="5120640"/>
+            <a:off x="457200" y="4297680"/>
+            <a:ext cx="11247120" cy="2194560"/>
           </a:xfrm>
           <a:prstGeom prst="rect">
             <a:avLst/>
@@ -4048,7 +4048,7 @@
           <a:p>
             <a:pPr algn="l">
               <a:spcAft>
-                <a:spcPts val="400"/>
+                <a:spcPts val="1000"/>
               </a:spcAft>
             </a:pPr>
             <a:r>
@@ -4069,7 +4069,7 @@
                 <a:latin typeface="Calibri"/>
                 <a:ea typeface="맑은 고딕"/>
               </a:rPr>
-              <a:t>두 layer 의 </a:t>
+              <a:t>host DRAM ↔ SSD </a:t>
             </a:r>
             <a:r>
               <a:rPr sz="1800" b="1" i="0">
@@ -4079,81 +4079,47 @@
                 <a:latin typeface="Calibri"/>
                 <a:ea typeface="맑은 고딕"/>
               </a:rPr>
-              <a:t>bandwidth 격차 (host DRAM ↔ SSD)</a:t>
-            </a:r>
-          </a:p>
-          <a:p>
-            <a:pPr algn="l">
-              <a:spcAft>
-                <a:spcPts val="400"/>
-              </a:spcAft>
-            </a:pPr>
+              <a:t>bandwidth 격차</a:t>
+            </a:r>
+            <a:r>
+              <a:rPr sz="1800" b="0" i="0">
+                <a:solidFill>
+                  <a:srgbClr val="1F2937"/>
+                </a:solidFill>
+                <a:latin typeface="Calibri"/>
+                <a:ea typeface="맑은 고딕"/>
+              </a:rPr>
+              <a:t>  ·  요청별 </a:t>
+            </a:r>
             <a:r>
               <a:rPr sz="1800" b="1" i="0">
                 <a:solidFill>
+                  <a:srgbClr val="1F2937"/>
+                </a:solidFill>
+                <a:latin typeface="Calibri"/>
+                <a:ea typeface="맑은 고딕"/>
+              </a:rPr>
+              <a:t>KV size 가 수십 MB ~ 수백 MB</a:t>
+            </a:r>
+            <a:r>
+              <a:rPr sz="1800" b="0" i="0">
+                <a:solidFill>
+                  <a:srgbClr val="1F2937"/>
+                </a:solidFill>
+                <a:latin typeface="Calibri"/>
+                <a:ea typeface="맑은 고딕"/>
+              </a:rPr>
+              <a:t>  ·  </a:t>
+            </a:r>
+            <a:r>
+              <a:rPr sz="1800" b="1" i="0">
+                <a:solidFill>
                   <a:srgbClr val="D9352A"/>
                 </a:solidFill>
                 <a:latin typeface="Calibri"/>
                 <a:ea typeface="맑은 고딕"/>
               </a:rPr>
-              <a:t>▸ </a:t>
-            </a:r>
-            <a:r>
-              <a:rPr sz="1800" b="0" i="0">
-                <a:solidFill>
-                  <a:srgbClr val="1F2937"/>
-                </a:solidFill>
-                <a:latin typeface="Calibri"/>
-                <a:ea typeface="맑은 고딕"/>
-              </a:rPr>
-              <a:t>요청별 </a:t>
-            </a:r>
-            <a:r>
-              <a:rPr sz="1800" b="1" i="0">
-                <a:solidFill>
-                  <a:srgbClr val="1F2937"/>
-                </a:solidFill>
-                <a:latin typeface="Calibri"/>
-                <a:ea typeface="맑은 고딕"/>
-              </a:rPr>
-              <a:t>KV size 자체가 매우 다름 (수십 MB ~ 수백 MB)</a:t>
-            </a:r>
-          </a:p>
-          <a:p>
-            <a:pPr algn="l">
-              <a:spcAft>
-                <a:spcPts val="400"/>
-              </a:spcAft>
-            </a:pPr>
-            <a:r>
-              <a:rPr sz="1800" b="1" i="0">
-                <a:solidFill>
-                  <a:srgbClr val="D9352A"/>
-                </a:solidFill>
-                <a:latin typeface="Calibri"/>
-                <a:ea typeface="맑은 고딕"/>
-              </a:rPr>
-              <a:t>▸ </a:t>
-            </a:r>
-            <a:r>
-              <a:rPr sz="1800" b="0" i="0">
-                <a:solidFill>
-                  <a:srgbClr val="1F2937"/>
-                </a:solidFill>
-                <a:latin typeface="Calibri"/>
-                <a:ea typeface="맑은 고딕"/>
-              </a:rPr>
-              <a:t>심지어 </a:t>
-            </a:r>
-            <a:r>
-              <a:rPr sz="1800" b="1" i="0">
-                <a:solidFill>
-                  <a:srgbClr val="1F2937"/>
-                </a:solidFill>
-                <a:latin typeface="Calibri"/>
-                <a:ea typeface="맑은 고딕"/>
-              </a:rPr>
-              <a:t>5초 윈도우 내에서도 CV &gt; 90% — globally 균일화되지 않음</a:t>
+              <a:t>5초 윈도우에서도 CV &gt; 90 %</a:t>
             </a:r>
           </a:p>
           <a:p>
@@ -4170,17 +4136,10 @@
                 <a:latin typeface="Calibri"/>
                 <a:ea typeface="맑은 고딕"/>
               </a:rPr>
-              <a:t>함의</a:t>
-            </a:r>
-          </a:p>
-          <a:p>
-            <a:pPr algn="l">
-              <a:spcAft>
-                <a:spcPts val="400"/>
-              </a:spcAft>
-            </a:pPr>
-            <a:r>
-              <a:rPr sz="1800" b="0" i="0">
+              <a:t>함의 — </a:t>
+            </a:r>
+            <a:r>
+              <a:rPr sz="2000" b="0" i="0">
                 <a:solidFill>
                   <a:srgbClr val="1F2937"/>
                 </a:solidFill>
@@ -4190,7 +4149,7 @@
               <a:t>큰 KV 한 개가 </a:t>
             </a:r>
             <a:r>
-              <a:rPr sz="1800" b="1" i="0">
+              <a:rPr sz="2000" b="1" i="0">
                 <a:solidFill>
                   <a:srgbClr val="D9352A"/>
                 </a:solidFill>
@@ -4837,8 +4796,8 @@
         </p:nvSpPr>
         <p:spPr>
           <a:xfrm>
-            <a:off x="457200" y="1280160"/>
-            <a:ext cx="5486400" cy="4937760"/>
+            <a:off x="457200" y="1417320"/>
+            <a:ext cx="5486400" cy="3474720"/>
           </a:xfrm>
           <a:prstGeom prst="rect">
             <a:avLst/>
@@ -4883,8 +4842,8 @@
         </p:nvSpPr>
         <p:spPr>
           <a:xfrm>
-            <a:off x="640080" y="1371600"/>
-            <a:ext cx="5120640" cy="4754880"/>
+            <a:off x="640080" y="1554480"/>
+            <a:ext cx="5120640" cy="3200400"/>
           </a:xfrm>
           <a:prstGeom prst="rect">
             <a:avLst/>
@@ -5041,8 +5000,8 @@
         </p:nvSpPr>
         <p:spPr>
           <a:xfrm>
-            <a:off x="6217920" y="1280160"/>
-            <a:ext cx="5486400" cy="4937760"/>
+            <a:off x="6217920" y="1417320"/>
+            <a:ext cx="5486400" cy="3474720"/>
           </a:xfrm>
           <a:prstGeom prst="rect">
             <a:avLst/>
@@ -5087,8 +5046,8 @@
         </p:nvSpPr>
         <p:spPr>
           <a:xfrm>
-            <a:off x="6400800" y="1371600"/>
-            <a:ext cx="5120640" cy="4754880"/>
+            <a:off x="6400800" y="1554480"/>
+            <a:ext cx="5120640" cy="3200400"/>
           </a:xfrm>
           <a:prstGeom prst="rect">
             <a:avLst/>
@@ -6651,8 +6610,8 @@
         </p:nvSpPr>
         <p:spPr>
           <a:xfrm>
-            <a:off x="457200" y="1188720"/>
-            <a:ext cx="5669280" cy="5120640"/>
+            <a:off x="457200" y="1280160"/>
+            <a:ext cx="5669280" cy="3657600"/>
           </a:xfrm>
           <a:prstGeom prst="rect">
             <a:avLst/>
@@ -6697,8 +6656,8 @@
         </p:nvSpPr>
         <p:spPr>
           <a:xfrm>
-            <a:off x="640080" y="1280160"/>
-            <a:ext cx="5303520" cy="4937760"/>
+            <a:off x="640080" y="1417320"/>
+            <a:ext cx="5303520" cy="3383280"/>
           </a:xfrm>
           <a:prstGeom prst="rect">
             <a:avLst/>
@@ -6842,8 +6801,8 @@
         </p:nvSpPr>
         <p:spPr>
           <a:xfrm>
-            <a:off x="6309360" y="1188720"/>
-            <a:ext cx="5394960" cy="5120640"/>
+            <a:off x="6309360" y="1280160"/>
+            <a:ext cx="5394960" cy="3657600"/>
           </a:xfrm>
           <a:prstGeom prst="rect">
             <a:avLst/>
@@ -6888,8 +6847,8 @@
         </p:nvSpPr>
         <p:spPr>
           <a:xfrm>
-            <a:off x="6492240" y="1280160"/>
-            <a:ext cx="5029200" cy="4937760"/>
+            <a:off x="6492240" y="1417320"/>
+            <a:ext cx="5029200" cy="3383280"/>
           </a:xfrm>
           <a:prstGeom prst="rect">
             <a:avLst/>
@@ -9031,8 +8990,8 @@
         </p:nvSpPr>
         <p:spPr>
           <a:xfrm>
-            <a:off x="457200" y="1280160"/>
-            <a:ext cx="640080" cy="731520"/>
+            <a:off x="457200" y="1463040"/>
+            <a:ext cx="822960" cy="822960"/>
           </a:xfrm>
           <a:prstGeom prst="rect">
             <a:avLst/>
@@ -9051,7 +9010,7 @@
               </a:spcAft>
             </a:pPr>
             <a:r>
-              <a:rPr sz="2000" b="1" i="0">
+              <a:rPr sz="2800" b="1" i="0">
                 <a:solidFill>
                   <a:srgbClr val="6B7280"/>
                 </a:solidFill>
@@ -9071,8 +9030,8 @@
         </p:nvSpPr>
         <p:spPr>
           <a:xfrm>
-            <a:off x="1188720" y="1325880"/>
-            <a:ext cx="10515600" cy="731520"/>
+            <a:off x="1371600" y="1508760"/>
+            <a:ext cx="10424160" cy="822960"/>
           </a:xfrm>
           <a:prstGeom prst="rect">
             <a:avLst/>
@@ -9091,7 +9050,7 @@
               </a:spcAft>
             </a:pPr>
             <a:r>
-              <a:rPr sz="1800" b="0" i="0">
+              <a:rPr sz="1900" b="0" i="0">
                 <a:solidFill>
                   <a:srgbClr val="1F2937"/>
                 </a:solidFill>
@@ -9111,8 +9070,8 @@
         </p:nvSpPr>
         <p:spPr>
           <a:xfrm>
-            <a:off x="457200" y="2057400"/>
-            <a:ext cx="640080" cy="731520"/>
+            <a:off x="457200" y="2423160"/>
+            <a:ext cx="822960" cy="822960"/>
           </a:xfrm>
           <a:prstGeom prst="rect">
             <a:avLst/>
@@ -9131,7 +9090,7 @@
               </a:spcAft>
             </a:pPr>
             <a:r>
-              <a:rPr sz="2000" b="1" i="0">
+              <a:rPr sz="2800" b="1" i="0">
                 <a:solidFill>
                   <a:srgbClr val="6B7280"/>
                 </a:solidFill>
@@ -9151,8 +9110,8 @@
         </p:nvSpPr>
         <p:spPr>
           <a:xfrm>
-            <a:off x="1188720" y="2103120"/>
-            <a:ext cx="10515600" cy="731520"/>
+            <a:off x="1371600" y="2468880"/>
+            <a:ext cx="10424160" cy="822960"/>
           </a:xfrm>
           <a:prstGeom prst="rect">
             <a:avLst/>
@@ -9171,7 +9130,7 @@
               </a:spcAft>
             </a:pPr>
             <a:r>
-              <a:rPr sz="1800" b="0" i="0">
+              <a:rPr sz="1900" b="0" i="0">
                 <a:solidFill>
                   <a:srgbClr val="1F2937"/>
                 </a:solidFill>
@@ -9191,8 +9150,8 @@
         </p:nvSpPr>
         <p:spPr>
           <a:xfrm>
-            <a:off x="457200" y="2834640"/>
-            <a:ext cx="640080" cy="731520"/>
+            <a:off x="457200" y="3383280"/>
+            <a:ext cx="822960" cy="822960"/>
           </a:xfrm>
           <a:prstGeom prst="rect">
             <a:avLst/>
@@ -9211,7 +9170,7 @@
               </a:spcAft>
             </a:pPr>
             <a:r>
-              <a:rPr sz="2000" b="1" i="0">
+              <a:rPr sz="2800" b="1" i="0">
                 <a:solidFill>
                   <a:srgbClr val="6B7280"/>
                 </a:solidFill>
@@ -9231,8 +9190,8 @@
         </p:nvSpPr>
         <p:spPr>
           <a:xfrm>
-            <a:off x="1188720" y="2880360"/>
-            <a:ext cx="10515600" cy="731520"/>
+            <a:off x="1371600" y="3429000"/>
+            <a:ext cx="10424160" cy="822960"/>
           </a:xfrm>
           <a:prstGeom prst="rect">
             <a:avLst/>
@@ -9251,7 +9210,7 @@
               </a:spcAft>
             </a:pPr>
             <a:r>
-              <a:rPr sz="1800" b="0" i="0">
+              <a:rPr sz="1900" b="0" i="0">
                 <a:solidFill>
                   <a:srgbClr val="1F2937"/>
                 </a:solidFill>
@@ -9271,8 +9230,8 @@
         </p:nvSpPr>
         <p:spPr>
           <a:xfrm>
-            <a:off x="457200" y="3611880"/>
-            <a:ext cx="640080" cy="731520"/>
+            <a:off x="457200" y="4343400"/>
+            <a:ext cx="822960" cy="822960"/>
           </a:xfrm>
           <a:prstGeom prst="rect">
             <a:avLst/>
@@ -9291,7 +9250,7 @@
               </a:spcAft>
             </a:pPr>
             <a:r>
-              <a:rPr sz="2000" b="1" i="0">
+              <a:rPr sz="2800" b="1" i="0">
                 <a:solidFill>
                   <a:srgbClr val="6B7280"/>
                 </a:solidFill>
@@ -9311,8 +9270,8 @@
         </p:nvSpPr>
         <p:spPr>
           <a:xfrm>
-            <a:off x="1188720" y="3657600"/>
-            <a:ext cx="10515600" cy="731520"/>
+            <a:off x="1371600" y="4389120"/>
+            <a:ext cx="10424160" cy="822960"/>
           </a:xfrm>
           <a:prstGeom prst="rect">
             <a:avLst/>
@@ -9331,7 +9290,7 @@
               </a:spcAft>
             </a:pPr>
             <a:r>
-              <a:rPr sz="1800" b="0" i="0">
+              <a:rPr sz="1900" b="0" i="0">
                 <a:solidFill>
                   <a:srgbClr val="1F2937"/>
                 </a:solidFill>
@@ -9351,8 +9310,8 @@
         </p:nvSpPr>
         <p:spPr>
           <a:xfrm>
-            <a:off x="457200" y="4389120"/>
-            <a:ext cx="640080" cy="731520"/>
+            <a:off x="457200" y="5303520"/>
+            <a:ext cx="822960" cy="822960"/>
           </a:xfrm>
           <a:prstGeom prst="rect">
             <a:avLst/>
@@ -9371,7 +9330,7 @@
               </a:spcAft>
             </a:pPr>
             <a:r>
-              <a:rPr sz="2000" b="1" i="0">
+              <a:rPr sz="2800" b="1" i="0">
                 <a:solidFill>
                   <a:srgbClr val="6B7280"/>
                 </a:solidFill>
@@ -9391,8 +9350,8 @@
         </p:nvSpPr>
         <p:spPr>
           <a:xfrm>
-            <a:off x="1188720" y="4434840"/>
-            <a:ext cx="10515600" cy="731520"/>
+            <a:off x="1371600" y="5349240"/>
+            <a:ext cx="10424160" cy="822960"/>
           </a:xfrm>
           <a:prstGeom prst="rect">
             <a:avLst/>
@@ -9411,7 +9370,7 @@
               </a:spcAft>
             </a:pPr>
             <a:r>
-              <a:rPr sz="1800" b="0" i="0">
+              <a:rPr sz="1900" b="0" i="0">
                 <a:solidFill>
                   <a:srgbClr val="1F2937"/>
                 </a:solidFill>
@@ -10258,7 +10217,7 @@
                 <a:latin typeface="Calibri"/>
                 <a:ea typeface="맑은 고딕"/>
               </a:rPr>
-              <a:t>▸ KV tensor 는 attention 입력으로 </a:t>
+              <a:t>▸ KV tensor 직접 필요 — </a:t>
             </a:r>
             <a:r>
               <a:rPr sz="1800" b="1" i="0">
@@ -10268,7 +10227,7 @@
                 <a:latin typeface="Calibri"/>
                 <a:ea typeface="맑은 고딕"/>
               </a:rPr>
-              <a:t>필요하지만 size 가 큼</a:t>
+              <a:t>그러나 size 가 큼</a:t>
             </a:r>
           </a:p>
           <a:p>
@@ -10501,8 +10460,8 @@
         </p:nvSpPr>
         <p:spPr>
           <a:xfrm>
-            <a:off x="457200" y="1188720"/>
-            <a:ext cx="5669280" cy="5120640"/>
+            <a:off x="457200" y="1280160"/>
+            <a:ext cx="5669280" cy="3108960"/>
           </a:xfrm>
           <a:prstGeom prst="rect">
             <a:avLst/>
@@ -10547,8 +10506,8 @@
         </p:nvSpPr>
         <p:spPr>
           <a:xfrm>
-            <a:off x="640080" y="1280160"/>
-            <a:ext cx="5303520" cy="4937760"/>
+            <a:off x="640080" y="1417320"/>
+            <a:ext cx="5303520" cy="2834640"/>
           </a:xfrm>
           <a:prstGeom prst="rect">
             <a:avLst/>
@@ -10601,7 +10560,7 @@
                 <a:latin typeface="Calibri"/>
                 <a:ea typeface="맑은 고딕"/>
               </a:rPr>
-              <a:t>Llama, Qwen, Bloom, OPT, Baichuan 등</a:t>
+              <a:t>Llama · Qwen · Bloom · OPT · Baichuan</a:t>
             </a:r>
           </a:p>
           <a:p>
@@ -10628,7 +10587,7 @@
                 <a:latin typeface="Calibri"/>
                 <a:ea typeface="맑은 고딕"/>
               </a:rPr>
-              <a:t>head 별 K, V 가 별도 → KV tensor가 큼</a:t>
+              <a:t>head 별 K, V 분리 → KV 가 큼</a:t>
             </a:r>
           </a:p>
           <a:p>
@@ -10655,7 +10614,7 @@
                 <a:latin typeface="Calibri"/>
                 <a:ea typeface="맑은 고딕"/>
               </a:rPr>
-              <a:t>Tensor 6 캐싱이 더 적은 공간으로 더 많은 compute를 절약</a:t>
+              <a:t>Tensor 6 캐싱 = 적은 공간 / 많은 compute 절약</a:t>
             </a:r>
           </a:p>
           <a:p>
@@ -10695,8 +10654,8 @@
         </p:nvSpPr>
         <p:spPr>
           <a:xfrm>
-            <a:off x="6309360" y="1188720"/>
-            <a:ext cx="5394960" cy="5120640"/>
+            <a:off x="6309360" y="1280160"/>
+            <a:ext cx="5394960" cy="3108960"/>
           </a:xfrm>
           <a:prstGeom prst="rect">
             <a:avLst/>
@@ -10741,8 +10700,8 @@
         </p:nvSpPr>
         <p:spPr>
           <a:xfrm>
-            <a:off x="6492240" y="1280160"/>
-            <a:ext cx="5029200" cy="4937760"/>
+            <a:off x="6492240" y="1417320"/>
+            <a:ext cx="5029200" cy="2834640"/>
           </a:xfrm>
           <a:prstGeom prst="rect">
             <a:avLst/>
@@ -14589,7 +14548,7 @@
         <p:spPr>
           <a:xfrm>
             <a:off x="457200" y="1188720"/>
-            <a:ext cx="5852160" cy="5120640"/>
+            <a:ext cx="5486400" cy="5120640"/>
           </a:xfrm>
           <a:prstGeom prst="rect">
             <a:avLst/>
@@ -16446,60 +16405,14 @@
       </p:sp>
       <p:sp>
         <p:nvSpPr>
-          <p:cNvPr id="6" name="Rectangle 5"/>
-          <p:cNvSpPr/>
-          <p:nvPr/>
-        </p:nvSpPr>
-        <p:spPr>
-          <a:xfrm>
-            <a:off x="457200" y="4937760"/>
-            <a:ext cx="11247120" cy="1463040"/>
-          </a:xfrm>
-          <a:prstGeom prst="rect">
-            <a:avLst/>
-          </a:prstGeom>
-          <a:solidFill>
-            <a:srgbClr val="FFFFFF"/>
-          </a:solidFill>
-          <a:ln w="6350">
-            <a:solidFill>
-              <a:srgbClr val="E5E7EB"/>
-            </a:solidFill>
-          </a:ln>
-          <a:effectLst/>
-        </p:spPr>
-        <p:style>
-          <a:lnRef idx="1">
-            <a:schemeClr val="accent1"/>
-          </a:lnRef>
-          <a:fillRef idx="3">
-            <a:schemeClr val="accent1"/>
-          </a:fillRef>
-          <a:effectRef idx="2">
-            <a:schemeClr val="accent1"/>
-          </a:effectRef>
-          <a:fontRef idx="minor">
-            <a:schemeClr val="lt1"/>
-          </a:fontRef>
-        </p:style>
-        <p:txBody>
-          <a:bodyPr rtlCol="0" anchor="ctr"/>
-          <a:lstStyle/>
-          <a:p>
-            <a:pPr algn="ctr"/>
-          </a:p>
-        </p:txBody>
-      </p:sp>
-      <p:sp>
-        <p:nvSpPr>
-          <p:cNvPr id="7" name="TextBox 6"/>
+          <p:cNvPr id="6" name="TextBox 5"/>
           <p:cNvSpPr txBox="1"/>
           <p:nvPr/>
         </p:nvSpPr>
         <p:spPr>
           <a:xfrm>
-            <a:off x="640080" y="5029200"/>
-            <a:ext cx="10972800" cy="1280160"/>
+            <a:off x="457200" y="5669280"/>
+            <a:ext cx="11247120" cy="640080"/>
           </a:xfrm>
           <a:prstGeom prst="rect">
             <a:avLst/>
@@ -16520,39 +16433,29 @@
             <a:r>
               <a:rPr sz="1800" b="0" i="0">
                 <a:solidFill>
-                  <a:srgbClr val="1F2937"/>
-                </a:solidFill>
-                <a:latin typeface="Calibri"/>
-                <a:ea typeface="맑은 고딕"/>
-              </a:rPr>
-              <a:t>이어지는 세 슬라이드에서 </a:t>
-            </a:r>
-            <a:r>
-              <a:rPr sz="1800" b="1" i="0">
+                  <a:srgbClr val="6B7280"/>
+                </a:solidFill>
+                <a:latin typeface="Calibri"/>
+                <a:ea typeface="맑은 고딕"/>
+              </a:rPr>
+              <a:t>이어지는 세 슬라이드 →  </a:t>
+            </a:r>
+            <a:r>
+              <a:rPr sz="2200" b="1" i="0">
                 <a:solidFill>
                   <a:srgbClr val="D9352A"/>
                 </a:solidFill>
                 <a:latin typeface="Calibri"/>
                 <a:ea typeface="맑은 고딕"/>
               </a:rPr>
-              <a:t>Observation 1 / 2 / 3</a:t>
-            </a:r>
-            <a:r>
-              <a:rPr sz="1800" b="0" i="0">
-                <a:solidFill>
-                  <a:srgbClr val="1F2937"/>
-                </a:solidFill>
-                <a:latin typeface="Calibri"/>
-                <a:ea typeface="맑은 고딕"/>
-              </a:rPr>
-              <a:t>을 차례로 살펴본다.</a:t>
-            </a:r>
-          </a:p>
-        </p:txBody>
-      </p:sp>
-      <p:sp>
-        <p:nvSpPr>
-          <p:cNvPr id="8" name="TextBox 7"/>
+              <a:t>Observation 1 · 2 · 3</a:t>
+            </a:r>
+          </a:p>
+        </p:txBody>
+      </p:sp>
+      <p:sp>
+        <p:nvSpPr>
+          <p:cNvPr id="7" name="TextBox 6"/>
           <p:cNvSpPr txBox="1"/>
           <p:nvPr/>
         </p:nvSpPr>
@@ -16791,7 +16694,7 @@
                 <a:latin typeface="Calibri"/>
                 <a:ea typeface="맑은 고딕"/>
               </a:rPr>
-              <a:t>사용자 평균 22.4 라운드 동안 KV 가 생존</a:t>
+              <a:t>22.4 라운드 동안 KV 생존</a:t>
             </a:r>
           </a:p>
           <a:p>
@@ -16845,7 +16748,7 @@
                 <a:latin typeface="Calibri"/>
                 <a:ea typeface="맑은 고딕"/>
               </a:rPr>
-              <a:t>OPT-13B · 30 users/min ≈ 480 GB (perf 200 GB)</a:t>
+              <a:t>30 users/min ≈ 480 GB &gt; perf 200 GB</a:t>
             </a:r>
           </a:p>
           <a:p>

</xml_diff>

<commit_message>
Insert worked-example slide showing answer-length → potential split
New slide 23 (right after Equation 2): a matplotlib chart of two users
sharing the same past distribution but receiving different answer
lengths. User A (20 tokens) keeps the small bucket and reaches
potential ≈ 0.79 → retain. User B (180 tokens) gets the lower bound
360 GB → small + P1..P4 truncated to 0 → potential ≈ 0.07 → evict.

- Add build/make_example_figure.py — registers Noto Sans CJK directly
  so Hangul renders correctly (avoids matplotlib font-cache miss)
- Add figures/example_alice_bob.png — the rendered chart
- Add slide_22b() in build/make_pptx.py; bump footer numbers 23..30 → 24..31
  and default total to 31

Helps Q&A on the trickiest point: why "answer is long" maps to
"truncate the *small* bucket" rather than the large one.
</commit_message>
<xml_diff>
--- a/Bidaw_seminar.pptx
+++ b/Bidaw_seminar.pptx
@@ -35,6 +35,7 @@
     <p:sldId id="283" r:id="rId34"/>
     <p:sldId id="284" r:id="rId35"/>
     <p:sldId id="285" r:id="rId36"/>
+    <p:sldId id="286" r:id="rId37"/>
   </p:sldIdLst>
   <p:sldSz cx="12191695" cy="6858000" type="screen4x3"/>
   <p:notesSz cx="6858000" cy="9144000"/>
@@ -10079,7 +10080,7 @@
                 <a:latin typeface="Calibri"/>
                 <a:ea typeface="맑은 고딕"/>
               </a:rPr>
-              <a:t>MECHANISM 3 / 3</a:t>
+              <a:t>MECHANISM 2 / 3</a:t>
             </a:r>
           </a:p>
           <a:p>
@@ -10096,14 +10097,14 @@
                 <a:latin typeface="Calibri"/>
                 <a:ea typeface="맑은 고딕"/>
               </a:rPr>
-              <a:t>Mechanism 3 — 어떤 tensor를 캐싱할 것인가</a:t>
+              <a:t>예시 — 두 사용자의 답변 길이에 따른 evict 결정</a:t>
             </a:r>
           </a:p>
         </p:txBody>
       </p:sp>
       <p:pic>
         <p:nvPicPr>
-          <p:cNvPr id="3" name="Picture 2" descr="figure_14.png"/>
+          <p:cNvPr id="3" name="Picture 2" descr="example_alice_bob.png"/>
           <p:cNvPicPr>
             <a:picLocks noChangeAspect="1"/>
           </p:cNvPicPr>
@@ -10117,8 +10118,8 @@
         </p:blipFill>
         <p:spPr>
           <a:xfrm>
-            <a:off x="457200" y="1188720"/>
-            <a:ext cx="6858000" cy="4059150"/>
+            <a:off x="1578207" y="1280160"/>
+            <a:ext cx="9005106" cy="4297680"/>
           </a:xfrm>
           <a:prstGeom prst="rect">
             <a:avLst/>
@@ -10133,8 +10134,8 @@
         </p:nvSpPr>
         <p:spPr>
           <a:xfrm>
-            <a:off x="457200" y="5293590"/>
-            <a:ext cx="6858000" cy="320040"/>
+            <a:off x="457200" y="5852160"/>
+            <a:ext cx="11247120" cy="640080"/>
           </a:xfrm>
           <a:prstGeom prst="rect">
             <a:avLst/>
@@ -10142,7 +10143,7 @@
           <a:noFill/>
         </p:spPr>
         <p:txBody>
-          <a:bodyPr wrap="square" lIns="45720" rIns="45720" tIns="18288" bIns="18288">
+          <a:bodyPr wrap="square" lIns="45720" rIns="45720" tIns="18288" bIns="18288" anchor="ctr">
             <a:spAutoFit/>
           </a:bodyPr>
           <a:lstStyle/>
@@ -10153,14 +10154,54 @@
               </a:spcAft>
             </a:pPr>
             <a:r>
-              <a:rPr sz="1000" b="0" i="1">
-                <a:solidFill>
-                  <a:srgbClr val="6B7280"/>
-                </a:solidFill>
-                <a:latin typeface="Calibri"/>
-                <a:ea typeface="맑은 고딕"/>
-              </a:rPr>
-              <a:t>Figure 14. (a) tensor별 size와 절약 가능한 GFLOPs, (b) cost efficiency</a:t>
+              <a:rPr sz="1600" b="0" i="0">
+                <a:solidFill>
+                  <a:srgbClr val="1F2937"/>
+                </a:solidFill>
+                <a:latin typeface="Calibri"/>
+                <a:ea typeface="맑은 고딕"/>
+              </a:rPr>
+              <a:t>같은 과거 분포라도 </a:t>
+            </a:r>
+            <a:r>
+              <a:rPr sz="1600" b="1" i="0">
+                <a:solidFill>
+                  <a:srgbClr val="D9352A"/>
+                </a:solidFill>
+                <a:latin typeface="Calibri"/>
+                <a:ea typeface="맑은 고딕"/>
+              </a:rPr>
+              <a:t>직전 답변 길이 한 가지</a:t>
+            </a:r>
+            <a:r>
+              <a:rPr sz="1600" b="0" i="0">
+                <a:solidFill>
+                  <a:srgbClr val="1F2937"/>
+                </a:solidFill>
+                <a:latin typeface="Calibri"/>
+                <a:ea typeface="맑은 고딕"/>
+              </a:rPr>
+              <a:t>가 potential 을 </a:t>
+            </a:r>
+            <a:r>
+              <a:rPr sz="1600" b="1" i="0">
+                <a:solidFill>
+                  <a:srgbClr val="D9352A"/>
+                </a:solidFill>
+                <a:latin typeface="Calibri"/>
+                <a:ea typeface="맑은 고딕"/>
+              </a:rPr>
+              <a:t>0.79 ↔ 0.07</a:t>
+            </a:r>
+            <a:r>
+              <a:rPr sz="1600" b="0" i="0">
+                <a:solidFill>
+                  <a:srgbClr val="1F2937"/>
+                </a:solidFill>
+                <a:latin typeface="Calibri"/>
+                <a:ea typeface="맑은 고딕"/>
+              </a:rPr>
+              <a:t>로 가른다</a:t>
             </a:r>
           </a:p>
         </p:txBody>
@@ -10168,178 +10209,6 @@
       <p:sp>
         <p:nvSpPr>
           <p:cNvPr id="5" name="TextBox 4"/>
-          <p:cNvSpPr txBox="1"/>
-          <p:nvPr/>
-        </p:nvSpPr>
-        <p:spPr>
-          <a:xfrm>
-            <a:off x="7589520" y="1280160"/>
-            <a:ext cx="4389120" cy="5029200"/>
-          </a:xfrm>
-          <a:prstGeom prst="rect">
-            <a:avLst/>
-          </a:prstGeom>
-          <a:noFill/>
-        </p:spPr>
-        <p:txBody>
-          <a:bodyPr wrap="square" lIns="45720" rIns="45720" tIns="18288" bIns="18288">
-            <a:spAutoFit/>
-          </a:bodyPr>
-          <a:lstStyle/>
-          <a:p>
-            <a:pPr algn="l">
-              <a:spcAft>
-                <a:spcPts val="400"/>
-              </a:spcAft>
-            </a:pPr>
-            <a:r>
-              <a:rPr sz="1800" b="1" i="0">
-                <a:solidFill>
-                  <a:srgbClr val="1F2937"/>
-                </a:solidFill>
-                <a:latin typeface="Calibri"/>
-                <a:ea typeface="맑은 고딕"/>
-              </a:rPr>
-              <a:t>왜 KV tensor가 최선이 아닌가</a:t>
-            </a:r>
-          </a:p>
-          <a:p>
-            <a:pPr algn="l">
-              <a:spcAft>
-                <a:spcPts val="600"/>
-              </a:spcAft>
-            </a:pPr>
-            <a:r>
-              <a:rPr sz="1800" b="0" i="0">
-                <a:solidFill>
-                  <a:srgbClr val="1F2937"/>
-                </a:solidFill>
-                <a:latin typeface="Calibri"/>
-                <a:ea typeface="맑은 고딕"/>
-              </a:rPr>
-              <a:t>▸ KV tensor가 직접 필요하지만 </a:t>
-            </a:r>
-            <a:r>
-              <a:rPr sz="1800" b="1" i="0">
-                <a:solidFill>
-                  <a:srgbClr val="1F2937"/>
-                </a:solidFill>
-                <a:latin typeface="Calibri"/>
-                <a:ea typeface="맑은 고딕"/>
-              </a:rPr>
-              <a:t>size가 크다</a:t>
-            </a:r>
-          </a:p>
-          <a:p>
-            <a:pPr algn="l">
-              <a:spcAft>
-                <a:spcPts val="200"/>
-              </a:spcAft>
-            </a:pPr>
-            <a:r>
-              <a:rPr sz="1800" b="1" i="0">
-                <a:solidFill>
-                  <a:srgbClr val="1F2937"/>
-                </a:solidFill>
-                <a:latin typeface="Calibri"/>
-                <a:ea typeface="맑은 고딕"/>
-              </a:rPr>
-              <a:t>Cost Efficiency</a:t>
-            </a:r>
-          </a:p>
-          <a:p>
-            <a:pPr algn="l">
-              <a:spcAft>
-                <a:spcPts val="800"/>
-              </a:spcAft>
-            </a:pPr>
-            <a:r>
-              <a:rPr sz="1800" b="0" i="0">
-                <a:solidFill>
-                  <a:srgbClr val="1F2937"/>
-                </a:solidFill>
-                <a:latin typeface="Consolas"/>
-                <a:ea typeface="맑은 고딕"/>
-              </a:rPr>
-              <a:t>= Saved compute / Required space  (GFLOPs/MB)</a:t>
-            </a:r>
-          </a:p>
-          <a:p>
-            <a:pPr algn="l">
-              <a:spcAft>
-                <a:spcPts val="200"/>
-              </a:spcAft>
-            </a:pPr>
-            <a:r>
-              <a:rPr sz="1800" b="1" i="0">
-                <a:solidFill>
-                  <a:srgbClr val="D9352A"/>
-                </a:solidFill>
-                <a:latin typeface="Calibri"/>
-                <a:ea typeface="맑은 고딕"/>
-              </a:rPr>
-              <a:t>Tensor 6 (정규화된 activation)</a:t>
-            </a:r>
-          </a:p>
-          <a:p>
-            <a:pPr algn="l">
-              <a:spcAft>
-                <a:spcPts val="200"/>
-              </a:spcAft>
-            </a:pPr>
-            <a:r>
-              <a:rPr sz="1800" b="0" i="0">
-                <a:solidFill>
-                  <a:srgbClr val="1F2937"/>
-                </a:solidFill>
-                <a:latin typeface="Calibri"/>
-                <a:ea typeface="맑은 고딕"/>
-              </a:rPr>
-              <a:t>▸ 51 GFLOPs/MB — KV tensor(30.5)의 1.67배</a:t>
-            </a:r>
-          </a:p>
-          <a:p>
-            <a:pPr algn="l">
-              <a:spcAft>
-                <a:spcPts val="400"/>
-              </a:spcAft>
-            </a:pPr>
-            <a:r>
-              <a:rPr sz="1800" b="0" i="0">
-                <a:solidFill>
-                  <a:srgbClr val="1F2937"/>
-                </a:solidFill>
-                <a:latin typeface="Calibri"/>
-                <a:ea typeface="맑은 고딕"/>
-              </a:rPr>
-              <a:t>▸ KV tensor로 변환하는 데 </a:t>
-            </a:r>
-            <a:r>
-              <a:rPr sz="1800" b="1" i="0">
-                <a:solidFill>
-                  <a:srgbClr val="1F2937"/>
-                </a:solidFill>
-                <a:latin typeface="Calibri"/>
-                <a:ea typeface="맑은 고딕"/>
-              </a:rPr>
-              <a:t>GPU 1 step</a:t>
-            </a:r>
-            <a:r>
-              <a:rPr sz="1800" b="0" i="0">
-                <a:solidFill>
-                  <a:srgbClr val="1F2937"/>
-                </a:solidFill>
-                <a:latin typeface="Calibri"/>
-                <a:ea typeface="맑은 고딕"/>
-              </a:rPr>
-              <a:t>이면 충분</a:t>
-            </a:r>
-          </a:p>
-        </p:txBody>
-      </p:sp>
-      <p:sp>
-        <p:nvSpPr>
-          <p:cNvPr id="6" name="TextBox 5"/>
           <p:cNvSpPr txBox="1"/>
           <p:nvPr/>
         </p:nvSpPr>
@@ -10447,57 +10316,35 @@
                 <a:latin typeface="Calibri"/>
                 <a:ea typeface="맑은 고딕"/>
               </a:rPr>
-              <a:t>Storage-efficient tensor caching — 적용 범위</a:t>
-            </a:r>
-          </a:p>
-        </p:txBody>
-      </p:sp>
-      <p:sp>
-        <p:nvSpPr>
-          <p:cNvPr id="3" name="Rectangle 2"/>
-          <p:cNvSpPr/>
-          <p:nvPr/>
-        </p:nvSpPr>
-        <p:spPr>
-          <a:xfrm>
-            <a:off x="457200" y="1280160"/>
-            <a:ext cx="5669280" cy="3108960"/>
-          </a:xfrm>
-          <a:prstGeom prst="rect">
-            <a:avLst/>
-          </a:prstGeom>
-          <a:solidFill>
-            <a:srgbClr val="FFFFFF"/>
-          </a:solidFill>
-          <a:ln w="6350">
-            <a:solidFill>
-              <a:srgbClr val="E5E7EB"/>
-            </a:solidFill>
-          </a:ln>
-          <a:effectLst/>
-        </p:spPr>
-        <p:style>
-          <a:lnRef idx="1">
-            <a:schemeClr val="accent1"/>
-          </a:lnRef>
-          <a:fillRef idx="3">
-            <a:schemeClr val="accent1"/>
-          </a:fillRef>
-          <a:effectRef idx="2">
-            <a:schemeClr val="accent1"/>
-          </a:effectRef>
-          <a:fontRef idx="minor">
-            <a:schemeClr val="lt1"/>
-          </a:fontRef>
-        </p:style>
-        <p:txBody>
-          <a:bodyPr rtlCol="0" anchor="ctr"/>
-          <a:lstStyle/>
-          <a:p>
-            <a:pPr algn="ctr"/>
-          </a:p>
-        </p:txBody>
-      </p:sp>
+              <a:t>Mechanism 3 — 어떤 tensor를 캐싱할 것인가</a:t>
+            </a:r>
+          </a:p>
+        </p:txBody>
+      </p:sp>
+      <p:pic>
+        <p:nvPicPr>
+          <p:cNvPr id="3" name="Picture 2" descr="figure_14.png"/>
+          <p:cNvPicPr>
+            <a:picLocks noChangeAspect="1"/>
+          </p:cNvPicPr>
+          <p:nvPr/>
+        </p:nvPicPr>
+        <p:blipFill>
+          <a:blip r:embed="rId2"/>
+          <a:stretch>
+            <a:fillRect/>
+          </a:stretch>
+        </p:blipFill>
+        <p:spPr>
+          <a:xfrm>
+            <a:off x="457200" y="1188720"/>
+            <a:ext cx="6858000" cy="4059150"/>
+          </a:xfrm>
+          <a:prstGeom prst="rect">
+            <a:avLst/>
+          </a:prstGeom>
+        </p:spPr>
+      </p:pic>
       <p:sp>
         <p:nvSpPr>
           <p:cNvPr id="4" name="TextBox 3"/>
@@ -10506,8 +10353,8 @@
         </p:nvSpPr>
         <p:spPr>
           <a:xfrm>
-            <a:off x="640080" y="1417320"/>
-            <a:ext cx="5303520" cy="2834640"/>
+            <a:off x="457200" y="5293590"/>
+            <a:ext cx="6858000" cy="320040"/>
           </a:xfrm>
           <a:prstGeom prst="rect">
             <a:avLst/>
@@ -10520,188 +10367,34 @@
           </a:bodyPr>
           <a:lstStyle/>
           <a:p>
-            <a:pPr algn="l">
-              <a:spcAft>
-                <a:spcPts val="400"/>
-              </a:spcAft>
-            </a:pPr>
-            <a:r>
-              <a:rPr sz="2000" b="1" i="0">
-                <a:solidFill>
-                  <a:srgbClr val="1F2937"/>
-                </a:solidFill>
-                <a:latin typeface="Calibri"/>
-                <a:ea typeface="맑은 고딕"/>
-              </a:rPr>
-              <a:t>MHA 기반 모델</a:t>
-            </a:r>
-          </a:p>
-          <a:p>
-            <a:pPr algn="l">
-              <a:spcAft>
-                <a:spcPts val="400"/>
-              </a:spcAft>
-            </a:pPr>
-            <a:r>
-              <a:rPr sz="1800" b="1" i="0">
-                <a:solidFill>
-                  <a:srgbClr val="D9352A"/>
-                </a:solidFill>
-                <a:latin typeface="Calibri"/>
-                <a:ea typeface="맑은 고딕"/>
-              </a:rPr>
-              <a:t>▸ </a:t>
-            </a:r>
-            <a:r>
-              <a:rPr sz="1800" b="0" i="0">
-                <a:solidFill>
-                  <a:srgbClr val="1F2937"/>
-                </a:solidFill>
-                <a:latin typeface="Calibri"/>
-                <a:ea typeface="맑은 고딕"/>
-              </a:rPr>
-              <a:t>Llama · Qwen · Bloom · OPT · Baichuan</a:t>
-            </a:r>
-          </a:p>
-          <a:p>
-            <a:pPr algn="l">
-              <a:spcAft>
-                <a:spcPts val="400"/>
-              </a:spcAft>
-            </a:pPr>
-            <a:r>
-              <a:rPr sz="1800" b="1" i="0">
-                <a:solidFill>
-                  <a:srgbClr val="D9352A"/>
-                </a:solidFill>
-                <a:latin typeface="Calibri"/>
-                <a:ea typeface="맑은 고딕"/>
-              </a:rPr>
-              <a:t>▸ </a:t>
-            </a:r>
-            <a:r>
-              <a:rPr sz="1800" b="0" i="0">
-                <a:solidFill>
-                  <a:srgbClr val="1F2937"/>
-                </a:solidFill>
-                <a:latin typeface="Calibri"/>
-                <a:ea typeface="맑은 고딕"/>
-              </a:rPr>
-              <a:t>head마다 K, V가 분리 → KV가 큼</a:t>
-            </a:r>
-          </a:p>
-          <a:p>
-            <a:pPr algn="l">
-              <a:spcAft>
-                <a:spcPts val="400"/>
-              </a:spcAft>
-            </a:pPr>
-            <a:r>
-              <a:rPr sz="1800" b="1" i="0">
-                <a:solidFill>
-                  <a:srgbClr val="D9352A"/>
-                </a:solidFill>
-                <a:latin typeface="Calibri"/>
-                <a:ea typeface="맑은 고딕"/>
-              </a:rPr>
-              <a:t>▸ </a:t>
-            </a:r>
-            <a:r>
-              <a:rPr sz="1800" b="0" i="0">
-                <a:solidFill>
-                  <a:srgbClr val="1F2937"/>
-                </a:solidFill>
-                <a:latin typeface="Calibri"/>
-                <a:ea typeface="맑은 고딕"/>
-              </a:rPr>
-              <a:t>tensor 6 캐싱이 적은 공간으로 많은 compute를 절약</a:t>
-            </a:r>
-          </a:p>
-          <a:p>
-            <a:pPr algn="l">
-              <a:spcAft>
-                <a:spcPts val="400"/>
-              </a:spcAft>
-            </a:pPr>
-            <a:r>
-              <a:rPr sz="1800" b="0" i="0">
-                <a:solidFill>
-                  <a:srgbClr val="1F2937"/>
-                </a:solidFill>
-                <a:latin typeface="Calibri"/>
-                <a:ea typeface="맑은 고딕"/>
-              </a:rPr>
-              <a:t>→ Bidaw는 </a:t>
-            </a:r>
-            <a:r>
-              <a:rPr sz="1800" b="1" i="0">
-                <a:solidFill>
-                  <a:srgbClr val="D9352A"/>
-                </a:solidFill>
-                <a:latin typeface="Calibri"/>
-                <a:ea typeface="맑은 고딕"/>
-              </a:rPr>
-              <a:t>tensor 6를 캐싱</a:t>
-            </a:r>
-          </a:p>
-        </p:txBody>
-      </p:sp>
-      <p:sp>
-        <p:nvSpPr>
-          <p:cNvPr id="5" name="Rectangle 4"/>
-          <p:cNvSpPr/>
-          <p:nvPr/>
-        </p:nvSpPr>
-        <p:spPr>
-          <a:xfrm>
-            <a:off x="6309360" y="1280160"/>
-            <a:ext cx="5394960" cy="3108960"/>
-          </a:xfrm>
-          <a:prstGeom prst="rect">
-            <a:avLst/>
-          </a:prstGeom>
-          <a:solidFill>
-            <a:srgbClr val="FFFFFF"/>
-          </a:solidFill>
-          <a:ln w="6350">
-            <a:solidFill>
-              <a:srgbClr val="E5E7EB"/>
-            </a:solidFill>
-          </a:ln>
-          <a:effectLst/>
-        </p:spPr>
-        <p:style>
-          <a:lnRef idx="1">
-            <a:schemeClr val="accent1"/>
-          </a:lnRef>
-          <a:fillRef idx="3">
-            <a:schemeClr val="accent1"/>
-          </a:fillRef>
-          <a:effectRef idx="2">
-            <a:schemeClr val="accent1"/>
-          </a:effectRef>
-          <a:fontRef idx="minor">
-            <a:schemeClr val="lt1"/>
-          </a:fontRef>
-        </p:style>
-        <p:txBody>
-          <a:bodyPr rtlCol="0" anchor="ctr"/>
-          <a:lstStyle/>
-          <a:p>
-            <a:pPr algn="ctr"/>
-          </a:p>
-        </p:txBody>
-      </p:sp>
-      <p:sp>
-        <p:nvSpPr>
-          <p:cNvPr id="6" name="TextBox 5"/>
+            <a:pPr algn="ctr">
+              <a:spcAft>
+                <a:spcPts val="400"/>
+              </a:spcAft>
+            </a:pPr>
+            <a:r>
+              <a:rPr sz="1000" b="0" i="1">
+                <a:solidFill>
+                  <a:srgbClr val="6B7280"/>
+                </a:solidFill>
+                <a:latin typeface="Calibri"/>
+                <a:ea typeface="맑은 고딕"/>
+              </a:rPr>
+              <a:t>Figure 14. (a) tensor별 size와 절약 가능한 GFLOPs, (b) cost efficiency</a:t>
+            </a:r>
+          </a:p>
+        </p:txBody>
+      </p:sp>
+      <p:sp>
+        <p:nvSpPr>
+          <p:cNvPr id="5" name="TextBox 4"/>
           <p:cNvSpPr txBox="1"/>
           <p:nvPr/>
         </p:nvSpPr>
         <p:spPr>
           <a:xfrm>
-            <a:off x="6492240" y="1417320"/>
-            <a:ext cx="5029200" cy="2834640"/>
+            <a:off x="7589520" y="1280160"/>
+            <a:ext cx="4389120" cy="5029200"/>
           </a:xfrm>
           <a:prstGeom prst="rect">
             <a:avLst/>
@@ -10720,32 +10413,100 @@
               </a:spcAft>
             </a:pPr>
             <a:r>
-              <a:rPr sz="2000" b="1" i="0">
-                <a:solidFill>
-                  <a:srgbClr val="1F2937"/>
-                </a:solidFill>
-                <a:latin typeface="Calibri"/>
-                <a:ea typeface="맑은 고딕"/>
-              </a:rPr>
-              <a:t>GQA 기반 모델</a:t>
-            </a:r>
-          </a:p>
-          <a:p>
-            <a:pPr algn="l">
-              <a:spcAft>
-                <a:spcPts val="400"/>
-              </a:spcAft>
-            </a:pPr>
-            <a:r>
               <a:rPr sz="1800" b="1" i="0">
                 <a:solidFill>
+                  <a:srgbClr val="1F2937"/>
+                </a:solidFill>
+                <a:latin typeface="Calibri"/>
+                <a:ea typeface="맑은 고딕"/>
+              </a:rPr>
+              <a:t>왜 KV tensor가 최선이 아닌가</a:t>
+            </a:r>
+          </a:p>
+          <a:p>
+            <a:pPr algn="l">
+              <a:spcAft>
+                <a:spcPts val="600"/>
+              </a:spcAft>
+            </a:pPr>
+            <a:r>
+              <a:rPr sz="1800" b="0" i="0">
+                <a:solidFill>
+                  <a:srgbClr val="1F2937"/>
+                </a:solidFill>
+                <a:latin typeface="Calibri"/>
+                <a:ea typeface="맑은 고딕"/>
+              </a:rPr>
+              <a:t>▸ KV tensor가 직접 필요하지만 </a:t>
+            </a:r>
+            <a:r>
+              <a:rPr sz="1800" b="1" i="0">
+                <a:solidFill>
+                  <a:srgbClr val="1F2937"/>
+                </a:solidFill>
+                <a:latin typeface="Calibri"/>
+                <a:ea typeface="맑은 고딕"/>
+              </a:rPr>
+              <a:t>size가 크다</a:t>
+            </a:r>
+          </a:p>
+          <a:p>
+            <a:pPr algn="l">
+              <a:spcAft>
+                <a:spcPts val="200"/>
+              </a:spcAft>
+            </a:pPr>
+            <a:r>
+              <a:rPr sz="1800" b="1" i="0">
+                <a:solidFill>
+                  <a:srgbClr val="1F2937"/>
+                </a:solidFill>
+                <a:latin typeface="Calibri"/>
+                <a:ea typeface="맑은 고딕"/>
+              </a:rPr>
+              <a:t>Cost Efficiency</a:t>
+            </a:r>
+          </a:p>
+          <a:p>
+            <a:pPr algn="l">
+              <a:spcAft>
+                <a:spcPts val="800"/>
+              </a:spcAft>
+            </a:pPr>
+            <a:r>
+              <a:rPr sz="1800" b="0" i="0">
+                <a:solidFill>
+                  <a:srgbClr val="1F2937"/>
+                </a:solidFill>
+                <a:latin typeface="Consolas"/>
+                <a:ea typeface="맑은 고딕"/>
+              </a:rPr>
+              <a:t>= Saved compute / Required space  (GFLOPs/MB)</a:t>
+            </a:r>
+          </a:p>
+          <a:p>
+            <a:pPr algn="l">
+              <a:spcAft>
+                <a:spcPts val="200"/>
+              </a:spcAft>
+            </a:pPr>
+            <a:r>
+              <a:rPr sz="1800" b="1" i="0">
+                <a:solidFill>
                   <a:srgbClr val="D9352A"/>
                 </a:solidFill>
                 <a:latin typeface="Calibri"/>
                 <a:ea typeface="맑은 고딕"/>
               </a:rPr>
-              <a:t>▸ </a:t>
-            </a:r>
+              <a:t>Tensor 6 (정규화된 activation)</a:t>
+            </a:r>
+          </a:p>
+          <a:p>
+            <a:pPr algn="l">
+              <a:spcAft>
+                <a:spcPts val="200"/>
+              </a:spcAft>
+            </a:pPr>
             <a:r>
               <a:rPr sz="1800" b="0" i="0">
                 <a:solidFill>
@@ -10754,24 +10515,34 @@
                 <a:latin typeface="Calibri"/>
                 <a:ea typeface="맑은 고딕"/>
               </a:rPr>
-              <a:t>여러 query head가 K, V를 공유 → KV tensor 자체가 작음</a:t>
-            </a:r>
-          </a:p>
-          <a:p>
-            <a:pPr algn="l">
-              <a:spcAft>
-                <a:spcPts val="400"/>
-              </a:spcAft>
-            </a:pPr>
+              <a:t>▸ 51 GFLOPs/MB — KV tensor(30.5)의 1.67배</a:t>
+            </a:r>
+          </a:p>
+          <a:p>
+            <a:pPr algn="l">
+              <a:spcAft>
+                <a:spcPts val="400"/>
+              </a:spcAft>
+            </a:pPr>
+            <a:r>
+              <a:rPr sz="1800" b="0" i="0">
+                <a:solidFill>
+                  <a:srgbClr val="1F2937"/>
+                </a:solidFill>
+                <a:latin typeface="Calibri"/>
+                <a:ea typeface="맑은 고딕"/>
+              </a:rPr>
+              <a:t>▸ KV tensor로 변환하는 데 </a:t>
+            </a:r>
             <a:r>
               <a:rPr sz="1800" b="1" i="0">
                 <a:solidFill>
-                  <a:srgbClr val="D9352A"/>
-                </a:solidFill>
-                <a:latin typeface="Calibri"/>
-                <a:ea typeface="맑은 고딕"/>
-              </a:rPr>
-              <a:t>▸ </a:t>
+                  <a:srgbClr val="1F2937"/>
+                </a:solidFill>
+                <a:latin typeface="Calibri"/>
+                <a:ea typeface="맑은 고딕"/>
+              </a:rPr>
+              <a:t>GPU 1 step</a:t>
             </a:r>
             <a:r>
               <a:rPr sz="1800" b="0" i="0">
@@ -10781,41 +10552,14 @@
                 <a:latin typeface="Calibri"/>
                 <a:ea typeface="맑은 고딕"/>
               </a:rPr>
-              <a:t>tensor 6의 cost-efficiency 이점이 사라짐</a:t>
-            </a:r>
-          </a:p>
-          <a:p>
-            <a:pPr algn="l">
-              <a:spcAft>
-                <a:spcPts val="400"/>
-              </a:spcAft>
-            </a:pPr>
-            <a:r>
-              <a:rPr sz="1800" b="0" i="0">
-                <a:solidFill>
-                  <a:srgbClr val="1F2937"/>
-                </a:solidFill>
-                <a:latin typeface="Calibri"/>
-                <a:ea typeface="맑은 고딕"/>
-              </a:rPr>
-              <a:t>→ GQA에서는 </a:t>
-            </a:r>
-            <a:r>
-              <a:rPr sz="1800" b="1" i="0">
-                <a:solidFill>
-                  <a:srgbClr val="D9352A"/>
-                </a:solidFill>
-                <a:latin typeface="Calibri"/>
-                <a:ea typeface="맑은 고딕"/>
-              </a:rPr>
-              <a:t>KV tensor를 그대로 캐싱</a:t>
-            </a:r>
-          </a:p>
-        </p:txBody>
-      </p:sp>
-      <p:sp>
-        <p:nvSpPr>
-          <p:cNvPr id="7" name="TextBox 6"/>
+              <a:t>이면 충분</a:t>
+            </a:r>
+          </a:p>
+        </p:txBody>
+      </p:sp>
+      <p:sp>
+        <p:nvSpPr>
+          <p:cNvPr id="6" name="TextBox 5"/>
           <p:cNvSpPr txBox="1"/>
           <p:nvPr/>
         </p:nvSpPr>
@@ -10906,7 +10650,7 @@
                 <a:latin typeface="Calibri"/>
                 <a:ea typeface="맑은 고딕"/>
               </a:rPr>
-              <a:t>IMPLEMENTATION</a:t>
+              <a:t>MECHANISM 3 / 3</a:t>
             </a:r>
           </a:p>
           <a:p>
@@ -10923,7 +10667,7 @@
                 <a:latin typeface="Calibri"/>
                 <a:ea typeface="맑은 고딕"/>
               </a:rPr>
-              <a:t>구현 노트 — vLLM 위에 얹는 네 가지 기법</a:t>
+              <a:t>Storage-efficient tensor caching — 적용 범위</a:t>
             </a:r>
           </a:p>
         </p:txBody>
@@ -10936,17 +10680,19 @@
         </p:nvSpPr>
         <p:spPr>
           <a:xfrm>
-            <a:off x="457200" y="1188720"/>
-            <a:ext cx="164592" cy="1005840"/>
+            <a:off x="457200" y="1280160"/>
+            <a:ext cx="5669280" cy="3108960"/>
           </a:xfrm>
           <a:prstGeom prst="rect">
             <a:avLst/>
           </a:prstGeom>
           <a:solidFill>
-            <a:srgbClr val="D9352A"/>
+            <a:srgbClr val="FFFFFF"/>
           </a:solidFill>
-          <a:ln>
-            <a:noFill/>
+          <a:ln w="6350">
+            <a:solidFill>
+              <a:srgbClr val="E5E7EB"/>
+            </a:solidFill>
           </a:ln>
           <a:effectLst/>
         </p:spPr>
@@ -10980,8 +10726,8 @@
         </p:nvSpPr>
         <p:spPr>
           <a:xfrm>
-            <a:off x="822960" y="1234440"/>
-            <a:ext cx="10789920" cy="1005840"/>
+            <a:off x="640080" y="1417320"/>
+            <a:ext cx="5303520" cy="2834640"/>
           </a:xfrm>
           <a:prstGeom prst="rect">
             <a:avLst/>
@@ -11007,15 +10753,25 @@
                 <a:latin typeface="Calibri"/>
                 <a:ea typeface="맑은 고딕"/>
               </a:rPr>
-              <a:t>Continuous batching</a:t>
-            </a:r>
-          </a:p>
-          <a:p>
-            <a:pPr algn="l">
-              <a:spcAft>
-                <a:spcPts val="400"/>
-              </a:spcAft>
-            </a:pPr>
+              <a:t>MHA 기반 모델</a:t>
+            </a:r>
+          </a:p>
+          <a:p>
+            <a:pPr algn="l">
+              <a:spcAft>
+                <a:spcPts val="400"/>
+              </a:spcAft>
+            </a:pPr>
+            <a:r>
+              <a:rPr sz="1800" b="1" i="0">
+                <a:solidFill>
+                  <a:srgbClr val="D9352A"/>
+                </a:solidFill>
+                <a:latin typeface="Calibri"/>
+                <a:ea typeface="맑은 고딕"/>
+              </a:rPr>
+              <a:t>▸ </a:t>
+            </a:r>
             <a:r>
               <a:rPr sz="1800" b="0" i="0">
                 <a:solidFill>
@@ -11024,7 +10780,88 @@
                 <a:latin typeface="Calibri"/>
                 <a:ea typeface="맑은 고딕"/>
               </a:rPr>
-              <a:t>일찍 끝난 요청을 배치에서 바로 빼고 새 요청을 곧장 받아들임 (ORCA 계열과 호환)</a:t>
+              <a:t>Llama · Qwen · Bloom · OPT · Baichuan</a:t>
+            </a:r>
+          </a:p>
+          <a:p>
+            <a:pPr algn="l">
+              <a:spcAft>
+                <a:spcPts val="400"/>
+              </a:spcAft>
+            </a:pPr>
+            <a:r>
+              <a:rPr sz="1800" b="1" i="0">
+                <a:solidFill>
+                  <a:srgbClr val="D9352A"/>
+                </a:solidFill>
+                <a:latin typeface="Calibri"/>
+                <a:ea typeface="맑은 고딕"/>
+              </a:rPr>
+              <a:t>▸ </a:t>
+            </a:r>
+            <a:r>
+              <a:rPr sz="1800" b="0" i="0">
+                <a:solidFill>
+                  <a:srgbClr val="1F2937"/>
+                </a:solidFill>
+                <a:latin typeface="Calibri"/>
+                <a:ea typeface="맑은 고딕"/>
+              </a:rPr>
+              <a:t>head마다 K, V가 분리 → KV가 큼</a:t>
+            </a:r>
+          </a:p>
+          <a:p>
+            <a:pPr algn="l">
+              <a:spcAft>
+                <a:spcPts val="400"/>
+              </a:spcAft>
+            </a:pPr>
+            <a:r>
+              <a:rPr sz="1800" b="1" i="0">
+                <a:solidFill>
+                  <a:srgbClr val="D9352A"/>
+                </a:solidFill>
+                <a:latin typeface="Calibri"/>
+                <a:ea typeface="맑은 고딕"/>
+              </a:rPr>
+              <a:t>▸ </a:t>
+            </a:r>
+            <a:r>
+              <a:rPr sz="1800" b="0" i="0">
+                <a:solidFill>
+                  <a:srgbClr val="1F2937"/>
+                </a:solidFill>
+                <a:latin typeface="Calibri"/>
+                <a:ea typeface="맑은 고딕"/>
+              </a:rPr>
+              <a:t>tensor 6 캐싱이 적은 공간으로 많은 compute를 절약</a:t>
+            </a:r>
+          </a:p>
+          <a:p>
+            <a:pPr algn="l">
+              <a:spcAft>
+                <a:spcPts val="400"/>
+              </a:spcAft>
+            </a:pPr>
+            <a:r>
+              <a:rPr sz="1800" b="0" i="0">
+                <a:solidFill>
+                  <a:srgbClr val="1F2937"/>
+                </a:solidFill>
+                <a:latin typeface="Calibri"/>
+                <a:ea typeface="맑은 고딕"/>
+              </a:rPr>
+              <a:t>→ Bidaw는 </a:t>
+            </a:r>
+            <a:r>
+              <a:rPr sz="1800" b="1" i="0">
+                <a:solidFill>
+                  <a:srgbClr val="D9352A"/>
+                </a:solidFill>
+                <a:latin typeface="Calibri"/>
+                <a:ea typeface="맑은 고딕"/>
+              </a:rPr>
+              <a:t>tensor 6를 캐싱</a:t>
             </a:r>
           </a:p>
         </p:txBody>
@@ -11037,17 +10874,19 @@
         </p:nvSpPr>
         <p:spPr>
           <a:xfrm>
-            <a:off x="457200" y="2468880"/>
-            <a:ext cx="164592" cy="1005840"/>
+            <a:off x="6309360" y="1280160"/>
+            <a:ext cx="5394960" cy="3108960"/>
           </a:xfrm>
           <a:prstGeom prst="rect">
             <a:avLst/>
           </a:prstGeom>
           <a:solidFill>
-            <a:srgbClr val="D9352A"/>
+            <a:srgbClr val="FFFFFF"/>
           </a:solidFill>
-          <a:ln>
-            <a:noFill/>
+          <a:ln w="6350">
+            <a:solidFill>
+              <a:srgbClr val="E5E7EB"/>
+            </a:solidFill>
           </a:ln>
           <a:effectLst/>
         </p:spPr>
@@ -11081,8 +10920,8 @@
         </p:nvSpPr>
         <p:spPr>
           <a:xfrm>
-            <a:off x="822960" y="2514600"/>
-            <a:ext cx="10789920" cy="1005840"/>
+            <a:off x="6492240" y="1417320"/>
+            <a:ext cx="5029200" cy="2834640"/>
           </a:xfrm>
           <a:prstGeom prst="rect">
             <a:avLst/>
@@ -11108,15 +10947,25 @@
                 <a:latin typeface="Calibri"/>
                 <a:ea typeface="맑은 고딕"/>
               </a:rPr>
-              <a:t>Mix-grained PagedAttention</a:t>
-            </a:r>
-          </a:p>
-          <a:p>
-            <a:pPr algn="l">
-              <a:spcAft>
-                <a:spcPts val="400"/>
-              </a:spcAft>
-            </a:pPr>
+              <a:t>GQA 기반 모델</a:t>
+            </a:r>
+          </a:p>
+          <a:p>
+            <a:pPr algn="l">
+              <a:spcAft>
+                <a:spcPts val="400"/>
+              </a:spcAft>
+            </a:pPr>
+            <a:r>
+              <a:rPr sz="1800" b="1" i="0">
+                <a:solidFill>
+                  <a:srgbClr val="D9352A"/>
+                </a:solidFill>
+                <a:latin typeface="Calibri"/>
+                <a:ea typeface="맑은 고딕"/>
+              </a:rPr>
+              <a:t>▸ </a:t>
+            </a:r>
             <a:r>
               <a:rPr sz="1800" b="0" i="0">
                 <a:solidFill>
@@ -11125,99 +10974,25 @@
                 <a:latin typeface="Calibri"/>
                 <a:ea typeface="맑은 고딕"/>
               </a:rPr>
-              <a:t>history/query 토큰은 256토큰의 큰 블록, response 토큰은 16토큰의 작은 블록으로 관리 → CPU-GPU 대역폭 활용도 향상, 단편화 감소</a:t>
-            </a:r>
-          </a:p>
-        </p:txBody>
-      </p:sp>
-      <p:sp>
-        <p:nvSpPr>
-          <p:cNvPr id="7" name="Rectangle 6"/>
-          <p:cNvSpPr/>
-          <p:nvPr/>
-        </p:nvSpPr>
-        <p:spPr>
-          <a:xfrm>
-            <a:off x="457200" y="3749040"/>
-            <a:ext cx="164592" cy="1005840"/>
-          </a:xfrm>
-          <a:prstGeom prst="rect">
-            <a:avLst/>
-          </a:prstGeom>
-          <a:solidFill>
-            <a:srgbClr val="D9352A"/>
-          </a:solidFill>
-          <a:ln>
-            <a:noFill/>
-          </a:ln>
-          <a:effectLst/>
-        </p:spPr>
-        <p:style>
-          <a:lnRef idx="1">
-            <a:schemeClr val="accent1"/>
-          </a:lnRef>
-          <a:fillRef idx="3">
-            <a:schemeClr val="accent1"/>
-          </a:fillRef>
-          <a:effectRef idx="2">
-            <a:schemeClr val="accent1"/>
-          </a:effectRef>
-          <a:fontRef idx="minor">
-            <a:schemeClr val="lt1"/>
-          </a:fontRef>
-        </p:style>
-        <p:txBody>
-          <a:bodyPr rtlCol="0" anchor="ctr"/>
-          <a:lstStyle/>
-          <a:p>
-            <a:pPr algn="ctr"/>
-          </a:p>
-        </p:txBody>
-      </p:sp>
-      <p:sp>
-        <p:nvSpPr>
-          <p:cNvPr id="8" name="TextBox 7"/>
-          <p:cNvSpPr txBox="1"/>
-          <p:nvPr/>
-        </p:nvSpPr>
-        <p:spPr>
-          <a:xfrm>
-            <a:off x="822960" y="3794760"/>
-            <a:ext cx="10789920" cy="1005840"/>
-          </a:xfrm>
-          <a:prstGeom prst="rect">
-            <a:avLst/>
-          </a:prstGeom>
-          <a:noFill/>
-        </p:spPr>
-        <p:txBody>
-          <a:bodyPr wrap="square" lIns="45720" rIns="45720" tIns="18288" bIns="18288">
-            <a:spAutoFit/>
-          </a:bodyPr>
-          <a:lstStyle/>
-          <a:p>
-            <a:pPr algn="l">
-              <a:spcAft>
-                <a:spcPts val="400"/>
-              </a:spcAft>
-            </a:pPr>
-            <a:r>
-              <a:rPr sz="2000" b="1" i="0">
-                <a:solidFill>
-                  <a:srgbClr val="1F2937"/>
-                </a:solidFill>
-                <a:latin typeface="Calibri"/>
-                <a:ea typeface="맑은 고딕"/>
-              </a:rPr>
-              <a:t>Low-priority CUDA stream</a:t>
-            </a:r>
-          </a:p>
-          <a:p>
-            <a:pPr algn="l">
-              <a:spcAft>
-                <a:spcPts val="400"/>
-              </a:spcAft>
-            </a:pPr>
+              <a:t>여러 query head가 K, V를 공유 → KV tensor 자체가 작음</a:t>
+            </a:r>
+          </a:p>
+          <a:p>
+            <a:pPr algn="l">
+              <a:spcAft>
+                <a:spcPts val="400"/>
+              </a:spcAft>
+            </a:pPr>
+            <a:r>
+              <a:rPr sz="1800" b="1" i="0">
+                <a:solidFill>
+                  <a:srgbClr val="D9352A"/>
+                </a:solidFill>
+                <a:latin typeface="Calibri"/>
+                <a:ea typeface="맑은 고딕"/>
+              </a:rPr>
+              <a:t>▸ </a:t>
+            </a:r>
             <a:r>
               <a:rPr sz="1800" b="0" i="0">
                 <a:solidFill>
@@ -11226,91 +11001,7 @@
                 <a:latin typeface="Calibri"/>
                 <a:ea typeface="맑은 고딕"/>
               </a:rPr>
-              <a:t>storage-efficient tensor를 KV tensor로 바꾸는 작업을 별도 스트림에서 실행 → 유휴 SM을 활용하고 실제 추론 latency에 영향 없음</a:t>
-            </a:r>
-          </a:p>
-        </p:txBody>
-      </p:sp>
-      <p:sp>
-        <p:nvSpPr>
-          <p:cNvPr id="9" name="Rectangle 8"/>
-          <p:cNvSpPr/>
-          <p:nvPr/>
-        </p:nvSpPr>
-        <p:spPr>
-          <a:xfrm>
-            <a:off x="457200" y="5029200"/>
-            <a:ext cx="164592" cy="1005840"/>
-          </a:xfrm>
-          <a:prstGeom prst="rect">
-            <a:avLst/>
-          </a:prstGeom>
-          <a:solidFill>
-            <a:srgbClr val="D9352A"/>
-          </a:solidFill>
-          <a:ln>
-            <a:noFill/>
-          </a:ln>
-          <a:effectLst/>
-        </p:spPr>
-        <p:style>
-          <a:lnRef idx="1">
-            <a:schemeClr val="accent1"/>
-          </a:lnRef>
-          <a:fillRef idx="3">
-            <a:schemeClr val="accent1"/>
-          </a:fillRef>
-          <a:effectRef idx="2">
-            <a:schemeClr val="accent1"/>
-          </a:effectRef>
-          <a:fontRef idx="minor">
-            <a:schemeClr val="lt1"/>
-          </a:fontRef>
-        </p:style>
-        <p:txBody>
-          <a:bodyPr rtlCol="0" anchor="ctr"/>
-          <a:lstStyle/>
-          <a:p>
-            <a:pPr algn="ctr"/>
-          </a:p>
-        </p:txBody>
-      </p:sp>
-      <p:sp>
-        <p:nvSpPr>
-          <p:cNvPr id="10" name="TextBox 9"/>
-          <p:cNvSpPr txBox="1"/>
-          <p:nvPr/>
-        </p:nvSpPr>
-        <p:spPr>
-          <a:xfrm>
-            <a:off x="822960" y="5074920"/>
-            <a:ext cx="10789920" cy="1005840"/>
-          </a:xfrm>
-          <a:prstGeom prst="rect">
-            <a:avLst/>
-          </a:prstGeom>
-          <a:noFill/>
-        </p:spPr>
-        <p:txBody>
-          <a:bodyPr wrap="square" lIns="45720" rIns="45720" tIns="18288" bIns="18288">
-            <a:spAutoFit/>
-          </a:bodyPr>
-          <a:lstStyle/>
-          <a:p>
-            <a:pPr algn="l">
-              <a:spcAft>
-                <a:spcPts val="400"/>
-              </a:spcAft>
-            </a:pPr>
-            <a:r>
-              <a:rPr sz="2000" b="1" i="0">
-                <a:solidFill>
-                  <a:srgbClr val="1F2937"/>
-                </a:solidFill>
-                <a:latin typeface="Calibri"/>
-                <a:ea typeface="맑은 고딕"/>
-              </a:rPr>
-              <a:t>Inclusive caching</a:t>
+              <a:t>tensor 6의 cost-efficiency 이점이 사라짐</a:t>
             </a:r>
           </a:p>
           <a:p>
@@ -11327,14 +11018,24 @@
                 <a:latin typeface="Calibri"/>
                 <a:ea typeface="맑은 고딕"/>
               </a:rPr>
-              <a:t>eviction 시점에 capacity layer에 이미 사본이 있어 추가 write 트래픽이 거의 없음 (FlashGen 계열과 동일)</a:t>
-            </a:r>
-          </a:p>
-        </p:txBody>
-      </p:sp>
-      <p:sp>
-        <p:nvSpPr>
-          <p:cNvPr id="11" name="TextBox 10"/>
+              <a:t>→ GQA에서는 </a:t>
+            </a:r>
+            <a:r>
+              <a:rPr sz="1800" b="1" i="0">
+                <a:solidFill>
+                  <a:srgbClr val="D9352A"/>
+                </a:solidFill>
+                <a:latin typeface="Calibri"/>
+                <a:ea typeface="맑은 고딕"/>
+              </a:rPr>
+              <a:t>KV tensor를 그대로 캐싱</a:t>
+            </a:r>
+          </a:p>
+        </p:txBody>
+      </p:sp>
+      <p:sp>
+        <p:nvSpPr>
+          <p:cNvPr id="7" name="TextBox 6"/>
           <p:cNvSpPr txBox="1"/>
           <p:nvPr/>
         </p:nvSpPr>
@@ -11425,7 +11126,7 @@
                 <a:latin typeface="Calibri"/>
                 <a:ea typeface="맑은 고딕"/>
               </a:rPr>
-              <a:t>EVALUATION</a:t>
+              <a:t>IMPLEMENTATION</a:t>
             </a:r>
           </a:p>
           <a:p>
@@ -11442,7 +11143,7 @@
                 <a:latin typeface="Calibri"/>
                 <a:ea typeface="맑은 고딕"/>
               </a:rPr>
-              <a:t>실험 환경 및 비교 대상</a:t>
+              <a:t>구현 노트 — vLLM 위에 얹는 네 가지 기법</a:t>
             </a:r>
           </a:p>
         </p:txBody>
@@ -11456,18 +11157,16 @@
         <p:spPr>
           <a:xfrm>
             <a:off x="457200" y="1188720"/>
-            <a:ext cx="5669280" cy="5120640"/>
+            <a:ext cx="164592" cy="1005840"/>
           </a:xfrm>
           <a:prstGeom prst="rect">
             <a:avLst/>
           </a:prstGeom>
           <a:solidFill>
-            <a:srgbClr val="FFFFFF"/>
+            <a:srgbClr val="D9352A"/>
           </a:solidFill>
-          <a:ln w="6350">
-            <a:solidFill>
-              <a:srgbClr val="E5E7EB"/>
-            </a:solidFill>
+          <a:ln>
+            <a:noFill/>
           </a:ln>
           <a:effectLst/>
         </p:spPr>
@@ -11501,8 +11200,8 @@
         </p:nvSpPr>
         <p:spPr>
           <a:xfrm>
-            <a:off x="640080" y="1280160"/>
-            <a:ext cx="5303520" cy="4937760"/>
+            <a:off x="822960" y="1234440"/>
+            <a:ext cx="10789920" cy="1005840"/>
           </a:xfrm>
           <a:prstGeom prst="rect">
             <a:avLst/>
@@ -11517,7 +11216,7 @@
           <a:p>
             <a:pPr algn="l">
               <a:spcAft>
-                <a:spcPts val="600"/>
+                <a:spcPts val="400"/>
               </a:spcAft>
             </a:pPr>
             <a:r>
@@ -11528,25 +11227,15 @@
                 <a:latin typeface="Calibri"/>
                 <a:ea typeface="맑은 고딕"/>
               </a:rPr>
-              <a:t>Hardware / Software</a:t>
-            </a:r>
-          </a:p>
-          <a:p>
-            <a:pPr algn="l">
-              <a:spcAft>
-                <a:spcPts val="400"/>
-              </a:spcAft>
-            </a:pPr>
-            <a:r>
-              <a:rPr sz="1800" b="1" i="0">
-                <a:solidFill>
-                  <a:srgbClr val="1F2937"/>
-                </a:solidFill>
-                <a:latin typeface="Calibri"/>
-                <a:ea typeface="맑은 고딕"/>
-              </a:rPr>
-              <a:t>GPU:  </a:t>
-            </a:r>
+              <a:t>Continuous batching</a:t>
+            </a:r>
+          </a:p>
+          <a:p>
+            <a:pPr algn="l">
+              <a:spcAft>
+                <a:spcPts val="400"/>
+              </a:spcAft>
+            </a:pPr>
             <a:r>
               <a:rPr sz="1800" b="0" i="0">
                 <a:solidFill>
@@ -11555,142 +11244,7 @@
                 <a:latin typeface="Calibri"/>
                 <a:ea typeface="맑은 고딕"/>
               </a:rPr>
-              <a:t>NVIDIA A800 80GB</a:t>
-            </a:r>
-          </a:p>
-          <a:p>
-            <a:pPr algn="l">
-              <a:spcAft>
-                <a:spcPts val="400"/>
-              </a:spcAft>
-            </a:pPr>
-            <a:r>
-              <a:rPr sz="1800" b="1" i="0">
-                <a:solidFill>
-                  <a:srgbClr val="1F2937"/>
-                </a:solidFill>
-                <a:latin typeface="Calibri"/>
-                <a:ea typeface="맑은 고딕"/>
-              </a:rPr>
-              <a:t>Host mem:  </a:t>
-            </a:r>
-            <a:r>
-              <a:rPr sz="1800" b="0" i="0">
-                <a:solidFill>
-                  <a:srgbClr val="1F2937"/>
-                </a:solidFill>
-                <a:latin typeface="Calibri"/>
-                <a:ea typeface="맑은 고딕"/>
-              </a:rPr>
-              <a:t>200 GB (perf layer)</a:t>
-            </a:r>
-          </a:p>
-          <a:p>
-            <a:pPr algn="l">
-              <a:spcAft>
-                <a:spcPts val="400"/>
-              </a:spcAft>
-            </a:pPr>
-            <a:r>
-              <a:rPr sz="1800" b="1" i="0">
-                <a:solidFill>
-                  <a:srgbClr val="1F2937"/>
-                </a:solidFill>
-                <a:latin typeface="Calibri"/>
-                <a:ea typeface="맑은 고딕"/>
-              </a:rPr>
-              <a:t>Storage:  </a:t>
-            </a:r>
-            <a:r>
-              <a:rPr sz="1800" b="0" i="0">
-                <a:solidFill>
-                  <a:srgbClr val="1F2937"/>
-                </a:solidFill>
-                <a:latin typeface="Calibri"/>
-                <a:ea typeface="맑은 고딕"/>
-              </a:rPr>
-              <a:t>SATA SSD 4장 RAID-5, 1.5 GB/s</a:t>
-            </a:r>
-          </a:p>
-          <a:p>
-            <a:pPr algn="l">
-              <a:spcAft>
-                <a:spcPts val="400"/>
-              </a:spcAft>
-            </a:pPr>
-            <a:r>
-              <a:rPr sz="1800" b="1" i="0">
-                <a:solidFill>
-                  <a:srgbClr val="1F2937"/>
-                </a:solidFill>
-                <a:latin typeface="Calibri"/>
-                <a:ea typeface="맑은 고딕"/>
-              </a:rPr>
-              <a:t>PCIe:  </a:t>
-            </a:r>
-            <a:r>
-              <a:rPr sz="1800" b="0" i="0">
-                <a:solidFill>
-                  <a:srgbClr val="1F2937"/>
-                </a:solidFill>
-                <a:latin typeface="Calibri"/>
-                <a:ea typeface="맑은 고딕"/>
-              </a:rPr>
-              <a:t>Gen 4 (~30 GB/s)</a:t>
-            </a:r>
-          </a:p>
-          <a:p>
-            <a:pPr algn="l">
-              <a:spcAft>
-                <a:spcPts val="400"/>
-              </a:spcAft>
-            </a:pPr>
-            <a:r>
-              <a:rPr sz="1800" b="1" i="0">
-                <a:solidFill>
-                  <a:srgbClr val="1F2937"/>
-                </a:solidFill>
-                <a:latin typeface="Calibri"/>
-                <a:ea typeface="맑은 고딕"/>
-              </a:rPr>
-              <a:t>Models:  </a:t>
-            </a:r>
-            <a:r>
-              <a:rPr sz="1800" b="0" i="0">
-                <a:solidFill>
-                  <a:srgbClr val="1F2937"/>
-                </a:solidFill>
-                <a:latin typeface="Calibri"/>
-                <a:ea typeface="맑은 고딕"/>
-              </a:rPr>
-              <a:t>OPT-6.7B/13B/30B, Qwen-7B/14B</a:t>
-            </a:r>
-          </a:p>
-          <a:p>
-            <a:pPr algn="l">
-              <a:spcAft>
-                <a:spcPts val="400"/>
-              </a:spcAft>
-            </a:pPr>
-            <a:r>
-              <a:rPr sz="1800" b="1" i="0">
-                <a:solidFill>
-                  <a:srgbClr val="1F2937"/>
-                </a:solidFill>
-                <a:latin typeface="Calibri"/>
-                <a:ea typeface="맑은 고딕"/>
-              </a:rPr>
-              <a:t>Workloads:  </a:t>
-            </a:r>
-            <a:r>
-              <a:rPr sz="1800" b="0" i="0">
-                <a:solidFill>
-                  <a:srgbClr val="1F2937"/>
-                </a:solidFill>
-                <a:latin typeface="Calibri"/>
-                <a:ea typeface="맑은 고딕"/>
-              </a:rPr>
-              <a:t>자체 100만 라운드 trace, ShareGPT (Poisson 시뮬)</a:t>
+              <a:t>일찍 끝난 요청을 배치에서 바로 빼고 새 요청을 곧장 받아들임 (ORCA 계열과 호환)</a:t>
             </a:r>
           </a:p>
         </p:txBody>
@@ -11703,19 +11257,17 @@
         </p:nvSpPr>
         <p:spPr>
           <a:xfrm>
-            <a:off x="6309360" y="1188720"/>
-            <a:ext cx="5394960" cy="5120640"/>
+            <a:off x="457200" y="2468880"/>
+            <a:ext cx="164592" cy="1005840"/>
           </a:xfrm>
           <a:prstGeom prst="rect">
             <a:avLst/>
           </a:prstGeom>
           <a:solidFill>
-            <a:srgbClr val="FFFFFF"/>
+            <a:srgbClr val="D9352A"/>
           </a:solidFill>
-          <a:ln w="6350">
-            <a:solidFill>
-              <a:srgbClr val="E5E7EB"/>
-            </a:solidFill>
+          <a:ln>
+            <a:noFill/>
           </a:ln>
           <a:effectLst/>
         </p:spPr>
@@ -11749,8 +11301,8 @@
         </p:nvSpPr>
         <p:spPr>
           <a:xfrm>
-            <a:off x="6492240" y="1280160"/>
-            <a:ext cx="5029200" cy="4937760"/>
+            <a:off x="822960" y="2514600"/>
+            <a:ext cx="10789920" cy="1005840"/>
           </a:xfrm>
           <a:prstGeom prst="rect">
             <a:avLst/>
@@ -11765,7 +11317,7 @@
           <a:p>
             <a:pPr algn="l">
               <a:spcAft>
-                <a:spcPts val="600"/>
+                <a:spcPts val="400"/>
               </a:spcAft>
             </a:pPr>
             <a:r>
@@ -11776,199 +11328,233 @@
                 <a:latin typeface="Calibri"/>
                 <a:ea typeface="맑은 고딕"/>
               </a:rPr>
-              <a:t>Baselines</a:t>
-            </a:r>
-          </a:p>
-          <a:p>
-            <a:pPr algn="l">
-              <a:spcAft>
-                <a:spcPts val="400"/>
-              </a:spcAft>
-            </a:pPr>
-            <a:r>
-              <a:rPr sz="1800" b="1" i="0">
-                <a:solidFill>
-                  <a:srgbClr val="D9352A"/>
-                </a:solidFill>
-                <a:latin typeface="Calibri"/>
-                <a:ea typeface="맑은 고딕"/>
-              </a:rPr>
-              <a:t>▸ </a:t>
-            </a:r>
-            <a:r>
-              <a:rPr sz="1800" b="1" i="0">
-                <a:solidFill>
-                  <a:srgbClr val="1F2937"/>
-                </a:solidFill>
-                <a:latin typeface="Calibri"/>
-                <a:ea typeface="맑은 고딕"/>
-              </a:rPr>
-              <a:t>vLLM</a:t>
-            </a:r>
-            <a:r>
-              <a:rPr sz="1400" b="0" i="0">
-                <a:solidFill>
-                  <a:srgbClr val="6B7280"/>
-                </a:solidFill>
-                <a:latin typeface="Calibri"/>
-                <a:ea typeface="맑은 고딕"/>
-              </a:rPr>
-              <a:t>  Recompute (KV caching 없음)</a:t>
-            </a:r>
-          </a:p>
-          <a:p>
-            <a:pPr algn="l">
-              <a:spcAft>
-                <a:spcPts val="400"/>
-              </a:spcAft>
-            </a:pPr>
-            <a:r>
-              <a:rPr sz="1800" b="1" i="0">
-                <a:solidFill>
-                  <a:srgbClr val="D9352A"/>
-                </a:solidFill>
-                <a:latin typeface="Calibri"/>
-                <a:ea typeface="맑은 고딕"/>
-              </a:rPr>
-              <a:t>▸ </a:t>
-            </a:r>
-            <a:r>
-              <a:rPr sz="1800" b="1" i="0">
-                <a:solidFill>
-                  <a:srgbClr val="1F2937"/>
-                </a:solidFill>
-                <a:latin typeface="Calibri"/>
-                <a:ea typeface="맑은 고딕"/>
-              </a:rPr>
-              <a:t>CachedAttention</a:t>
-            </a:r>
-            <a:r>
-              <a:rPr sz="1400" b="0" i="0">
-                <a:solidFill>
-                  <a:srgbClr val="6B7280"/>
-                </a:solidFill>
-                <a:latin typeface="Calibri"/>
-                <a:ea typeface="맑은 고딕"/>
-              </a:rPr>
-              <a:t>  Queue-enhanced LRU + 2-tier</a:t>
-            </a:r>
-          </a:p>
-          <a:p>
-            <a:pPr algn="l">
-              <a:spcAft>
-                <a:spcPts val="400"/>
-              </a:spcAft>
-            </a:pPr>
-            <a:r>
-              <a:rPr sz="1800" b="1" i="0">
-                <a:solidFill>
-                  <a:srgbClr val="D9352A"/>
-                </a:solidFill>
-                <a:latin typeface="Calibri"/>
-                <a:ea typeface="맑은 고딕"/>
-              </a:rPr>
-              <a:t>▸ </a:t>
-            </a:r>
-            <a:r>
-              <a:rPr sz="1800" b="1" i="0">
-                <a:solidFill>
-                  <a:srgbClr val="1F2937"/>
-                </a:solidFill>
-                <a:latin typeface="Calibri"/>
-                <a:ea typeface="맑은 고딕"/>
-              </a:rPr>
-              <a:t>FlashGen</a:t>
-            </a:r>
-            <a:r>
-              <a:rPr sz="1400" b="0" i="0">
-                <a:solidFill>
-                  <a:srgbClr val="6B7280"/>
-                </a:solidFill>
-                <a:latin typeface="Calibri"/>
-                <a:ea typeface="맑은 고딕"/>
-              </a:rPr>
-              <a:t>  Inclusive caching + GPU-fit scheduling</a:t>
-            </a:r>
-          </a:p>
-          <a:p>
-            <a:pPr algn="l">
-              <a:spcAft>
-                <a:spcPts val="400"/>
-              </a:spcAft>
-            </a:pPr>
-            <a:r>
-              <a:rPr sz="1800" b="1" i="0">
-                <a:solidFill>
-                  <a:srgbClr val="D9352A"/>
-                </a:solidFill>
-                <a:latin typeface="Calibri"/>
-                <a:ea typeface="맑은 고딕"/>
-              </a:rPr>
-              <a:t>▸ </a:t>
-            </a:r>
-            <a:r>
-              <a:rPr sz="1800" b="1" i="0">
-                <a:solidFill>
-                  <a:srgbClr val="1F2937"/>
-                </a:solidFill>
-                <a:latin typeface="Calibri"/>
-                <a:ea typeface="맑은 고딕"/>
-              </a:rPr>
-              <a:t>Optimal</a:t>
-            </a:r>
-            <a:r>
-              <a:rPr sz="1400" b="0" i="0">
-                <a:solidFill>
-                  <a:srgbClr val="6B7280"/>
-                </a:solidFill>
-                <a:latin typeface="Calibri"/>
-                <a:ea typeface="맑은 고딕"/>
-              </a:rPr>
-              <a:t>  모든 KV가 perf layer에 있는 상한선</a:t>
-            </a:r>
-          </a:p>
-          <a:p>
-            <a:pPr algn="l">
-              <a:spcAft>
-                <a:spcPts val="400"/>
-              </a:spcAft>
-            </a:pPr>
-            <a:r>
-              <a:rPr sz="1800" b="1" i="0">
-                <a:solidFill>
-                  <a:srgbClr val="D9352A"/>
-                </a:solidFill>
-                <a:latin typeface="Calibri"/>
-                <a:ea typeface="맑은 고딕"/>
-              </a:rPr>
-              <a:t>▸ </a:t>
-            </a:r>
-            <a:r>
-              <a:rPr sz="1800" b="1" i="0">
-                <a:solidFill>
-                  <a:srgbClr val="1F2937"/>
-                </a:solidFill>
-                <a:latin typeface="Calibri"/>
-                <a:ea typeface="맑은 고딕"/>
-              </a:rPr>
-              <a:t>Bidaw</a:t>
-            </a:r>
-            <a:r>
-              <a:rPr sz="1400" b="0" i="0">
-                <a:solidFill>
-                  <a:srgbClr val="6B7280"/>
-                </a:solidFill>
-                <a:latin typeface="Calibri"/>
-                <a:ea typeface="맑은 고딕"/>
-              </a:rPr>
-              <a:t>  이 논문</a:t>
-            </a:r>
-          </a:p>
-        </p:txBody>
-      </p:sp>
-      <p:sp>
-        <p:nvSpPr>
-          <p:cNvPr id="7" name="TextBox 6"/>
+              <a:t>Mix-grained PagedAttention</a:t>
+            </a:r>
+          </a:p>
+          <a:p>
+            <a:pPr algn="l">
+              <a:spcAft>
+                <a:spcPts val="400"/>
+              </a:spcAft>
+            </a:pPr>
+            <a:r>
+              <a:rPr sz="1800" b="0" i="0">
+                <a:solidFill>
+                  <a:srgbClr val="1F2937"/>
+                </a:solidFill>
+                <a:latin typeface="Calibri"/>
+                <a:ea typeface="맑은 고딕"/>
+              </a:rPr>
+              <a:t>history/query 토큰은 256토큰의 큰 블록, response 토큰은 16토큰의 작은 블록으로 관리 → CPU-GPU 대역폭 활용도 향상, 단편화 감소</a:t>
+            </a:r>
+          </a:p>
+        </p:txBody>
+      </p:sp>
+      <p:sp>
+        <p:nvSpPr>
+          <p:cNvPr id="7" name="Rectangle 6"/>
+          <p:cNvSpPr/>
+          <p:nvPr/>
+        </p:nvSpPr>
+        <p:spPr>
+          <a:xfrm>
+            <a:off x="457200" y="3749040"/>
+            <a:ext cx="164592" cy="1005840"/>
+          </a:xfrm>
+          <a:prstGeom prst="rect">
+            <a:avLst/>
+          </a:prstGeom>
+          <a:solidFill>
+            <a:srgbClr val="D9352A"/>
+          </a:solidFill>
+          <a:ln>
+            <a:noFill/>
+          </a:ln>
+          <a:effectLst/>
+        </p:spPr>
+        <p:style>
+          <a:lnRef idx="1">
+            <a:schemeClr val="accent1"/>
+          </a:lnRef>
+          <a:fillRef idx="3">
+            <a:schemeClr val="accent1"/>
+          </a:fillRef>
+          <a:effectRef idx="2">
+            <a:schemeClr val="accent1"/>
+          </a:effectRef>
+          <a:fontRef idx="minor">
+            <a:schemeClr val="lt1"/>
+          </a:fontRef>
+        </p:style>
+        <p:txBody>
+          <a:bodyPr rtlCol="0" anchor="ctr"/>
+          <a:lstStyle/>
+          <a:p>
+            <a:pPr algn="ctr"/>
+          </a:p>
+        </p:txBody>
+      </p:sp>
+      <p:sp>
+        <p:nvSpPr>
+          <p:cNvPr id="8" name="TextBox 7"/>
+          <p:cNvSpPr txBox="1"/>
+          <p:nvPr/>
+        </p:nvSpPr>
+        <p:spPr>
+          <a:xfrm>
+            <a:off x="822960" y="3794760"/>
+            <a:ext cx="10789920" cy="1005840"/>
+          </a:xfrm>
+          <a:prstGeom prst="rect">
+            <a:avLst/>
+          </a:prstGeom>
+          <a:noFill/>
+        </p:spPr>
+        <p:txBody>
+          <a:bodyPr wrap="square" lIns="45720" rIns="45720" tIns="18288" bIns="18288">
+            <a:spAutoFit/>
+          </a:bodyPr>
+          <a:lstStyle/>
+          <a:p>
+            <a:pPr algn="l">
+              <a:spcAft>
+                <a:spcPts val="400"/>
+              </a:spcAft>
+            </a:pPr>
+            <a:r>
+              <a:rPr sz="2000" b="1" i="0">
+                <a:solidFill>
+                  <a:srgbClr val="1F2937"/>
+                </a:solidFill>
+                <a:latin typeface="Calibri"/>
+                <a:ea typeface="맑은 고딕"/>
+              </a:rPr>
+              <a:t>Low-priority CUDA stream</a:t>
+            </a:r>
+          </a:p>
+          <a:p>
+            <a:pPr algn="l">
+              <a:spcAft>
+                <a:spcPts val="400"/>
+              </a:spcAft>
+            </a:pPr>
+            <a:r>
+              <a:rPr sz="1800" b="0" i="0">
+                <a:solidFill>
+                  <a:srgbClr val="1F2937"/>
+                </a:solidFill>
+                <a:latin typeface="Calibri"/>
+                <a:ea typeface="맑은 고딕"/>
+              </a:rPr>
+              <a:t>storage-efficient tensor를 KV tensor로 바꾸는 작업을 별도 스트림에서 실행 → 유휴 SM을 활용하고 실제 추론 latency에 영향 없음</a:t>
+            </a:r>
+          </a:p>
+        </p:txBody>
+      </p:sp>
+      <p:sp>
+        <p:nvSpPr>
+          <p:cNvPr id="9" name="Rectangle 8"/>
+          <p:cNvSpPr/>
+          <p:nvPr/>
+        </p:nvSpPr>
+        <p:spPr>
+          <a:xfrm>
+            <a:off x="457200" y="5029200"/>
+            <a:ext cx="164592" cy="1005840"/>
+          </a:xfrm>
+          <a:prstGeom prst="rect">
+            <a:avLst/>
+          </a:prstGeom>
+          <a:solidFill>
+            <a:srgbClr val="D9352A"/>
+          </a:solidFill>
+          <a:ln>
+            <a:noFill/>
+          </a:ln>
+          <a:effectLst/>
+        </p:spPr>
+        <p:style>
+          <a:lnRef idx="1">
+            <a:schemeClr val="accent1"/>
+          </a:lnRef>
+          <a:fillRef idx="3">
+            <a:schemeClr val="accent1"/>
+          </a:fillRef>
+          <a:effectRef idx="2">
+            <a:schemeClr val="accent1"/>
+          </a:effectRef>
+          <a:fontRef idx="minor">
+            <a:schemeClr val="lt1"/>
+          </a:fontRef>
+        </p:style>
+        <p:txBody>
+          <a:bodyPr rtlCol="0" anchor="ctr"/>
+          <a:lstStyle/>
+          <a:p>
+            <a:pPr algn="ctr"/>
+          </a:p>
+        </p:txBody>
+      </p:sp>
+      <p:sp>
+        <p:nvSpPr>
+          <p:cNvPr id="10" name="TextBox 9"/>
+          <p:cNvSpPr txBox="1"/>
+          <p:nvPr/>
+        </p:nvSpPr>
+        <p:spPr>
+          <a:xfrm>
+            <a:off x="822960" y="5074920"/>
+            <a:ext cx="10789920" cy="1005840"/>
+          </a:xfrm>
+          <a:prstGeom prst="rect">
+            <a:avLst/>
+          </a:prstGeom>
+          <a:noFill/>
+        </p:spPr>
+        <p:txBody>
+          <a:bodyPr wrap="square" lIns="45720" rIns="45720" tIns="18288" bIns="18288">
+            <a:spAutoFit/>
+          </a:bodyPr>
+          <a:lstStyle/>
+          <a:p>
+            <a:pPr algn="l">
+              <a:spcAft>
+                <a:spcPts val="400"/>
+              </a:spcAft>
+            </a:pPr>
+            <a:r>
+              <a:rPr sz="2000" b="1" i="0">
+                <a:solidFill>
+                  <a:srgbClr val="1F2937"/>
+                </a:solidFill>
+                <a:latin typeface="Calibri"/>
+                <a:ea typeface="맑은 고딕"/>
+              </a:rPr>
+              <a:t>Inclusive caching</a:t>
+            </a:r>
+          </a:p>
+          <a:p>
+            <a:pPr algn="l">
+              <a:spcAft>
+                <a:spcPts val="400"/>
+              </a:spcAft>
+            </a:pPr>
+            <a:r>
+              <a:rPr sz="1800" b="0" i="0">
+                <a:solidFill>
+                  <a:srgbClr val="1F2937"/>
+                </a:solidFill>
+                <a:latin typeface="Calibri"/>
+                <a:ea typeface="맑은 고딕"/>
+              </a:rPr>
+              <a:t>eviction 시점에 capacity layer에 이미 사본이 있어 추가 write 트래픽이 거의 없음 (FlashGen 계열과 동일)</a:t>
+            </a:r>
+          </a:p>
+        </p:txBody>
+      </p:sp>
+      <p:sp>
+        <p:nvSpPr>
+          <p:cNvPr id="11" name="TextBox 10"/>
           <p:cNvSpPr txBox="1"/>
           <p:nvPr/>
         </p:nvSpPr>
@@ -12076,35 +11662,57 @@
                 <a:latin typeface="Calibri"/>
                 <a:ea typeface="맑은 고딕"/>
               </a:rPr>
-              <a:t>Overall performance — 모델 5종 동시 평가</a:t>
-            </a:r>
-          </a:p>
-        </p:txBody>
-      </p:sp>
-      <p:pic>
-        <p:nvPicPr>
-          <p:cNvPr id="3" name="Picture 2" descr="figure_15.png"/>
-          <p:cNvPicPr>
-            <a:picLocks noChangeAspect="1"/>
-          </p:cNvPicPr>
-          <p:nvPr/>
-        </p:nvPicPr>
-        <p:blipFill>
-          <a:blip r:embed="rId2"/>
-          <a:stretch>
-            <a:fillRect/>
-          </a:stretch>
-        </p:blipFill>
-        <p:spPr>
-          <a:xfrm>
-            <a:off x="274320" y="1188720"/>
-            <a:ext cx="11612880" cy="2024636"/>
-          </a:xfrm>
-          <a:prstGeom prst="rect">
-            <a:avLst/>
-          </a:prstGeom>
-        </p:spPr>
-      </p:pic>
+              <a:t>실험 환경 및 비교 대상</a:t>
+            </a:r>
+          </a:p>
+        </p:txBody>
+      </p:sp>
+      <p:sp>
+        <p:nvSpPr>
+          <p:cNvPr id="3" name="Rectangle 2"/>
+          <p:cNvSpPr/>
+          <p:nvPr/>
+        </p:nvSpPr>
+        <p:spPr>
+          <a:xfrm>
+            <a:off x="457200" y="1188720"/>
+            <a:ext cx="5669280" cy="5120640"/>
+          </a:xfrm>
+          <a:prstGeom prst="rect">
+            <a:avLst/>
+          </a:prstGeom>
+          <a:solidFill>
+            <a:srgbClr val="FFFFFF"/>
+          </a:solidFill>
+          <a:ln w="6350">
+            <a:solidFill>
+              <a:srgbClr val="E5E7EB"/>
+            </a:solidFill>
+          </a:ln>
+          <a:effectLst/>
+        </p:spPr>
+        <p:style>
+          <a:lnRef idx="1">
+            <a:schemeClr val="accent1"/>
+          </a:lnRef>
+          <a:fillRef idx="3">
+            <a:schemeClr val="accent1"/>
+          </a:fillRef>
+          <a:effectRef idx="2">
+            <a:schemeClr val="accent1"/>
+          </a:effectRef>
+          <a:fontRef idx="minor">
+            <a:schemeClr val="lt1"/>
+          </a:fontRef>
+        </p:style>
+        <p:txBody>
+          <a:bodyPr rtlCol="0" anchor="ctr"/>
+          <a:lstStyle/>
+          <a:p>
+            <a:pPr algn="ctr"/>
+          </a:p>
+        </p:txBody>
+      </p:sp>
       <p:sp>
         <p:nvSpPr>
           <p:cNvPr id="4" name="TextBox 3"/>
@@ -12113,8 +11721,8 @@
         </p:nvSpPr>
         <p:spPr>
           <a:xfrm>
-            <a:off x="274320" y="3259076"/>
-            <a:ext cx="11612880" cy="320040"/>
+            <a:off x="640080" y="1280160"/>
+            <a:ext cx="5303520" cy="4937760"/>
           </a:xfrm>
           <a:prstGeom prst="rect">
             <a:avLst/>
@@ -12127,34 +11735,242 @@
           </a:bodyPr>
           <a:lstStyle/>
           <a:p>
-            <a:pPr algn="ctr">
-              <a:spcAft>
-                <a:spcPts val="400"/>
-              </a:spcAft>
-            </a:pPr>
-            <a:r>
-              <a:rPr sz="1000" b="0" i="1">
-                <a:solidFill>
-                  <a:srgbClr val="6B7280"/>
-                </a:solidFill>
-                <a:latin typeface="Calibri"/>
-                <a:ea typeface="맑은 고딕"/>
-              </a:rPr>
-              <a:t>Figure 15. 사용자 도착률 vs 평균 응답 latency, 모델 5종</a:t>
-            </a:r>
-          </a:p>
-        </p:txBody>
-      </p:sp>
-      <p:sp>
-        <p:nvSpPr>
-          <p:cNvPr id="5" name="TextBox 4"/>
+            <a:pPr algn="l">
+              <a:spcAft>
+                <a:spcPts val="600"/>
+              </a:spcAft>
+            </a:pPr>
+            <a:r>
+              <a:rPr sz="2000" b="1" i="0">
+                <a:solidFill>
+                  <a:srgbClr val="1F2937"/>
+                </a:solidFill>
+                <a:latin typeface="Calibri"/>
+                <a:ea typeface="맑은 고딕"/>
+              </a:rPr>
+              <a:t>Hardware / Software</a:t>
+            </a:r>
+          </a:p>
+          <a:p>
+            <a:pPr algn="l">
+              <a:spcAft>
+                <a:spcPts val="400"/>
+              </a:spcAft>
+            </a:pPr>
+            <a:r>
+              <a:rPr sz="1800" b="1" i="0">
+                <a:solidFill>
+                  <a:srgbClr val="1F2937"/>
+                </a:solidFill>
+                <a:latin typeface="Calibri"/>
+                <a:ea typeface="맑은 고딕"/>
+              </a:rPr>
+              <a:t>GPU:  </a:t>
+            </a:r>
+            <a:r>
+              <a:rPr sz="1800" b="0" i="0">
+                <a:solidFill>
+                  <a:srgbClr val="1F2937"/>
+                </a:solidFill>
+                <a:latin typeface="Calibri"/>
+                <a:ea typeface="맑은 고딕"/>
+              </a:rPr>
+              <a:t>NVIDIA A800 80GB</a:t>
+            </a:r>
+          </a:p>
+          <a:p>
+            <a:pPr algn="l">
+              <a:spcAft>
+                <a:spcPts val="400"/>
+              </a:spcAft>
+            </a:pPr>
+            <a:r>
+              <a:rPr sz="1800" b="1" i="0">
+                <a:solidFill>
+                  <a:srgbClr val="1F2937"/>
+                </a:solidFill>
+                <a:latin typeface="Calibri"/>
+                <a:ea typeface="맑은 고딕"/>
+              </a:rPr>
+              <a:t>Host mem:  </a:t>
+            </a:r>
+            <a:r>
+              <a:rPr sz="1800" b="0" i="0">
+                <a:solidFill>
+                  <a:srgbClr val="1F2937"/>
+                </a:solidFill>
+                <a:latin typeface="Calibri"/>
+                <a:ea typeface="맑은 고딕"/>
+              </a:rPr>
+              <a:t>200 GB (perf layer)</a:t>
+            </a:r>
+          </a:p>
+          <a:p>
+            <a:pPr algn="l">
+              <a:spcAft>
+                <a:spcPts val="400"/>
+              </a:spcAft>
+            </a:pPr>
+            <a:r>
+              <a:rPr sz="1800" b="1" i="0">
+                <a:solidFill>
+                  <a:srgbClr val="1F2937"/>
+                </a:solidFill>
+                <a:latin typeface="Calibri"/>
+                <a:ea typeface="맑은 고딕"/>
+              </a:rPr>
+              <a:t>Storage:  </a:t>
+            </a:r>
+            <a:r>
+              <a:rPr sz="1800" b="0" i="0">
+                <a:solidFill>
+                  <a:srgbClr val="1F2937"/>
+                </a:solidFill>
+                <a:latin typeface="Calibri"/>
+                <a:ea typeface="맑은 고딕"/>
+              </a:rPr>
+              <a:t>SATA SSD 4장 RAID-5, 1.5 GB/s</a:t>
+            </a:r>
+          </a:p>
+          <a:p>
+            <a:pPr algn="l">
+              <a:spcAft>
+                <a:spcPts val="400"/>
+              </a:spcAft>
+            </a:pPr>
+            <a:r>
+              <a:rPr sz="1800" b="1" i="0">
+                <a:solidFill>
+                  <a:srgbClr val="1F2937"/>
+                </a:solidFill>
+                <a:latin typeface="Calibri"/>
+                <a:ea typeface="맑은 고딕"/>
+              </a:rPr>
+              <a:t>PCIe:  </a:t>
+            </a:r>
+            <a:r>
+              <a:rPr sz="1800" b="0" i="0">
+                <a:solidFill>
+                  <a:srgbClr val="1F2937"/>
+                </a:solidFill>
+                <a:latin typeface="Calibri"/>
+                <a:ea typeface="맑은 고딕"/>
+              </a:rPr>
+              <a:t>Gen 4 (~30 GB/s)</a:t>
+            </a:r>
+          </a:p>
+          <a:p>
+            <a:pPr algn="l">
+              <a:spcAft>
+                <a:spcPts val="400"/>
+              </a:spcAft>
+            </a:pPr>
+            <a:r>
+              <a:rPr sz="1800" b="1" i="0">
+                <a:solidFill>
+                  <a:srgbClr val="1F2937"/>
+                </a:solidFill>
+                <a:latin typeface="Calibri"/>
+                <a:ea typeface="맑은 고딕"/>
+              </a:rPr>
+              <a:t>Models:  </a:t>
+            </a:r>
+            <a:r>
+              <a:rPr sz="1800" b="0" i="0">
+                <a:solidFill>
+                  <a:srgbClr val="1F2937"/>
+                </a:solidFill>
+                <a:latin typeface="Calibri"/>
+                <a:ea typeface="맑은 고딕"/>
+              </a:rPr>
+              <a:t>OPT-6.7B/13B/30B, Qwen-7B/14B</a:t>
+            </a:r>
+          </a:p>
+          <a:p>
+            <a:pPr algn="l">
+              <a:spcAft>
+                <a:spcPts val="400"/>
+              </a:spcAft>
+            </a:pPr>
+            <a:r>
+              <a:rPr sz="1800" b="1" i="0">
+                <a:solidFill>
+                  <a:srgbClr val="1F2937"/>
+                </a:solidFill>
+                <a:latin typeface="Calibri"/>
+                <a:ea typeface="맑은 고딕"/>
+              </a:rPr>
+              <a:t>Workloads:  </a:t>
+            </a:r>
+            <a:r>
+              <a:rPr sz="1800" b="0" i="0">
+                <a:solidFill>
+                  <a:srgbClr val="1F2937"/>
+                </a:solidFill>
+                <a:latin typeface="Calibri"/>
+                <a:ea typeface="맑은 고딕"/>
+              </a:rPr>
+              <a:t>자체 100만 라운드 trace, ShareGPT (Poisson 시뮬)</a:t>
+            </a:r>
+          </a:p>
+        </p:txBody>
+      </p:sp>
+      <p:sp>
+        <p:nvSpPr>
+          <p:cNvPr id="5" name="Rectangle 4"/>
+          <p:cNvSpPr/>
+          <p:nvPr/>
+        </p:nvSpPr>
+        <p:spPr>
+          <a:xfrm>
+            <a:off x="6309360" y="1188720"/>
+            <a:ext cx="5394960" cy="5120640"/>
+          </a:xfrm>
+          <a:prstGeom prst="rect">
+            <a:avLst/>
+          </a:prstGeom>
+          <a:solidFill>
+            <a:srgbClr val="FFFFFF"/>
+          </a:solidFill>
+          <a:ln w="6350">
+            <a:solidFill>
+              <a:srgbClr val="E5E7EB"/>
+            </a:solidFill>
+          </a:ln>
+          <a:effectLst/>
+        </p:spPr>
+        <p:style>
+          <a:lnRef idx="1">
+            <a:schemeClr val="accent1"/>
+          </a:lnRef>
+          <a:fillRef idx="3">
+            <a:schemeClr val="accent1"/>
+          </a:fillRef>
+          <a:effectRef idx="2">
+            <a:schemeClr val="accent1"/>
+          </a:effectRef>
+          <a:fontRef idx="minor">
+            <a:schemeClr val="lt1"/>
+          </a:fontRef>
+        </p:style>
+        <p:txBody>
+          <a:bodyPr rtlCol="0" anchor="ctr"/>
+          <a:lstStyle/>
+          <a:p>
+            <a:pPr algn="ctr"/>
+          </a:p>
+        </p:txBody>
+      </p:sp>
+      <p:sp>
+        <p:nvSpPr>
+          <p:cNvPr id="6" name="TextBox 5"/>
           <p:cNvSpPr txBox="1"/>
           <p:nvPr/>
         </p:nvSpPr>
         <p:spPr>
           <a:xfrm>
-            <a:off x="457200" y="4937760"/>
-            <a:ext cx="11247120" cy="1554480"/>
+            <a:off x="6492240" y="1280160"/>
+            <a:ext cx="5029200" cy="4937760"/>
           </a:xfrm>
           <a:prstGeom prst="rect">
             <a:avLst/>
@@ -12169,6 +11985,23 @@
           <a:p>
             <a:pPr algn="l">
               <a:spcAft>
+                <a:spcPts val="600"/>
+              </a:spcAft>
+            </a:pPr>
+            <a:r>
+              <a:rPr sz="2000" b="1" i="0">
+                <a:solidFill>
+                  <a:srgbClr val="1F2937"/>
+                </a:solidFill>
+                <a:latin typeface="Calibri"/>
+                <a:ea typeface="맑은 고딕"/>
+              </a:rPr>
+              <a:t>Baselines</a:t>
+            </a:r>
+          </a:p>
+          <a:p>
+            <a:pPr algn="l">
+              <a:spcAft>
                 <a:spcPts val="400"/>
               </a:spcAft>
             </a:pPr>
@@ -12190,17 +12023,17 @@
                 <a:latin typeface="Calibri"/>
                 <a:ea typeface="맑은 고딕"/>
               </a:rPr>
-              <a:t>Bidaw — 응답 latency </a:t>
-            </a:r>
-            <a:r>
-              <a:rPr sz="1800" b="0" i="0">
-                <a:solidFill>
-                  <a:srgbClr val="1F2937"/>
-                </a:solidFill>
-                <a:latin typeface="Calibri"/>
-                <a:ea typeface="맑은 고딕"/>
-              </a:rPr>
-              <a:t>최대 3.58배 감소 (vs CachedAttention/FlashGen)</a:t>
+              <a:t>vLLM</a:t>
+            </a:r>
+            <a:r>
+              <a:rPr sz="1400" b="0" i="0">
+                <a:solidFill>
+                  <a:srgbClr val="6B7280"/>
+                </a:solidFill>
+                <a:latin typeface="Calibri"/>
+                <a:ea typeface="맑은 고딕"/>
+              </a:rPr>
+              <a:t>  Recompute (KV caching 없음)</a:t>
             </a:r>
           </a:p>
           <a:p>
@@ -12227,17 +12060,17 @@
                 <a:latin typeface="Calibri"/>
                 <a:ea typeface="맑은 고딕"/>
               </a:rPr>
-              <a:t>Bidaw — throughput </a:t>
-            </a:r>
-            <a:r>
-              <a:rPr sz="1800" b="0" i="0">
-                <a:solidFill>
-                  <a:srgbClr val="1F2937"/>
-                </a:solidFill>
-                <a:latin typeface="Calibri"/>
-                <a:ea typeface="맑은 고딕"/>
-              </a:rPr>
-              <a:t>1.43~1.83배 향상 (동일 latency 기준)</a:t>
+              <a:t>CachedAttention</a:t>
+            </a:r>
+            <a:r>
+              <a:rPr sz="1400" b="0" i="0">
+                <a:solidFill>
+                  <a:srgbClr val="6B7280"/>
+                </a:solidFill>
+                <a:latin typeface="Calibri"/>
+                <a:ea typeface="맑은 고딕"/>
+              </a:rPr>
+              <a:t>  Queue-enhanced LRU + 2-tier</a:t>
             </a:r>
           </a:p>
           <a:p>
@@ -12264,17 +12097,17 @@
                 <a:latin typeface="Calibri"/>
                 <a:ea typeface="맑은 고딕"/>
               </a:rPr>
-              <a:t>Optimal과의 격차 </a:t>
-            </a:r>
-            <a:r>
-              <a:rPr sz="1800" b="0" i="0">
-                <a:solidFill>
-                  <a:srgbClr val="1F2937"/>
-                </a:solidFill>
-                <a:latin typeface="Calibri"/>
-                <a:ea typeface="맑은 고딕"/>
-              </a:rPr>
-              <a:t>거의 없음 — perf-layer-only 수준에 근접</a:t>
+              <a:t>FlashGen</a:t>
+            </a:r>
+            <a:r>
+              <a:rPr sz="1400" b="0" i="0">
+                <a:solidFill>
+                  <a:srgbClr val="6B7280"/>
+                </a:solidFill>
+                <a:latin typeface="Calibri"/>
+                <a:ea typeface="맑은 고딕"/>
+              </a:rPr>
+              <a:t>  Inclusive caching + GPU-fit scheduling</a:t>
             </a:r>
           </a:p>
           <a:p>
@@ -12301,24 +12134,61 @@
                 <a:latin typeface="Calibri"/>
                 <a:ea typeface="맑은 고딕"/>
               </a:rPr>
-              <a:t>Note </a:t>
-            </a:r>
-            <a:r>
-              <a:rPr sz="1800" b="0" i="0">
-                <a:solidFill>
-                  <a:srgbClr val="1F2937"/>
-                </a:solidFill>
-                <a:latin typeface="Calibri"/>
-                <a:ea typeface="맑은 고딕"/>
-              </a:rPr>
-              <a:t>Bidaw는 lossless — 답변 정확도는 FlashGen 등과 같음</a:t>
-            </a:r>
-          </a:p>
-        </p:txBody>
-      </p:sp>
-      <p:sp>
-        <p:nvSpPr>
-          <p:cNvPr id="6" name="TextBox 5"/>
+              <a:t>Optimal</a:t>
+            </a:r>
+            <a:r>
+              <a:rPr sz="1400" b="0" i="0">
+                <a:solidFill>
+                  <a:srgbClr val="6B7280"/>
+                </a:solidFill>
+                <a:latin typeface="Calibri"/>
+                <a:ea typeface="맑은 고딕"/>
+              </a:rPr>
+              <a:t>  모든 KV가 perf layer에 있는 상한선</a:t>
+            </a:r>
+          </a:p>
+          <a:p>
+            <a:pPr algn="l">
+              <a:spcAft>
+                <a:spcPts val="400"/>
+              </a:spcAft>
+            </a:pPr>
+            <a:r>
+              <a:rPr sz="1800" b="1" i="0">
+                <a:solidFill>
+                  <a:srgbClr val="D9352A"/>
+                </a:solidFill>
+                <a:latin typeface="Calibri"/>
+                <a:ea typeface="맑은 고딕"/>
+              </a:rPr>
+              <a:t>▸ </a:t>
+            </a:r>
+            <a:r>
+              <a:rPr sz="1800" b="1" i="0">
+                <a:solidFill>
+                  <a:srgbClr val="1F2937"/>
+                </a:solidFill>
+                <a:latin typeface="Calibri"/>
+                <a:ea typeface="맑은 고딕"/>
+              </a:rPr>
+              <a:t>Bidaw</a:t>
+            </a:r>
+            <a:r>
+              <a:rPr sz="1400" b="0" i="0">
+                <a:solidFill>
+                  <a:srgbClr val="6B7280"/>
+                </a:solidFill>
+                <a:latin typeface="Calibri"/>
+                <a:ea typeface="맑은 고딕"/>
+              </a:rPr>
+              <a:t>  이 논문</a:t>
+            </a:r>
+          </a:p>
+        </p:txBody>
+      </p:sp>
+      <p:sp>
+        <p:nvSpPr>
+          <p:cNvPr id="7" name="TextBox 6"/>
           <p:cNvSpPr txBox="1"/>
           <p:nvPr/>
         </p:nvSpPr>
@@ -12426,14 +12296,14 @@
                 <a:latin typeface="Calibri"/>
                 <a:ea typeface="맑은 고딕"/>
               </a:rPr>
-              <a:t>Memory sensitivity &amp; Eviction miss rate</a:t>
+              <a:t>Overall performance — 모델 5종 동시 평가</a:t>
             </a:r>
           </a:p>
         </p:txBody>
       </p:sp>
       <p:pic>
         <p:nvPicPr>
-          <p:cNvPr id="3" name="Picture 2" descr="figure_16.png"/>
+          <p:cNvPr id="3" name="Picture 2" descr="figure_15.png"/>
           <p:cNvPicPr>
             <a:picLocks noChangeAspect="1"/>
           </p:cNvPicPr>
@@ -12448,7 +12318,7 @@
         <p:spPr>
           <a:xfrm>
             <a:off x="274320" y="1188720"/>
-            <a:ext cx="6400800" cy="1115941"/>
+            <a:ext cx="11612880" cy="2024636"/>
           </a:xfrm>
           <a:prstGeom prst="rect">
             <a:avLst/>
@@ -12463,8 +12333,8 @@
         </p:nvSpPr>
         <p:spPr>
           <a:xfrm>
-            <a:off x="274320" y="2350381"/>
-            <a:ext cx="6400800" cy="320040"/>
+            <a:off x="274320" y="3259076"/>
+            <a:ext cx="11612880" cy="320040"/>
           </a:xfrm>
           <a:prstGeom prst="rect">
             <a:avLst/>
@@ -12490,45 +12360,21 @@
                 <a:latin typeface="Calibri"/>
                 <a:ea typeface="맑은 고딕"/>
               </a:rPr>
-              <a:t>Figure 16. host memory 120~200GB 범위에서의 latency</a:t>
-            </a:r>
-          </a:p>
-        </p:txBody>
-      </p:sp>
-      <p:pic>
-        <p:nvPicPr>
-          <p:cNvPr id="5" name="Picture 4" descr="figure_18.png"/>
-          <p:cNvPicPr>
-            <a:picLocks noChangeAspect="1"/>
-          </p:cNvPicPr>
-          <p:nvPr/>
-        </p:nvPicPr>
-        <p:blipFill>
-          <a:blip r:embed="rId3"/>
-          <a:stretch>
-            <a:fillRect/>
-          </a:stretch>
-        </p:blipFill>
-        <p:spPr>
-          <a:xfrm>
-            <a:off x="6949440" y="1188720"/>
-            <a:ext cx="5029200" cy="2335189"/>
-          </a:xfrm>
-          <a:prstGeom prst="rect">
-            <a:avLst/>
-          </a:prstGeom>
-        </p:spPr>
-      </p:pic>
-      <p:sp>
-        <p:nvSpPr>
-          <p:cNvPr id="6" name="TextBox 5"/>
+              <a:t>Figure 15. 사용자 도착률 vs 평균 응답 latency, 모델 5종</a:t>
+            </a:r>
+          </a:p>
+        </p:txBody>
+      </p:sp>
+      <p:sp>
+        <p:nvSpPr>
+          <p:cNvPr id="5" name="TextBox 4"/>
           <p:cNvSpPr txBox="1"/>
           <p:nvPr/>
         </p:nvSpPr>
         <p:spPr>
           <a:xfrm>
-            <a:off x="6949440" y="3569629"/>
-            <a:ext cx="5029200" cy="320040"/>
+            <a:off x="457200" y="4937760"/>
+            <a:ext cx="11247120" cy="1554480"/>
           </a:xfrm>
           <a:prstGeom prst="rect">
             <a:avLst/>
@@ -12541,46 +12387,6 @@
           </a:bodyPr>
           <a:lstStyle/>
           <a:p>
-            <a:pPr algn="ctr">
-              <a:spcAft>
-                <a:spcPts val="400"/>
-              </a:spcAft>
-            </a:pPr>
-            <a:r>
-              <a:rPr sz="1000" b="0" i="1">
-                <a:solidFill>
-                  <a:srgbClr val="6B7280"/>
-                </a:solidFill>
-                <a:latin typeface="Calibri"/>
-                <a:ea typeface="맑은 고딕"/>
-              </a:rPr>
-              <a:t>Figure 18. (a) memory size · (b) workload pressure</a:t>
-            </a:r>
-          </a:p>
-        </p:txBody>
-      </p:sp>
-      <p:sp>
-        <p:nvSpPr>
-          <p:cNvPr id="7" name="TextBox 6"/>
-          <p:cNvSpPr txBox="1"/>
-          <p:nvPr/>
-        </p:nvSpPr>
-        <p:spPr>
-          <a:xfrm>
-            <a:off x="457200" y="4023360"/>
-            <a:ext cx="11247120" cy="2468880"/>
-          </a:xfrm>
-          <a:prstGeom prst="rect">
-            <a:avLst/>
-          </a:prstGeom>
-          <a:noFill/>
-        </p:spPr>
-        <p:txBody>
-          <a:bodyPr wrap="square" lIns="45720" rIns="45720" tIns="18288" bIns="18288">
-            <a:spAutoFit/>
-          </a:bodyPr>
-          <a:lstStyle/>
-          <a:p>
             <a:pPr algn="l">
               <a:spcAft>
                 <a:spcPts val="400"/>
@@ -12589,23 +12395,43 @@
             <a:r>
               <a:rPr sz="1800" b="1" i="0">
                 <a:solidFill>
-                  <a:srgbClr val="1F2937"/>
-                </a:solidFill>
-                <a:latin typeface="Calibri"/>
-                <a:ea typeface="맑은 고딕"/>
-              </a:rPr>
-              <a:t>Memory sensitivity (Fig. 16)</a:t>
-            </a:r>
-          </a:p>
-          <a:p>
-            <a:pPr algn="l">
-              <a:spcAft>
-                <a:spcPts val="200"/>
-              </a:spcAft>
-            </a:pPr>
+                  <a:srgbClr val="D9352A"/>
+                </a:solidFill>
+                <a:latin typeface="Calibri"/>
+                <a:ea typeface="맑은 고딕"/>
+              </a:rPr>
+              <a:t>▸ </a:t>
+            </a:r>
             <a:r>
               <a:rPr sz="1800" b="1" i="0">
                 <a:solidFill>
+                  <a:srgbClr val="1F2937"/>
+                </a:solidFill>
+                <a:latin typeface="Calibri"/>
+                <a:ea typeface="맑은 고딕"/>
+              </a:rPr>
+              <a:t>Bidaw — 응답 latency </a:t>
+            </a:r>
+            <a:r>
+              <a:rPr sz="1800" b="0" i="0">
+                <a:solidFill>
+                  <a:srgbClr val="1F2937"/>
+                </a:solidFill>
+                <a:latin typeface="Calibri"/>
+                <a:ea typeface="맑은 고딕"/>
+              </a:rPr>
+              <a:t>최대 3.58배 감소 (vs CachedAttention/FlashGen)</a:t>
+            </a:r>
+          </a:p>
+          <a:p>
+            <a:pPr algn="l">
+              <a:spcAft>
+                <a:spcPts val="400"/>
+              </a:spcAft>
+            </a:pPr>
+            <a:r>
+              <a:rPr sz="1800" b="1" i="0">
+                <a:solidFill>
                   <a:srgbClr val="D9352A"/>
                 </a:solidFill>
                 <a:latin typeface="Calibri"/>
@@ -12614,6 +12440,16 @@
               <a:t>▸ </a:t>
             </a:r>
             <a:r>
+              <a:rPr sz="1800" b="1" i="0">
+                <a:solidFill>
+                  <a:srgbClr val="1F2937"/>
+                </a:solidFill>
+                <a:latin typeface="Calibri"/>
+                <a:ea typeface="맑은 고딕"/>
+              </a:rPr>
+              <a:t>Bidaw — throughput </a:t>
+            </a:r>
+            <a:r>
               <a:rPr sz="1800" b="0" i="0">
                 <a:solidFill>
                   <a:srgbClr val="1F2937"/>
@@ -12621,13 +12457,13 @@
                 <a:latin typeface="Calibri"/>
                 <a:ea typeface="맑은 고딕"/>
               </a:rPr>
-              <a:t>host memory를 120GB까지 줄여도 Bidaw는 baseline 200GB 수준의 latency</a:t>
-            </a:r>
-          </a:p>
-          <a:p>
-            <a:pPr algn="l">
-              <a:spcAft>
-                <a:spcPts val="200"/>
+              <a:t>1.43~1.83배 향상 (동일 latency 기준)</a:t>
+            </a:r>
+          </a:p>
+          <a:p>
+            <a:pPr algn="l">
+              <a:spcAft>
+                <a:spcPts val="400"/>
               </a:spcAft>
             </a:pPr>
             <a:r>
@@ -12641,6 +12477,16 @@
               <a:t>▸ </a:t>
             </a:r>
             <a:r>
+              <a:rPr sz="1800" b="1" i="0">
+                <a:solidFill>
+                  <a:srgbClr val="1F2937"/>
+                </a:solidFill>
+                <a:latin typeface="Calibri"/>
+                <a:ea typeface="맑은 고딕"/>
+              </a:rPr>
+              <a:t>Optimal과의 격차 </a:t>
+            </a:r>
+            <a:r>
               <a:rPr sz="1800" b="0" i="0">
                 <a:solidFill>
                   <a:srgbClr val="1F2937"/>
@@ -12648,7 +12494,7 @@
                 <a:latin typeface="Calibri"/>
                 <a:ea typeface="맑은 고딕"/>
               </a:rPr>
-              <a:t>동일 메모리에서 1.75~2.19배 더 많은 사용자/분 처리 — 메모리가 작을수록 격차가 더 벌어짐</a:t>
+              <a:t>거의 없음 — perf-layer-only 수준에 근접</a:t>
             </a:r>
           </a:p>
           <a:p>
@@ -12660,29 +12506,22 @@
             <a:r>
               <a:rPr sz="1800" b="1" i="0">
                 <a:solidFill>
-                  <a:srgbClr val="1F2937"/>
-                </a:solidFill>
-                <a:latin typeface="Calibri"/>
-                <a:ea typeface="맑은 고딕"/>
-              </a:rPr>
-              <a:t>Eviction miss rate (Fig. 18)</a:t>
-            </a:r>
-          </a:p>
-          <a:p>
-            <a:pPr algn="l">
-              <a:spcAft>
-                <a:spcPts val="200"/>
-              </a:spcAft>
-            </a:pPr>
+                  <a:srgbClr val="D9352A"/>
+                </a:solidFill>
+                <a:latin typeface="Calibri"/>
+                <a:ea typeface="맑은 고딕"/>
+              </a:rPr>
+              <a:t>▸ </a:t>
+            </a:r>
             <a:r>
               <a:rPr sz="1800" b="1" i="0">
                 <a:solidFill>
-                  <a:srgbClr val="D9352A"/>
-                </a:solidFill>
-                <a:latin typeface="Calibri"/>
-                <a:ea typeface="맑은 고딕"/>
-              </a:rPr>
-              <a:t>▸ </a:t>
+                  <a:srgbClr val="1F2937"/>
+                </a:solidFill>
+                <a:latin typeface="Calibri"/>
+                <a:ea typeface="맑은 고딕"/>
+              </a:rPr>
+              <a:t>Note </a:t>
             </a:r>
             <a:r>
               <a:rPr sz="1800" b="0" i="0">
@@ -12692,61 +12531,14 @@
                 <a:latin typeface="Calibri"/>
                 <a:ea typeface="맑은 고딕"/>
               </a:rPr>
-              <a:t>queue-enhanced (CachedAttention)</a:t>
-            </a:r>
-            <a:r>
-              <a:rPr sz="1800" b="1" i="0">
-                <a:solidFill>
-                  <a:srgbClr val="1F2937"/>
-                </a:solidFill>
-                <a:latin typeface="Calibri"/>
-                <a:ea typeface="맑은 고딕"/>
-              </a:rPr>
-              <a:t>  보다 miss rate -57.6%</a:t>
-            </a:r>
-          </a:p>
-          <a:p>
-            <a:pPr algn="l">
-              <a:spcAft>
-                <a:spcPts val="200"/>
-              </a:spcAft>
-            </a:pPr>
-            <a:r>
-              <a:rPr sz="1800" b="1" i="0">
-                <a:solidFill>
-                  <a:srgbClr val="D9352A"/>
-                </a:solidFill>
-                <a:latin typeface="Calibri"/>
-                <a:ea typeface="맑은 고딕"/>
-              </a:rPr>
-              <a:t>▸ </a:t>
-            </a:r>
-            <a:r>
-              <a:rPr sz="1800" b="0" i="0">
-                <a:solidFill>
-                  <a:srgbClr val="1F2937"/>
-                </a:solidFill>
-                <a:latin typeface="Calibri"/>
-                <a:ea typeface="맑은 고딕"/>
-              </a:rPr>
-              <a:t>LFU/LRU/FIFO 같은 일반 정책</a:t>
-            </a:r>
-            <a:r>
-              <a:rPr sz="1800" b="1" i="0">
-                <a:solidFill>
-                  <a:srgbClr val="1F2937"/>
-                </a:solidFill>
-                <a:latin typeface="Calibri"/>
-                <a:ea typeface="맑은 고딕"/>
-              </a:rPr>
-              <a:t>  보다 miss rate -69.9%</a:t>
-            </a:r>
-          </a:p>
-        </p:txBody>
-      </p:sp>
-      <p:sp>
-        <p:nvSpPr>
-          <p:cNvPr id="8" name="TextBox 7"/>
+              <a:t>Bidaw는 lossless — 답변 정확도는 FlashGen 등과 같음</a:t>
+            </a:r>
+          </a:p>
+        </p:txBody>
+      </p:sp>
+      <p:sp>
+        <p:nvSpPr>
+          <p:cNvPr id="6" name="TextBox 5"/>
           <p:cNvSpPr txBox="1"/>
           <p:nvPr/>
         </p:nvSpPr>
@@ -12854,14 +12646,14 @@
                 <a:latin typeface="Calibri"/>
                 <a:ea typeface="맑은 고딕"/>
               </a:rPr>
-              <a:t>Tail latency · Ablation · Overhead</a:t>
+              <a:t>Memory sensitivity &amp; Eviction miss rate</a:t>
             </a:r>
           </a:p>
         </p:txBody>
       </p:sp>
       <p:pic>
         <p:nvPicPr>
-          <p:cNvPr id="3" name="Picture 2" descr="figure_22.png"/>
+          <p:cNvPr id="3" name="Picture 2" descr="figure_16.png"/>
           <p:cNvPicPr>
             <a:picLocks noChangeAspect="1"/>
           </p:cNvPicPr>
@@ -12875,8 +12667,8 @@
         </p:blipFill>
         <p:spPr>
           <a:xfrm>
-            <a:off x="786216" y="1188720"/>
-            <a:ext cx="4919808" cy="2743200"/>
+            <a:off x="274320" y="1188720"/>
+            <a:ext cx="6400800" cy="1115941"/>
           </a:xfrm>
           <a:prstGeom prst="rect">
             <a:avLst/>
@@ -12891,8 +12683,8 @@
         </p:nvSpPr>
         <p:spPr>
           <a:xfrm>
-            <a:off x="274320" y="3977640"/>
-            <a:ext cx="5943600" cy="320040"/>
+            <a:off x="274320" y="2350381"/>
+            <a:ext cx="6400800" cy="320040"/>
           </a:xfrm>
           <a:prstGeom prst="rect">
             <a:avLst/>
@@ -12918,14 +12710,14 @@
                 <a:latin typeface="Calibri"/>
                 <a:ea typeface="맑은 고딕"/>
               </a:rPr>
-              <a:t>Figure 22. Tail latency P90 / P95 / P99 (OPT-30B)</a:t>
+              <a:t>Figure 16. host memory 120~200GB 범위에서의 latency</a:t>
             </a:r>
           </a:p>
         </p:txBody>
       </p:sp>
       <p:pic>
         <p:nvPicPr>
-          <p:cNvPr id="5" name="Picture 4" descr="figure_21.png"/>
+          <p:cNvPr id="5" name="Picture 4" descr="figure_18.png"/>
           <p:cNvPicPr>
             <a:picLocks noChangeAspect="1"/>
           </p:cNvPicPr>
@@ -12939,8 +12731,8 @@
         </p:blipFill>
         <p:spPr>
           <a:xfrm>
-            <a:off x="6400800" y="1188720"/>
-            <a:ext cx="2743200" cy="1223023"/>
+            <a:off x="6949440" y="1188720"/>
+            <a:ext cx="5029200" cy="2335189"/>
           </a:xfrm>
           <a:prstGeom prst="rect">
             <a:avLst/>
@@ -12955,8 +12747,8 @@
         </p:nvSpPr>
         <p:spPr>
           <a:xfrm>
-            <a:off x="6400800" y="2457463"/>
-            <a:ext cx="2743200" cy="320040"/>
+            <a:off x="6949440" y="3569629"/>
+            <a:ext cx="5029200" cy="320040"/>
           </a:xfrm>
           <a:prstGeom prst="rect">
             <a:avLst/>
@@ -12982,45 +12774,21 @@
                 <a:latin typeface="Calibri"/>
                 <a:ea typeface="맑은 고딕"/>
               </a:rPr>
-              <a:t>Figure 21. Ablation</a:t>
-            </a:r>
-          </a:p>
-        </p:txBody>
-      </p:sp>
-      <p:pic>
-        <p:nvPicPr>
-          <p:cNvPr id="7" name="Picture 6" descr="figure_20.png"/>
-          <p:cNvPicPr>
-            <a:picLocks noChangeAspect="1"/>
-          </p:cNvPicPr>
-          <p:nvPr/>
-        </p:nvPicPr>
-        <p:blipFill>
-          <a:blip r:embed="rId4"/>
-          <a:stretch>
-            <a:fillRect/>
-          </a:stretch>
-        </p:blipFill>
-        <p:spPr>
-          <a:xfrm>
-            <a:off x="9326880" y="1188720"/>
-            <a:ext cx="2651760" cy="934995"/>
-          </a:xfrm>
-          <a:prstGeom prst="rect">
-            <a:avLst/>
-          </a:prstGeom>
-        </p:spPr>
-      </p:pic>
-      <p:sp>
-        <p:nvSpPr>
-          <p:cNvPr id="8" name="TextBox 7"/>
+              <a:t>Figure 18. (a) memory size · (b) workload pressure</a:t>
+            </a:r>
+          </a:p>
+        </p:txBody>
+      </p:sp>
+      <p:sp>
+        <p:nvSpPr>
+          <p:cNvPr id="7" name="TextBox 6"/>
           <p:cNvSpPr txBox="1"/>
           <p:nvPr/>
         </p:nvSpPr>
         <p:spPr>
           <a:xfrm>
-            <a:off x="9326880" y="2169435"/>
-            <a:ext cx="2651760" cy="320040"/>
+            <a:off x="457200" y="4023360"/>
+            <a:ext cx="11247120" cy="2468880"/>
           </a:xfrm>
           <a:prstGeom prst="rect">
             <a:avLst/>
@@ -13033,54 +12801,31 @@
           </a:bodyPr>
           <a:lstStyle/>
           <a:p>
-            <a:pPr algn="ctr">
-              <a:spcAft>
-                <a:spcPts val="400"/>
-              </a:spcAft>
-            </a:pPr>
-            <a:r>
-              <a:rPr sz="1000" b="0" i="1">
-                <a:solidFill>
-                  <a:srgbClr val="6B7280"/>
-                </a:solidFill>
-                <a:latin typeface="Calibri"/>
-                <a:ea typeface="맑은 고딕"/>
-              </a:rPr>
-              <a:t>Figure 20. Overhead</a:t>
-            </a:r>
-          </a:p>
-        </p:txBody>
-      </p:sp>
-      <p:sp>
-        <p:nvSpPr>
-          <p:cNvPr id="9" name="TextBox 8"/>
-          <p:cNvSpPr txBox="1"/>
-          <p:nvPr/>
-        </p:nvSpPr>
-        <p:spPr>
-          <a:xfrm>
-            <a:off x="457200" y="4206240"/>
-            <a:ext cx="11247120" cy="2286000"/>
-          </a:xfrm>
-          <a:prstGeom prst="rect">
-            <a:avLst/>
-          </a:prstGeom>
-          <a:noFill/>
-        </p:spPr>
-        <p:txBody>
-          <a:bodyPr wrap="square" lIns="45720" rIns="45720" tIns="18288" bIns="18288">
-            <a:spAutoFit/>
-          </a:bodyPr>
-          <a:lstStyle/>
-          <a:p>
-            <a:pPr algn="l">
-              <a:spcAft>
-                <a:spcPts val="600"/>
+            <a:pPr algn="l">
+              <a:spcAft>
+                <a:spcPts val="400"/>
               </a:spcAft>
             </a:pPr>
             <a:r>
               <a:rPr sz="1800" b="1" i="0">
                 <a:solidFill>
+                  <a:srgbClr val="1F2937"/>
+                </a:solidFill>
+                <a:latin typeface="Calibri"/>
+                <a:ea typeface="맑은 고딕"/>
+              </a:rPr>
+              <a:t>Memory sensitivity (Fig. 16)</a:t>
+            </a:r>
+          </a:p>
+          <a:p>
+            <a:pPr algn="l">
+              <a:spcAft>
+                <a:spcPts val="200"/>
+              </a:spcAft>
+            </a:pPr>
+            <a:r>
+              <a:rPr sz="1800" b="1" i="0">
+                <a:solidFill>
                   <a:srgbClr val="D9352A"/>
                 </a:solidFill>
                 <a:latin typeface="Calibri"/>
@@ -13089,14 +12834,31 @@
               <a:t>▸ </a:t>
             </a:r>
             <a:r>
+              <a:rPr sz="1800" b="0" i="0">
+                <a:solidFill>
+                  <a:srgbClr val="1F2937"/>
+                </a:solidFill>
+                <a:latin typeface="Calibri"/>
+                <a:ea typeface="맑은 고딕"/>
+              </a:rPr>
+              <a:t>host memory를 120GB까지 줄여도 Bidaw는 baseline 200GB 수준의 latency</a:t>
+            </a:r>
+          </a:p>
+          <a:p>
+            <a:pPr algn="l">
+              <a:spcAft>
+                <a:spcPts val="200"/>
+              </a:spcAft>
+            </a:pPr>
+            <a:r>
               <a:rPr sz="1800" b="1" i="0">
                 <a:solidFill>
-                  <a:srgbClr val="1F2937"/>
-                </a:solidFill>
-                <a:latin typeface="Calibri"/>
-                <a:ea typeface="맑은 고딕"/>
-              </a:rPr>
-              <a:t>Tail latency</a:t>
+                  <a:srgbClr val="D9352A"/>
+                </a:solidFill>
+                <a:latin typeface="Calibri"/>
+                <a:ea typeface="맑은 고딕"/>
+              </a:rPr>
+              <a:t>▸ </a:t>
             </a:r>
             <a:r>
               <a:rPr sz="1800" b="0" i="0">
@@ -13106,18 +12868,35 @@
                 <a:latin typeface="Calibri"/>
                 <a:ea typeface="맑은 고딕"/>
               </a:rPr>
-              <a:t>    CachedAttention 대비 P90 −52.96% / P95 −49.30% / P99 −47.03%</a:t>
-            </a:r>
-          </a:p>
-          <a:p>
-            <a:pPr algn="l">
-              <a:spcAft>
-                <a:spcPts val="600"/>
+              <a:t>동일 메모리에서 1.75~2.19배 더 많은 사용자/분 처리 — 메모리가 작을수록 격차가 더 벌어짐</a:t>
+            </a:r>
+          </a:p>
+          <a:p>
+            <a:pPr algn="l">
+              <a:spcAft>
+                <a:spcPts val="400"/>
               </a:spcAft>
             </a:pPr>
             <a:r>
               <a:rPr sz="1800" b="1" i="0">
                 <a:solidFill>
+                  <a:srgbClr val="1F2937"/>
+                </a:solidFill>
+                <a:latin typeface="Calibri"/>
+                <a:ea typeface="맑은 고딕"/>
+              </a:rPr>
+              <a:t>Eviction miss rate (Fig. 18)</a:t>
+            </a:r>
+          </a:p>
+          <a:p>
+            <a:pPr algn="l">
+              <a:spcAft>
+                <a:spcPts val="200"/>
+              </a:spcAft>
+            </a:pPr>
+            <a:r>
+              <a:rPr sz="1800" b="1" i="0">
+                <a:solidFill>
                   <a:srgbClr val="D9352A"/>
                 </a:solidFill>
                 <a:latin typeface="Calibri"/>
@@ -13126,6 +12905,16 @@
               <a:t>▸ </a:t>
             </a:r>
             <a:r>
+              <a:rPr sz="1800" b="0" i="0">
+                <a:solidFill>
+                  <a:srgbClr val="1F2937"/>
+                </a:solidFill>
+                <a:latin typeface="Calibri"/>
+                <a:ea typeface="맑은 고딕"/>
+              </a:rPr>
+              <a:t>queue-enhanced (CachedAttention)</a:t>
+            </a:r>
+            <a:r>
               <a:rPr sz="1800" b="1" i="0">
                 <a:solidFill>
                   <a:srgbClr val="1F2937"/>
@@ -13133,7 +12922,24 @@
                 <a:latin typeface="Calibri"/>
                 <a:ea typeface="맑은 고딕"/>
               </a:rPr>
-              <a:t>Ablation</a:t>
+              <a:t>  보다 miss rate -57.6%</a:t>
+            </a:r>
+          </a:p>
+          <a:p>
+            <a:pPr algn="l">
+              <a:spcAft>
+                <a:spcPts val="200"/>
+              </a:spcAft>
+            </a:pPr>
+            <a:r>
+              <a:rPr sz="1800" b="1" i="0">
+                <a:solidFill>
+                  <a:srgbClr val="D9352A"/>
+                </a:solidFill>
+                <a:latin typeface="Calibri"/>
+                <a:ea typeface="맑은 고딕"/>
+              </a:rPr>
+              <a:t>▸ </a:t>
             </a:r>
             <a:r>
               <a:rPr sz="1800" b="0" i="0">
@@ -13143,51 +12949,24 @@
                 <a:latin typeface="Calibri"/>
                 <a:ea typeface="맑은 고딕"/>
               </a:rPr>
-              <a:t>    Scheduling +1.58배, Eviction +1.25배, Tensor caching +1.10배</a:t>
-            </a:r>
-          </a:p>
-          <a:p>
-            <a:pPr algn="l">
-              <a:spcAft>
-                <a:spcPts val="600"/>
-              </a:spcAft>
-            </a:pPr>
+              <a:t>LFU/LRU/FIFO 같은 일반 정책</a:t>
+            </a:r>
             <a:r>
               <a:rPr sz="1800" b="1" i="0">
                 <a:solidFill>
-                  <a:srgbClr val="D9352A"/>
-                </a:solidFill>
-                <a:latin typeface="Calibri"/>
-                <a:ea typeface="맑은 고딕"/>
-              </a:rPr>
-              <a:t>▸ </a:t>
-            </a:r>
-            <a:r>
-              <a:rPr sz="1800" b="1" i="0">
-                <a:solidFill>
-                  <a:srgbClr val="1F2937"/>
-                </a:solidFill>
-                <a:latin typeface="Calibri"/>
-                <a:ea typeface="맑은 고딕"/>
-              </a:rPr>
-              <a:t>Overhead</a:t>
-            </a:r>
-            <a:r>
-              <a:rPr sz="1800" b="0" i="0">
-                <a:solidFill>
-                  <a:srgbClr val="1F2937"/>
-                </a:solidFill>
-                <a:latin typeface="Calibri"/>
-                <a:ea typeface="맑은 고딕"/>
-              </a:rPr>
-              <a:t>    Scheduling 0.62 ms, Eviction 0.35 ms, KV transform &lt;0.1 s</a:t>
-            </a:r>
-          </a:p>
-        </p:txBody>
-      </p:sp>
-      <p:sp>
-        <p:nvSpPr>
-          <p:cNvPr id="10" name="TextBox 9"/>
+                  <a:srgbClr val="1F2937"/>
+                </a:solidFill>
+                <a:latin typeface="Calibri"/>
+                <a:ea typeface="맑은 고딕"/>
+              </a:rPr>
+              <a:t>  보다 miss rate -69.9%</a:t>
+            </a:r>
+          </a:p>
+        </p:txBody>
+      </p:sp>
+      <p:sp>
+        <p:nvSpPr>
+          <p:cNvPr id="8" name="TextBox 7"/>
           <p:cNvSpPr txBox="1"/>
           <p:nvPr/>
         </p:nvSpPr>
@@ -13649,6 +13428,447 @@
                 <a:latin typeface="Calibri"/>
                 <a:ea typeface="맑은 고딕"/>
               </a:rPr>
+              <a:t>EVALUATION</a:t>
+            </a:r>
+          </a:p>
+          <a:p>
+            <a:pPr algn="l">
+              <a:spcAft>
+                <a:spcPts val="400"/>
+              </a:spcAft>
+            </a:pPr>
+            <a:r>
+              <a:rPr sz="2800" b="1" i="0">
+                <a:solidFill>
+                  <a:srgbClr val="1F2937"/>
+                </a:solidFill>
+                <a:latin typeface="Calibri"/>
+                <a:ea typeface="맑은 고딕"/>
+              </a:rPr>
+              <a:t>Tail latency · Ablation · Overhead</a:t>
+            </a:r>
+          </a:p>
+        </p:txBody>
+      </p:sp>
+      <p:pic>
+        <p:nvPicPr>
+          <p:cNvPr id="3" name="Picture 2" descr="figure_22.png"/>
+          <p:cNvPicPr>
+            <a:picLocks noChangeAspect="1"/>
+          </p:cNvPicPr>
+          <p:nvPr/>
+        </p:nvPicPr>
+        <p:blipFill>
+          <a:blip r:embed="rId2"/>
+          <a:stretch>
+            <a:fillRect/>
+          </a:stretch>
+        </p:blipFill>
+        <p:spPr>
+          <a:xfrm>
+            <a:off x="786216" y="1188720"/>
+            <a:ext cx="4919808" cy="2743200"/>
+          </a:xfrm>
+          <a:prstGeom prst="rect">
+            <a:avLst/>
+          </a:prstGeom>
+        </p:spPr>
+      </p:pic>
+      <p:sp>
+        <p:nvSpPr>
+          <p:cNvPr id="4" name="TextBox 3"/>
+          <p:cNvSpPr txBox="1"/>
+          <p:nvPr/>
+        </p:nvSpPr>
+        <p:spPr>
+          <a:xfrm>
+            <a:off x="274320" y="3977640"/>
+            <a:ext cx="5943600" cy="320040"/>
+          </a:xfrm>
+          <a:prstGeom prst="rect">
+            <a:avLst/>
+          </a:prstGeom>
+          <a:noFill/>
+        </p:spPr>
+        <p:txBody>
+          <a:bodyPr wrap="square" lIns="45720" rIns="45720" tIns="18288" bIns="18288">
+            <a:spAutoFit/>
+          </a:bodyPr>
+          <a:lstStyle/>
+          <a:p>
+            <a:pPr algn="ctr">
+              <a:spcAft>
+                <a:spcPts val="400"/>
+              </a:spcAft>
+            </a:pPr>
+            <a:r>
+              <a:rPr sz="1000" b="0" i="1">
+                <a:solidFill>
+                  <a:srgbClr val="6B7280"/>
+                </a:solidFill>
+                <a:latin typeface="Calibri"/>
+                <a:ea typeface="맑은 고딕"/>
+              </a:rPr>
+              <a:t>Figure 22. Tail latency P90 / P95 / P99 (OPT-30B)</a:t>
+            </a:r>
+          </a:p>
+        </p:txBody>
+      </p:sp>
+      <p:pic>
+        <p:nvPicPr>
+          <p:cNvPr id="5" name="Picture 4" descr="figure_21.png"/>
+          <p:cNvPicPr>
+            <a:picLocks noChangeAspect="1"/>
+          </p:cNvPicPr>
+          <p:nvPr/>
+        </p:nvPicPr>
+        <p:blipFill>
+          <a:blip r:embed="rId3"/>
+          <a:stretch>
+            <a:fillRect/>
+          </a:stretch>
+        </p:blipFill>
+        <p:spPr>
+          <a:xfrm>
+            <a:off x="6400800" y="1188720"/>
+            <a:ext cx="2743200" cy="1223023"/>
+          </a:xfrm>
+          <a:prstGeom prst="rect">
+            <a:avLst/>
+          </a:prstGeom>
+        </p:spPr>
+      </p:pic>
+      <p:sp>
+        <p:nvSpPr>
+          <p:cNvPr id="6" name="TextBox 5"/>
+          <p:cNvSpPr txBox="1"/>
+          <p:nvPr/>
+        </p:nvSpPr>
+        <p:spPr>
+          <a:xfrm>
+            <a:off x="6400800" y="2457463"/>
+            <a:ext cx="2743200" cy="320040"/>
+          </a:xfrm>
+          <a:prstGeom prst="rect">
+            <a:avLst/>
+          </a:prstGeom>
+          <a:noFill/>
+        </p:spPr>
+        <p:txBody>
+          <a:bodyPr wrap="square" lIns="45720" rIns="45720" tIns="18288" bIns="18288">
+            <a:spAutoFit/>
+          </a:bodyPr>
+          <a:lstStyle/>
+          <a:p>
+            <a:pPr algn="ctr">
+              <a:spcAft>
+                <a:spcPts val="400"/>
+              </a:spcAft>
+            </a:pPr>
+            <a:r>
+              <a:rPr sz="1000" b="0" i="1">
+                <a:solidFill>
+                  <a:srgbClr val="6B7280"/>
+                </a:solidFill>
+                <a:latin typeface="Calibri"/>
+                <a:ea typeface="맑은 고딕"/>
+              </a:rPr>
+              <a:t>Figure 21. Ablation</a:t>
+            </a:r>
+          </a:p>
+        </p:txBody>
+      </p:sp>
+      <p:pic>
+        <p:nvPicPr>
+          <p:cNvPr id="7" name="Picture 6" descr="figure_20.png"/>
+          <p:cNvPicPr>
+            <a:picLocks noChangeAspect="1"/>
+          </p:cNvPicPr>
+          <p:nvPr/>
+        </p:nvPicPr>
+        <p:blipFill>
+          <a:blip r:embed="rId4"/>
+          <a:stretch>
+            <a:fillRect/>
+          </a:stretch>
+        </p:blipFill>
+        <p:spPr>
+          <a:xfrm>
+            <a:off x="9326880" y="1188720"/>
+            <a:ext cx="2651760" cy="934995"/>
+          </a:xfrm>
+          <a:prstGeom prst="rect">
+            <a:avLst/>
+          </a:prstGeom>
+        </p:spPr>
+      </p:pic>
+      <p:sp>
+        <p:nvSpPr>
+          <p:cNvPr id="8" name="TextBox 7"/>
+          <p:cNvSpPr txBox="1"/>
+          <p:nvPr/>
+        </p:nvSpPr>
+        <p:spPr>
+          <a:xfrm>
+            <a:off x="9326880" y="2169435"/>
+            <a:ext cx="2651760" cy="320040"/>
+          </a:xfrm>
+          <a:prstGeom prst="rect">
+            <a:avLst/>
+          </a:prstGeom>
+          <a:noFill/>
+        </p:spPr>
+        <p:txBody>
+          <a:bodyPr wrap="square" lIns="45720" rIns="45720" tIns="18288" bIns="18288">
+            <a:spAutoFit/>
+          </a:bodyPr>
+          <a:lstStyle/>
+          <a:p>
+            <a:pPr algn="ctr">
+              <a:spcAft>
+                <a:spcPts val="400"/>
+              </a:spcAft>
+            </a:pPr>
+            <a:r>
+              <a:rPr sz="1000" b="0" i="1">
+                <a:solidFill>
+                  <a:srgbClr val="6B7280"/>
+                </a:solidFill>
+                <a:latin typeface="Calibri"/>
+                <a:ea typeface="맑은 고딕"/>
+              </a:rPr>
+              <a:t>Figure 20. Overhead</a:t>
+            </a:r>
+          </a:p>
+        </p:txBody>
+      </p:sp>
+      <p:sp>
+        <p:nvSpPr>
+          <p:cNvPr id="9" name="TextBox 8"/>
+          <p:cNvSpPr txBox="1"/>
+          <p:nvPr/>
+        </p:nvSpPr>
+        <p:spPr>
+          <a:xfrm>
+            <a:off x="457200" y="4206240"/>
+            <a:ext cx="11247120" cy="2286000"/>
+          </a:xfrm>
+          <a:prstGeom prst="rect">
+            <a:avLst/>
+          </a:prstGeom>
+          <a:noFill/>
+        </p:spPr>
+        <p:txBody>
+          <a:bodyPr wrap="square" lIns="45720" rIns="45720" tIns="18288" bIns="18288">
+            <a:spAutoFit/>
+          </a:bodyPr>
+          <a:lstStyle/>
+          <a:p>
+            <a:pPr algn="l">
+              <a:spcAft>
+                <a:spcPts val="600"/>
+              </a:spcAft>
+            </a:pPr>
+            <a:r>
+              <a:rPr sz="1800" b="1" i="0">
+                <a:solidFill>
+                  <a:srgbClr val="D9352A"/>
+                </a:solidFill>
+                <a:latin typeface="Calibri"/>
+                <a:ea typeface="맑은 고딕"/>
+              </a:rPr>
+              <a:t>▸ </a:t>
+            </a:r>
+            <a:r>
+              <a:rPr sz="1800" b="1" i="0">
+                <a:solidFill>
+                  <a:srgbClr val="1F2937"/>
+                </a:solidFill>
+                <a:latin typeface="Calibri"/>
+                <a:ea typeface="맑은 고딕"/>
+              </a:rPr>
+              <a:t>Tail latency</a:t>
+            </a:r>
+            <a:r>
+              <a:rPr sz="1800" b="0" i="0">
+                <a:solidFill>
+                  <a:srgbClr val="1F2937"/>
+                </a:solidFill>
+                <a:latin typeface="Calibri"/>
+                <a:ea typeface="맑은 고딕"/>
+              </a:rPr>
+              <a:t>    CachedAttention 대비 P90 −52.96% / P95 −49.30% / P99 −47.03%</a:t>
+            </a:r>
+          </a:p>
+          <a:p>
+            <a:pPr algn="l">
+              <a:spcAft>
+                <a:spcPts val="600"/>
+              </a:spcAft>
+            </a:pPr>
+            <a:r>
+              <a:rPr sz="1800" b="1" i="0">
+                <a:solidFill>
+                  <a:srgbClr val="D9352A"/>
+                </a:solidFill>
+                <a:latin typeface="Calibri"/>
+                <a:ea typeface="맑은 고딕"/>
+              </a:rPr>
+              <a:t>▸ </a:t>
+            </a:r>
+            <a:r>
+              <a:rPr sz="1800" b="1" i="0">
+                <a:solidFill>
+                  <a:srgbClr val="1F2937"/>
+                </a:solidFill>
+                <a:latin typeface="Calibri"/>
+                <a:ea typeface="맑은 고딕"/>
+              </a:rPr>
+              <a:t>Ablation</a:t>
+            </a:r>
+            <a:r>
+              <a:rPr sz="1800" b="0" i="0">
+                <a:solidFill>
+                  <a:srgbClr val="1F2937"/>
+                </a:solidFill>
+                <a:latin typeface="Calibri"/>
+                <a:ea typeface="맑은 고딕"/>
+              </a:rPr>
+              <a:t>    Scheduling +1.58배, Eviction +1.25배, Tensor caching +1.10배</a:t>
+            </a:r>
+          </a:p>
+          <a:p>
+            <a:pPr algn="l">
+              <a:spcAft>
+                <a:spcPts val="600"/>
+              </a:spcAft>
+            </a:pPr>
+            <a:r>
+              <a:rPr sz="1800" b="1" i="0">
+                <a:solidFill>
+                  <a:srgbClr val="D9352A"/>
+                </a:solidFill>
+                <a:latin typeface="Calibri"/>
+                <a:ea typeface="맑은 고딕"/>
+              </a:rPr>
+              <a:t>▸ </a:t>
+            </a:r>
+            <a:r>
+              <a:rPr sz="1800" b="1" i="0">
+                <a:solidFill>
+                  <a:srgbClr val="1F2937"/>
+                </a:solidFill>
+                <a:latin typeface="Calibri"/>
+                <a:ea typeface="맑은 고딕"/>
+              </a:rPr>
+              <a:t>Overhead</a:t>
+            </a:r>
+            <a:r>
+              <a:rPr sz="1800" b="0" i="0">
+                <a:solidFill>
+                  <a:srgbClr val="1F2937"/>
+                </a:solidFill>
+                <a:latin typeface="Calibri"/>
+                <a:ea typeface="맑은 고딕"/>
+              </a:rPr>
+              <a:t>    Scheduling 0.62 ms, Eviction 0.35 ms, KV transform &lt;0.1 s</a:t>
+            </a:r>
+          </a:p>
+        </p:txBody>
+      </p:sp>
+      <p:sp>
+        <p:nvSpPr>
+          <p:cNvPr id="10" name="TextBox 9"/>
+          <p:cNvSpPr txBox="1"/>
+          <p:nvPr/>
+        </p:nvSpPr>
+        <p:spPr>
+          <a:xfrm>
+            <a:off x="11094415" y="6446520"/>
+            <a:ext cx="822960" cy="274320"/>
+          </a:xfrm>
+          <a:prstGeom prst="rect">
+            <a:avLst/>
+          </a:prstGeom>
+          <a:noFill/>
+        </p:spPr>
+        <p:txBody>
+          <a:bodyPr wrap="square" lIns="45720" rIns="45720" tIns="18288" bIns="18288">
+            <a:spAutoFit/>
+          </a:bodyPr>
+          <a:lstStyle/>
+          <a:p>
+            <a:pPr algn="r">
+              <a:spcAft>
+                <a:spcPts val="400"/>
+              </a:spcAft>
+            </a:pPr>
+            <a:r>
+              <a:rPr sz="1000" b="0" i="0">
+                <a:solidFill>
+                  <a:srgbClr val="6B7280"/>
+                </a:solidFill>
+                <a:latin typeface="Calibri"/>
+                <a:ea typeface="맑은 고딕"/>
+              </a:rPr>
+              <a:t>30</a:t>
+            </a:r>
+          </a:p>
+        </p:txBody>
+      </p:sp>
+    </p:spTree>
+  </p:cSld>
+  <p:clrMapOvr>
+    <a:masterClrMapping/>
+  </p:clrMapOvr>
+</p:sld>
+</file>
+
+<file path=ppt/slides/slide31.xml><?xml version="1.0" encoding="utf-8"?>
+<p:sld xmlns:a="http://schemas.openxmlformats.org/drawingml/2006/main" xmlns:p="http://schemas.openxmlformats.org/presentationml/2006/main" xmlns:r="http://schemas.openxmlformats.org/officeDocument/2006/relationships">
+  <p:cSld>
+    <p:spTree>
+      <p:nvGrpSpPr>
+        <p:cNvPr id="1" name=""/>
+        <p:cNvGrpSpPr/>
+        <p:nvPr/>
+      </p:nvGrpSpPr>
+      <p:grpSpPr/>
+      <p:sp>
+        <p:nvSpPr>
+          <p:cNvPr id="2" name="TextBox 1"/>
+          <p:cNvSpPr txBox="1"/>
+          <p:nvPr/>
+        </p:nvSpPr>
+        <p:spPr>
+          <a:xfrm>
+            <a:off x="548640" y="320040"/>
+            <a:ext cx="11094415" cy="914400"/>
+          </a:xfrm>
+          <a:prstGeom prst="rect">
+            <a:avLst/>
+          </a:prstGeom>
+          <a:noFill/>
+        </p:spPr>
+        <p:txBody>
+          <a:bodyPr wrap="square" lIns="45720" rIns="45720" tIns="18288" bIns="18288">
+            <a:spAutoFit/>
+          </a:bodyPr>
+          <a:lstStyle/>
+          <a:p>
+            <a:pPr algn="l">
+              <a:spcAft>
+                <a:spcPts val="200"/>
+              </a:spcAft>
+            </a:pPr>
+            <a:r>
+              <a:rPr sz="1200" b="1" i="0">
+                <a:solidFill>
+                  <a:srgbClr val="6B7280"/>
+                </a:solidFill>
+                <a:latin typeface="Calibri"/>
+                <a:ea typeface="맑은 고딕"/>
+              </a:rPr>
               <a:t>CONCLUSION</a:t>
             </a:r>
           </a:p>
@@ -14261,7 +14481,7 @@
                 <a:latin typeface="Calibri"/>
                 <a:ea typeface="맑은 고딕"/>
               </a:rPr>
-              <a:t>30</a:t>
+              <a:t>31</a:t>
             </a:r>
           </a:p>
         </p:txBody>

</xml_diff>